<commit_message>
chore(marketing): polish OCM exec deck and add Plain / Compact layout
Tighten layout, fix diagram readability issues, and split text/diagram
slides per the design rule that each slide carries either text or a
diagram, not both. Add a Plain / Compact variant of the Plain layout
so 1-line titles get a tight gap to the body while 2-line titles keep
breathing room.

Signed-off-by: Gerald Morrison (SAP) <gerald.morrison@sap.com>
</commit_message>
<xml_diff>
--- a/docs/community/marketing/decks/exec-phase1/OCM-Sovereign-Delivery-Exec.pptx
+++ b/docs/community/marketing/decks/exec-phase1/OCM-Sovereign-Delivery-Exec.pptx
@@ -15,6 +15,8 @@
     <p:sldId id="263" r:id="rId14"/>
     <p:sldId id="264" r:id="rId15"/>
     <p:sldId id="265" r:id="rId16"/>
+    <p:sldId id="266" r:id="rId17"/>
+    <p:sldId id="267" r:id="rId18"/>
   </p:sldIdLst>
   <p:sldSz cx="18288000" cy="10287000"/>
   <p:notesSz cx="6858000" cy="9144000"/>
@@ -154,7 +156,7 @@
         <ns0:spPr>
           <ns2:xfrm xmlns:ns2="http://schemas.openxmlformats.org/drawingml/2006/main">
             <ns2:off x="914400" y="1590675"/>
-            <ns2:ext cx="14287500" cy="1762125"/>
+            <ns2:ext cx="16192500" cy="1905000"/>
           </ns2:xfrm>
           <ns3:prstGeom xmlns:ns3="http://schemas.openxmlformats.org/drawingml/2006/main" prst="rect">
             <ns3:avLst/>
@@ -165,7 +167,7 @@
           <ns5:lstStyle xmlns:ns5="http://schemas.openxmlformats.org/drawingml/2006/main">
             <ns5:lvl1pPr marL="0" indent="0" algn="l">
               <ns5:buNone/>
-              <ns5:defRPr sz="7200" b="1">
+              <ns5:defRPr sz="11500" b="1">
                 <ns5:solidFill>
                   <ns5:srgbClr val="FFFFFF"/>
                 </ns5:solidFill>
@@ -194,8 +196,8 @@
         </ns0:nvSpPr>
         <ns0:spPr>
           <ns2:xfrm xmlns:ns2="http://schemas.openxmlformats.org/drawingml/2006/main">
-            <ns2:off x="914400" y="2876550"/>
-            <ns2:ext cx="14287500" cy="1762125"/>
+            <ns2:off x="914400" y="3067050"/>
+            <ns2:ext cx="16192500" cy="1905000"/>
           </ns2:xfrm>
           <ns3:prstGeom xmlns:ns3="http://schemas.openxmlformats.org/drawingml/2006/main" prst="rect">
             <ns3:avLst/>
@@ -206,7 +208,7 @@
           <ns5:lstStyle xmlns:ns5="http://schemas.openxmlformats.org/drawingml/2006/main">
             <ns5:lvl1pPr marL="0" indent="0" algn="l">
               <ns5:buNone/>
-              <ns5:defRPr sz="7200" b="1">
+              <ns5:defRPr sz="11500" b="1">
                 <ns5:solidFill>
                   <ns5:srgbClr val="5CD6FF"/>
                 </ns5:solidFill>
@@ -235,8 +237,8 @@
         </ns0:nvSpPr>
         <ns0:spPr>
           <ns2:xfrm xmlns:ns2="http://schemas.openxmlformats.org/drawingml/2006/main">
-            <ns2:off x="914400" y="5133975"/>
-            <ns2:ext cx="15087600" cy="676275"/>
+            <ns2:off x="914400" y="5257800"/>
+            <ns2:ext cx="16192500" cy="571500"/>
           </ns2:xfrm>
           <ns3:prstGeom xmlns:ns3="http://schemas.openxmlformats.org/drawingml/2006/main" prst="rect">
             <ns3:avLst/>
@@ -247,7 +249,7 @@
           <ns5:lstStyle xmlns:ns5="http://schemas.openxmlformats.org/drawingml/2006/main">
             <ns5:lvl1pPr marL="0" indent="0" algn="l">
               <ns5:buNone/>
-              <ns5:defRPr sz="2800">
+              <ns5:defRPr sz="3600">
                 <ns5:solidFill>
                   <ns5:srgbClr val="5CD6FF"/>
                 </ns5:solidFill>
@@ -276,8 +278,8 @@
         </ns0:nvSpPr>
         <ns0:spPr>
           <ns2:xfrm xmlns:ns2="http://schemas.openxmlformats.org/drawingml/2006/main">
-            <ns2:off x="914400" y="6210300"/>
-            <ns2:ext cx="14287500" cy="552450"/>
+            <ns2:off x="914400" y="6067425"/>
+            <ns2:ext cx="16192500" cy="476250"/>
           </ns2:xfrm>
           <ns3:prstGeom xmlns:ns3="http://schemas.openxmlformats.org/drawingml/2006/main" prst="rect">
             <ns3:avLst/>
@@ -288,7 +290,7 @@
           <ns5:lstStyle xmlns:ns5="http://schemas.openxmlformats.org/drawingml/2006/main">
             <ns5:lvl1pPr marL="0" indent="0" algn="l">
               <ns5:buNone/>
-              <ns5:defRPr sz="2000">
+              <ns5:defRPr sz="2800">
                 <ns5:solidFill>
                   <ns5:srgbClr val="FFFFFF"/>
                 </ns5:solidFill>
@@ -465,8 +467,8 @@
         </ns0:nvSpPr>
         <ns0:spPr>
           <ns2:xfrm xmlns:ns2="http://schemas.openxmlformats.org/drawingml/2006/main">
-            <ns2:off x="762000" y="1714500"/>
-            <ns2:ext cx="16764000" cy="266700"/>
+            <ns2:off x="1143000" y="2428875"/>
+            <ns2:ext cx="16002000" cy="457200"/>
           </ns2:xfrm>
           <ns3:prstGeom xmlns:ns3="http://schemas.openxmlformats.org/drawingml/2006/main" prst="rect">
             <ns3:avLst/>
@@ -477,7 +479,7 @@
           <ns5:lstStyle xmlns:ns5="http://schemas.openxmlformats.org/drawingml/2006/main">
             <ns5:lvl1pPr marL="0" indent="0" algn="l">
               <ns5:buNone/>
-              <ns5:defRPr sz="1400" b="1" cap="all" spc="110">
+              <ns5:defRPr sz="2800" b="1" cap="all" spc="140">
                 <ns5:solidFill>
                   <ns5:srgbClr val="0F6BFF"/>
                 </ns5:solidFill>
@@ -506,8 +508,8 @@
         </ns0:nvSpPr>
         <ns0:spPr>
           <ns2:xfrm xmlns:ns2="http://schemas.openxmlformats.org/drawingml/2006/main">
-            <ns2:off x="762000" y="2057400"/>
-            <ns2:ext cx="16764000" cy="1047750"/>
+            <ns2:off x="1143000" y="2933700"/>
+            <ns2:ext cx="16002000" cy="1905000"/>
           </ns2:xfrm>
           <ns3:prstGeom xmlns:ns3="http://schemas.openxmlformats.org/drawingml/2006/main" prst="rect">
             <ns3:avLst/>
@@ -517,6 +519,9 @@
           <ns4:bodyPr xmlns:ns4="http://schemas.openxmlformats.org/drawingml/2006/main" wrap="square" rtlCol="0" anchor="t" lIns="0" tIns="0" rIns="0" bIns="0"/>
           <ns5:lstStyle xmlns:ns5="http://schemas.openxmlformats.org/drawingml/2006/main">
             <ns5:lvl1pPr marL="0" indent="0" algn="l">
+              <ns5:lnSpc>
+                <ns5:spcPct val="90000"/>
+              </ns5:lnSpc>
               <ns5:buNone/>
               <ns5:defRPr sz="6400" b="1">
                 <ns5:solidFill>
@@ -543,8 +548,8 @@
         </ns0:nvSpPr>
         <ns0:spPr>
           <ns1:xfrm xmlns:ns1="http://schemas.openxmlformats.org/drawingml/2006/main">
-            <ns1:off x="762000" y="3810000"/>
-            <ns1:ext cx="5381625" cy="38100"/>
+            <ns1:off x="1143000" y="4953000"/>
+            <ns1:ext cx="4972050" cy="38100"/>
           </ns1:xfrm>
           <ns2:prstGeom xmlns:ns2="http://schemas.openxmlformats.org/drawingml/2006/main" prst="rect">
             <ns2:avLst/>
@@ -576,8 +581,8 @@
         </ns0:nvSpPr>
         <ns0:spPr>
           <ns2:xfrm xmlns:ns2="http://schemas.openxmlformats.org/drawingml/2006/main">
-            <ns2:off x="762000" y="4076700"/>
-            <ns2:ext cx="5381625" cy="342900"/>
+            <ns2:off x="1143000" y="5105400"/>
+            <ns2:ext cx="4972050" cy="342900"/>
           </ns2:xfrm>
           <ns3:prstGeom xmlns:ns3="http://schemas.openxmlformats.org/drawingml/2006/main" prst="rect">
             <ns3:avLst/>
@@ -588,7 +593,7 @@
           <ns5:lstStyle xmlns:ns5="http://schemas.openxmlformats.org/drawingml/2006/main">
             <ns5:lvl1pPr marL="0" indent="0" algn="l">
               <ns5:buNone/>
-              <ns5:defRPr sz="1600" b="1" cap="all" spc="130">
+              <ns5:defRPr sz="2000" b="1" cap="all" spc="130">
                 <ns5:solidFill>
                   <ns5:srgbClr val="0F6BFF"/>
                 </ns5:solidFill>
@@ -617,8 +622,8 @@
         </ns0:nvSpPr>
         <ns0:spPr>
           <ns2:xfrm xmlns:ns2="http://schemas.openxmlformats.org/drawingml/2006/main">
-            <ns2:off x="762000" y="4533900"/>
-            <ns2:ext cx="5381625" cy="4572000"/>
+            <ns2:off x="1143000" y="5524500"/>
+            <ns2:ext cx="4972050" cy="4572000"/>
           </ns2:xfrm>
           <ns3:prstGeom xmlns:ns3="http://schemas.openxmlformats.org/drawingml/2006/main" prst="rect">
             <ns3:avLst/>
@@ -629,7 +634,7 @@
           <ns5:lstStyle xmlns:ns5="http://schemas.openxmlformats.org/drawingml/2006/main">
             <ns5:lvl1pPr marL="0" indent="0" algn="l">
               <ns5:buNone/>
-              <ns5:defRPr sz="1800">
+              <ns5:defRPr sz="2200">
                 <ns5:solidFill>
                   <ns5:srgbClr val="000000"/>
                 </ns5:solidFill>
@@ -654,8 +659,8 @@
         </ns0:nvSpPr>
         <ns0:spPr>
           <ns1:xfrm xmlns:ns1="http://schemas.openxmlformats.org/drawingml/2006/main">
-            <ns1:off x="6448425" y="3810000"/>
-            <ns1:ext cx="5381625" cy="38100"/>
+            <ns1:off x="6648450" y="4953000"/>
+            <ns1:ext cx="4972050" cy="38100"/>
           </ns1:xfrm>
           <ns2:prstGeom xmlns:ns2="http://schemas.openxmlformats.org/drawingml/2006/main" prst="rect">
             <ns2:avLst/>
@@ -687,8 +692,8 @@
         </ns0:nvSpPr>
         <ns0:spPr>
           <ns2:xfrm xmlns:ns2="http://schemas.openxmlformats.org/drawingml/2006/main">
-            <ns2:off x="6448425" y="4076700"/>
-            <ns2:ext cx="5381625" cy="342900"/>
+            <ns2:off x="6648450" y="5105400"/>
+            <ns2:ext cx="4972050" cy="342900"/>
           </ns2:xfrm>
           <ns3:prstGeom xmlns:ns3="http://schemas.openxmlformats.org/drawingml/2006/main" prst="rect">
             <ns3:avLst/>
@@ -699,7 +704,7 @@
           <ns5:lstStyle xmlns:ns5="http://schemas.openxmlformats.org/drawingml/2006/main">
             <ns5:lvl1pPr marL="0" indent="0" algn="l">
               <ns5:buNone/>
-              <ns5:defRPr sz="1600" b="1" cap="all" spc="130">
+              <ns5:defRPr sz="2000" b="1" cap="all" spc="130">
                 <ns5:solidFill>
                   <ns5:srgbClr val="0F6BFF"/>
                 </ns5:solidFill>
@@ -728,8 +733,8 @@
         </ns0:nvSpPr>
         <ns0:spPr>
           <ns2:xfrm xmlns:ns2="http://schemas.openxmlformats.org/drawingml/2006/main">
-            <ns2:off x="6448425" y="4533900"/>
-            <ns2:ext cx="5381625" cy="4572000"/>
+            <ns2:off x="6648450" y="5524500"/>
+            <ns2:ext cx="4972050" cy="4572000"/>
           </ns2:xfrm>
           <ns3:prstGeom xmlns:ns3="http://schemas.openxmlformats.org/drawingml/2006/main" prst="rect">
             <ns3:avLst/>
@@ -740,7 +745,7 @@
           <ns5:lstStyle xmlns:ns5="http://schemas.openxmlformats.org/drawingml/2006/main">
             <ns5:lvl1pPr marL="0" indent="0" algn="l">
               <ns5:buNone/>
-              <ns5:defRPr sz="1800">
+              <ns5:defRPr sz="2200">
                 <ns5:solidFill>
                   <ns5:srgbClr val="000000"/>
                 </ns5:solidFill>
@@ -765,8 +770,8 @@
         </ns0:nvSpPr>
         <ns0:spPr>
           <ns1:xfrm xmlns:ns1="http://schemas.openxmlformats.org/drawingml/2006/main">
-            <ns1:off x="12134850" y="3810000"/>
-            <ns1:ext cx="5381625" cy="38100"/>
+            <ns1:off x="12153900" y="4953000"/>
+            <ns1:ext cx="4972050" cy="38100"/>
           </ns1:xfrm>
           <ns2:prstGeom xmlns:ns2="http://schemas.openxmlformats.org/drawingml/2006/main" prst="rect">
             <ns2:avLst/>
@@ -798,8 +803,8 @@
         </ns0:nvSpPr>
         <ns0:spPr>
           <ns2:xfrm xmlns:ns2="http://schemas.openxmlformats.org/drawingml/2006/main">
-            <ns2:off x="12134850" y="4076700"/>
-            <ns2:ext cx="5381625" cy="342900"/>
+            <ns2:off x="12153900" y="5105400"/>
+            <ns2:ext cx="4972050" cy="342900"/>
           </ns2:xfrm>
           <ns3:prstGeom xmlns:ns3="http://schemas.openxmlformats.org/drawingml/2006/main" prst="rect">
             <ns3:avLst/>
@@ -810,7 +815,7 @@
           <ns5:lstStyle xmlns:ns5="http://schemas.openxmlformats.org/drawingml/2006/main">
             <ns5:lvl1pPr marL="0" indent="0" algn="l">
               <ns5:buNone/>
-              <ns5:defRPr sz="1600" b="1" cap="all" spc="130">
+              <ns5:defRPr sz="2000" b="1" cap="all" spc="130">
                 <ns5:solidFill>
                   <ns5:srgbClr val="0F6BFF"/>
                 </ns5:solidFill>
@@ -839,8 +844,8 @@
         </ns0:nvSpPr>
         <ns0:spPr>
           <ns2:xfrm xmlns:ns2="http://schemas.openxmlformats.org/drawingml/2006/main">
-            <ns2:off x="12134850" y="4533900"/>
-            <ns2:ext cx="5381625" cy="4572000"/>
+            <ns2:off x="12153900" y="5524500"/>
+            <ns2:ext cx="4972050" cy="4572000"/>
           </ns2:xfrm>
           <ns3:prstGeom xmlns:ns3="http://schemas.openxmlformats.org/drawingml/2006/main" prst="rect">
             <ns3:avLst/>
@@ -851,7 +856,7 @@
           <ns5:lstStyle xmlns:ns5="http://schemas.openxmlformats.org/drawingml/2006/main">
             <ns5:lvl1pPr marL="0" indent="0" algn="l">
               <ns5:buNone/>
-              <ns5:defRPr sz="1800">
+              <ns5:defRPr sz="2200">
                 <ns5:solidFill>
                   <ns5:srgbClr val="000000"/>
                 </ns5:solidFill>
@@ -878,8 +883,8 @@
         </ns0:nvSpPr>
         <ns0:spPr>
           <ns2:xfrm xmlns:ns2="http://schemas.openxmlformats.org/drawingml/2006/main">
-            <ns2:off x="762000" y="9982200"/>
-            <ns2:ext cx="16764000" cy="228600"/>
+            <ns2:off x="1143000" y="9982200"/>
+            <ns2:ext cx="16002000" cy="228600"/>
           </ns2:xfrm>
           <ns3:prstGeom xmlns:ns3="http://schemas.openxmlformats.org/drawingml/2006/main" prst="rect">
             <ns3:avLst/>
@@ -952,8 +957,8 @@
         </ns0:nvSpPr>
         <ns0:spPr>
           <ns2:xfrm xmlns:ns2="http://schemas.openxmlformats.org/drawingml/2006/main">
-            <ns2:off x="762000" y="1714500"/>
-            <ns2:ext cx="16764000" cy="266700"/>
+            <ns2:off x="1143000" y="2428875"/>
+            <ns2:ext cx="16002000" cy="457200"/>
           </ns2:xfrm>
           <ns3:prstGeom xmlns:ns3="http://schemas.openxmlformats.org/drawingml/2006/main" prst="rect">
             <ns3:avLst/>
@@ -964,7 +969,7 @@
           <ns5:lstStyle xmlns:ns5="http://schemas.openxmlformats.org/drawingml/2006/main">
             <ns5:lvl1pPr marL="0" indent="0" algn="l">
               <ns5:buNone/>
-              <ns5:defRPr sz="1800" b="1" cap="all" spc="140">
+              <ns5:defRPr sz="2800" b="1" cap="all" spc="140">
                 <ns5:solidFill>
                   <ns5:srgbClr val="0F6BFF"/>
                 </ns5:solidFill>
@@ -993,8 +998,8 @@
         </ns0:nvSpPr>
         <ns0:spPr>
           <ns2:xfrm xmlns:ns2="http://schemas.openxmlformats.org/drawingml/2006/main">
-            <ns2:off x="762000" y="2057400"/>
-            <ns2:ext cx="16764000" cy="1047750"/>
+            <ns2:off x="1143000" y="2933700"/>
+            <ns2:ext cx="16002000" cy="1905000"/>
           </ns2:xfrm>
           <ns3:prstGeom xmlns:ns3="http://schemas.openxmlformats.org/drawingml/2006/main" prst="rect">
             <ns3:avLst/>
@@ -1004,6 +1009,9 @@
           <ns4:bodyPr xmlns:ns4="http://schemas.openxmlformats.org/drawingml/2006/main" wrap="square" rtlCol="0" anchor="t" lIns="0" tIns="0" rIns="0" bIns="0"/>
           <ns5:lstStyle xmlns:ns5="http://schemas.openxmlformats.org/drawingml/2006/main">
             <ns5:lvl1pPr marL="0" indent="0" algn="l">
+              <ns5:lnSpc>
+                <ns5:spcPct val="90000"/>
+              </ns5:lnSpc>
               <ns5:buNone/>
               <ns5:defRPr sz="6400" b="1">
                 <ns5:solidFill>
@@ -1034,8 +1042,8 @@
         </ns0:nvSpPr>
         <ns0:spPr>
           <ns2:xfrm xmlns:ns2="http://schemas.openxmlformats.org/drawingml/2006/main">
-            <ns2:off x="762000" y="4191000"/>
-            <ns2:ext cx="16764000" cy="5143500"/>
+            <ns2:off x="1143000" y="4953000"/>
+            <ns2:ext cx="16002000" cy="4381500"/>
           </ns2:xfrm>
           <ns3:prstGeom xmlns:ns3="http://schemas.openxmlformats.org/drawingml/2006/main" prst="rect">
             <ns3:avLst/>
@@ -1059,8 +1067,8 @@
         </ns0:nvSpPr>
         <ns0:spPr>
           <ns2:xfrm xmlns:ns2="http://schemas.openxmlformats.org/drawingml/2006/main">
-            <ns2:off x="762000" y="9982200"/>
-            <ns2:ext cx="16764000" cy="228600"/>
+            <ns2:off x="1143000" y="9982200"/>
+            <ns2:ext cx="16002000" cy="228600"/>
           </ns2:xfrm>
           <ns3:prstGeom xmlns:ns3="http://schemas.openxmlformats.org/drawingml/2006/main" prst="rect">
             <ns3:avLst/>
@@ -1133,8 +1141,8 @@
         </ns0:nvSpPr>
         <ns0:spPr>
           <ns2:xfrm xmlns:ns2="http://schemas.openxmlformats.org/drawingml/2006/main">
-            <ns2:off x="762000" y="1714500"/>
-            <ns2:ext cx="16764000" cy="266700"/>
+            <ns2:off x="1143000" y="2428875"/>
+            <ns2:ext cx="16002000" cy="457200"/>
           </ns2:xfrm>
           <ns3:prstGeom xmlns:ns3="http://schemas.openxmlformats.org/drawingml/2006/main" prst="rect">
             <ns3:avLst/>
@@ -1145,7 +1153,7 @@
           <ns5:lstStyle xmlns:ns5="http://schemas.openxmlformats.org/drawingml/2006/main">
             <ns5:lvl1pPr marL="0" indent="0" algn="l">
               <ns5:buNone/>
-              <ns5:defRPr sz="1800" b="1" cap="all" spc="140">
+              <ns5:defRPr sz="2800" b="1" cap="all" spc="140">
                 <ns5:solidFill>
                   <ns5:srgbClr val="0F6BFF"/>
                 </ns5:solidFill>
@@ -1174,8 +1182,8 @@
         </ns0:nvSpPr>
         <ns0:spPr>
           <ns2:xfrm xmlns:ns2="http://schemas.openxmlformats.org/drawingml/2006/main">
-            <ns2:off x="762000" y="2057400"/>
-            <ns2:ext cx="16764000" cy="1047750"/>
+            <ns2:off x="1143000" y="2933700"/>
+            <ns2:ext cx="16002000" cy="1905000"/>
           </ns2:xfrm>
           <ns3:prstGeom xmlns:ns3="http://schemas.openxmlformats.org/drawingml/2006/main" prst="rect">
             <ns3:avLst/>
@@ -1185,6 +1193,9 @@
           <ns4:bodyPr xmlns:ns4="http://schemas.openxmlformats.org/drawingml/2006/main" wrap="square" rtlCol="0" anchor="t" lIns="0" tIns="0" rIns="0" bIns="0"/>
           <ns5:lstStyle xmlns:ns5="http://schemas.openxmlformats.org/drawingml/2006/main">
             <ns5:lvl1pPr marL="0" indent="0" algn="l">
+              <ns5:lnSpc>
+                <ns5:spcPct val="90000"/>
+              </ns5:lnSpc>
               <ns5:buNone/>
               <ns5:defRPr sz="6400" b="1">
                 <ns5:solidFill>
@@ -1211,8 +1222,8 @@
         </ns0:nvSpPr>
         <ns0:spPr>
           <ns1:xfrm xmlns:ns1="http://schemas.openxmlformats.org/drawingml/2006/main">
-            <ns1:off x="762000" y="3810000"/>
-            <ns1:ext cx="5429250" cy="2571750"/>
+            <ns1:off x="1143000" y="4953000"/>
+            <ns1:ext cx="5181600" cy="2190750"/>
           </ns1:xfrm>
           <ns2:prstGeom xmlns:ns2="http://schemas.openxmlformats.org/drawingml/2006/main" prst="rect">
             <ns2:avLst/>
@@ -1240,8 +1251,8 @@
         </ns0:nvSpPr>
         <ns0:spPr>
           <ns1:xfrm xmlns:ns1="http://schemas.openxmlformats.org/drawingml/2006/main">
-            <ns1:off x="762000" y="3810000"/>
-            <ns1:ext cx="5429250" cy="28575"/>
+            <ns1:off x="1143000" y="4953000"/>
+            <ns1:ext cx="5181600" cy="28575"/>
           </ns1:xfrm>
           <ns2:prstGeom xmlns:ns2="http://schemas.openxmlformats.org/drawingml/2006/main" prst="rect">
             <ns2:avLst/>
@@ -1273,8 +1284,8 @@
         </ns0:nvSpPr>
         <ns0:spPr>
           <ns2:xfrm xmlns:ns2="http://schemas.openxmlformats.org/drawingml/2006/main">
-            <ns2:off x="990600" y="4648200"/>
-            <ns2:ext cx="4972050" cy="304800"/>
+            <ns2:off x="1371600" y="5791200"/>
+            <ns2:ext cx="4724400" cy="304800"/>
           </ns2:xfrm>
           <ns3:prstGeom xmlns:ns3="http://schemas.openxmlformats.org/drawingml/2006/main" prst="rect">
             <ns3:avLst/>
@@ -1314,8 +1325,8 @@
         </ns0:nvSpPr>
         <ns0:spPr>
           <ns2:xfrm xmlns:ns2="http://schemas.openxmlformats.org/drawingml/2006/main">
-            <ns2:off x="990600" y="4991100"/>
-            <ns2:ext cx="4972050" cy="1238250"/>
+            <ns2:off x="1371600" y="6134100"/>
+            <ns2:ext cx="4724400" cy="857250"/>
           </ns2:xfrm>
           <ns3:prstGeom xmlns:ns3="http://schemas.openxmlformats.org/drawingml/2006/main" prst="rect">
             <ns3:avLst/>
@@ -1326,7 +1337,7 @@
           <ns5:lstStyle xmlns:ns5="http://schemas.openxmlformats.org/drawingml/2006/main">
             <ns5:lvl1pPr marL="0" indent="0" algn="l">
               <ns5:buNone/>
-              <ns5:defRPr sz="1200">
+              <ns5:defRPr sz="1800">
                 <ns5:solidFill>
                   <ns5:srgbClr val="000000"/>
                 </ns5:solidFill>
@@ -1351,8 +1362,8 @@
         </ns0:nvSpPr>
         <ns0:spPr>
           <ns1:xfrm xmlns:ns1="http://schemas.openxmlformats.org/drawingml/2006/main">
-            <ns1:off x="6419850" y="3810000"/>
-            <ns1:ext cx="5429250" cy="2571750"/>
+            <ns1:off x="6553200" y="4953000"/>
+            <ns1:ext cx="5181600" cy="2190750"/>
           </ns1:xfrm>
           <ns2:prstGeom xmlns:ns2="http://schemas.openxmlformats.org/drawingml/2006/main" prst="rect">
             <ns2:avLst/>
@@ -1380,8 +1391,8 @@
         </ns0:nvSpPr>
         <ns0:spPr>
           <ns1:xfrm xmlns:ns1="http://schemas.openxmlformats.org/drawingml/2006/main">
-            <ns1:off x="6419850" y="3810000"/>
-            <ns1:ext cx="5429250" cy="28575"/>
+            <ns1:off x="6553200" y="4953000"/>
+            <ns1:ext cx="5181600" cy="28575"/>
           </ns1:xfrm>
           <ns2:prstGeom xmlns:ns2="http://schemas.openxmlformats.org/drawingml/2006/main" prst="rect">
             <ns2:avLst/>
@@ -1413,8 +1424,8 @@
         </ns0:nvSpPr>
         <ns0:spPr>
           <ns2:xfrm xmlns:ns2="http://schemas.openxmlformats.org/drawingml/2006/main">
-            <ns2:off x="6648450" y="4648200"/>
-            <ns2:ext cx="4972050" cy="304800"/>
+            <ns2:off x="6781800" y="5791200"/>
+            <ns2:ext cx="4724400" cy="304800"/>
           </ns2:xfrm>
           <ns3:prstGeom xmlns:ns3="http://schemas.openxmlformats.org/drawingml/2006/main" prst="rect">
             <ns3:avLst/>
@@ -1454,8 +1465,8 @@
         </ns0:nvSpPr>
         <ns0:spPr>
           <ns2:xfrm xmlns:ns2="http://schemas.openxmlformats.org/drawingml/2006/main">
-            <ns2:off x="6648450" y="4991100"/>
-            <ns2:ext cx="4972050" cy="1238250"/>
+            <ns2:off x="6781800" y="6134100"/>
+            <ns2:ext cx="4724400" cy="857250"/>
           </ns2:xfrm>
           <ns3:prstGeom xmlns:ns3="http://schemas.openxmlformats.org/drawingml/2006/main" prst="rect">
             <ns3:avLst/>
@@ -1466,7 +1477,7 @@
           <ns5:lstStyle xmlns:ns5="http://schemas.openxmlformats.org/drawingml/2006/main">
             <ns5:lvl1pPr marL="0" indent="0" algn="l">
               <ns5:buNone/>
-              <ns5:defRPr sz="1200">
+              <ns5:defRPr sz="1800">
                 <ns5:solidFill>
                   <ns5:srgbClr val="000000"/>
                 </ns5:solidFill>
@@ -1491,8 +1502,8 @@
         </ns0:nvSpPr>
         <ns0:spPr>
           <ns1:xfrm xmlns:ns1="http://schemas.openxmlformats.org/drawingml/2006/main">
-            <ns1:off x="12077700" y="3810000"/>
-            <ns1:ext cx="5429250" cy="2571750"/>
+            <ns1:off x="11963400" y="4953000"/>
+            <ns1:ext cx="5181600" cy="2190750"/>
           </ns1:xfrm>
           <ns2:prstGeom xmlns:ns2="http://schemas.openxmlformats.org/drawingml/2006/main" prst="rect">
             <ns2:avLst/>
@@ -1520,8 +1531,8 @@
         </ns0:nvSpPr>
         <ns0:spPr>
           <ns1:xfrm xmlns:ns1="http://schemas.openxmlformats.org/drawingml/2006/main">
-            <ns1:off x="12077700" y="3810000"/>
-            <ns1:ext cx="5429250" cy="28575"/>
+            <ns1:off x="11963400" y="4953000"/>
+            <ns1:ext cx="5181600" cy="28575"/>
           </ns1:xfrm>
           <ns2:prstGeom xmlns:ns2="http://schemas.openxmlformats.org/drawingml/2006/main" prst="rect">
             <ns2:avLst/>
@@ -1553,8 +1564,8 @@
         </ns0:nvSpPr>
         <ns0:spPr>
           <ns2:xfrm xmlns:ns2="http://schemas.openxmlformats.org/drawingml/2006/main">
-            <ns2:off x="12306300" y="4648200"/>
-            <ns2:ext cx="4972050" cy="304800"/>
+            <ns2:off x="12192000" y="5791200"/>
+            <ns2:ext cx="4724400" cy="304800"/>
           </ns2:xfrm>
           <ns3:prstGeom xmlns:ns3="http://schemas.openxmlformats.org/drawingml/2006/main" prst="rect">
             <ns3:avLst/>
@@ -1594,8 +1605,8 @@
         </ns0:nvSpPr>
         <ns0:spPr>
           <ns2:xfrm xmlns:ns2="http://schemas.openxmlformats.org/drawingml/2006/main">
-            <ns2:off x="12306300" y="4991100"/>
-            <ns2:ext cx="4972050" cy="1238250"/>
+            <ns2:off x="12192000" y="6134100"/>
+            <ns2:ext cx="4724400" cy="857250"/>
           </ns2:xfrm>
           <ns3:prstGeom xmlns:ns3="http://schemas.openxmlformats.org/drawingml/2006/main" prst="rect">
             <ns3:avLst/>
@@ -1606,7 +1617,7 @@
           <ns5:lstStyle xmlns:ns5="http://schemas.openxmlformats.org/drawingml/2006/main">
             <ns5:lvl1pPr marL="0" indent="0" algn="l">
               <ns5:buNone/>
-              <ns5:defRPr sz="1200">
+              <ns5:defRPr sz="1800">
                 <ns5:solidFill>
                   <ns5:srgbClr val="000000"/>
                 </ns5:solidFill>
@@ -1631,8 +1642,8 @@
         </ns0:nvSpPr>
         <ns0:spPr>
           <ns1:xfrm xmlns:ns1="http://schemas.openxmlformats.org/drawingml/2006/main">
-            <ns1:off x="762000" y="6610350"/>
-            <ns1:ext cx="5429250" cy="2571750"/>
+            <ns1:off x="1143000" y="7372350"/>
+            <ns1:ext cx="5181600" cy="2190750"/>
           </ns1:xfrm>
           <ns2:prstGeom xmlns:ns2="http://schemas.openxmlformats.org/drawingml/2006/main" prst="rect">
             <ns2:avLst/>
@@ -1660,8 +1671,8 @@
         </ns0:nvSpPr>
         <ns0:spPr>
           <ns1:xfrm xmlns:ns1="http://schemas.openxmlformats.org/drawingml/2006/main">
-            <ns1:off x="762000" y="6610350"/>
-            <ns1:ext cx="5429250" cy="28575"/>
+            <ns1:off x="1143000" y="7372350"/>
+            <ns1:ext cx="5181600" cy="28575"/>
           </ns1:xfrm>
           <ns2:prstGeom xmlns:ns2="http://schemas.openxmlformats.org/drawingml/2006/main" prst="rect">
             <ns2:avLst/>
@@ -1693,8 +1704,8 @@
         </ns0:nvSpPr>
         <ns0:spPr>
           <ns2:xfrm xmlns:ns2="http://schemas.openxmlformats.org/drawingml/2006/main">
-            <ns2:off x="990600" y="7448550"/>
-            <ns2:ext cx="4972050" cy="304800"/>
+            <ns2:off x="1371600" y="8210550"/>
+            <ns2:ext cx="4724400" cy="304800"/>
           </ns2:xfrm>
           <ns3:prstGeom xmlns:ns3="http://schemas.openxmlformats.org/drawingml/2006/main" prst="rect">
             <ns3:avLst/>
@@ -1734,8 +1745,8 @@
         </ns0:nvSpPr>
         <ns0:spPr>
           <ns2:xfrm xmlns:ns2="http://schemas.openxmlformats.org/drawingml/2006/main">
-            <ns2:off x="990600" y="7791450"/>
-            <ns2:ext cx="4972050" cy="1238250"/>
+            <ns2:off x="1371600" y="8553450"/>
+            <ns2:ext cx="4724400" cy="857250"/>
           </ns2:xfrm>
           <ns3:prstGeom xmlns:ns3="http://schemas.openxmlformats.org/drawingml/2006/main" prst="rect">
             <ns3:avLst/>
@@ -1746,7 +1757,7 @@
           <ns5:lstStyle xmlns:ns5="http://schemas.openxmlformats.org/drawingml/2006/main">
             <ns5:lvl1pPr marL="0" indent="0" algn="l">
               <ns5:buNone/>
-              <ns5:defRPr sz="1200">
+              <ns5:defRPr sz="1800">
                 <ns5:solidFill>
                   <ns5:srgbClr val="000000"/>
                 </ns5:solidFill>
@@ -1771,8 +1782,8 @@
         </ns0:nvSpPr>
         <ns0:spPr>
           <ns1:xfrm xmlns:ns1="http://schemas.openxmlformats.org/drawingml/2006/main">
-            <ns1:off x="6419850" y="6610350"/>
-            <ns1:ext cx="5429250" cy="2571750"/>
+            <ns1:off x="6553200" y="7372350"/>
+            <ns1:ext cx="5181600" cy="2190750"/>
           </ns1:xfrm>
           <ns2:prstGeom xmlns:ns2="http://schemas.openxmlformats.org/drawingml/2006/main" prst="rect">
             <ns2:avLst/>
@@ -1800,8 +1811,8 @@
         </ns0:nvSpPr>
         <ns0:spPr>
           <ns1:xfrm xmlns:ns1="http://schemas.openxmlformats.org/drawingml/2006/main">
-            <ns1:off x="6419850" y="6610350"/>
-            <ns1:ext cx="5429250" cy="28575"/>
+            <ns1:off x="6553200" y="7372350"/>
+            <ns1:ext cx="5181600" cy="28575"/>
           </ns1:xfrm>
           <ns2:prstGeom xmlns:ns2="http://schemas.openxmlformats.org/drawingml/2006/main" prst="rect">
             <ns2:avLst/>
@@ -1833,8 +1844,8 @@
         </ns0:nvSpPr>
         <ns0:spPr>
           <ns2:xfrm xmlns:ns2="http://schemas.openxmlformats.org/drawingml/2006/main">
-            <ns2:off x="6648450" y="7448550"/>
-            <ns2:ext cx="4972050" cy="304800"/>
+            <ns2:off x="6781800" y="8210550"/>
+            <ns2:ext cx="4724400" cy="304800"/>
           </ns2:xfrm>
           <ns3:prstGeom xmlns:ns3="http://schemas.openxmlformats.org/drawingml/2006/main" prst="rect">
             <ns3:avLst/>
@@ -1874,8 +1885,8 @@
         </ns0:nvSpPr>
         <ns0:spPr>
           <ns2:xfrm xmlns:ns2="http://schemas.openxmlformats.org/drawingml/2006/main">
-            <ns2:off x="6648450" y="7791450"/>
-            <ns2:ext cx="4972050" cy="1238250"/>
+            <ns2:off x="6781800" y="8553450"/>
+            <ns2:ext cx="4724400" cy="857250"/>
           </ns2:xfrm>
           <ns3:prstGeom xmlns:ns3="http://schemas.openxmlformats.org/drawingml/2006/main" prst="rect">
             <ns3:avLst/>
@@ -1886,7 +1897,7 @@
           <ns5:lstStyle xmlns:ns5="http://schemas.openxmlformats.org/drawingml/2006/main">
             <ns5:lvl1pPr marL="0" indent="0" algn="l">
               <ns5:buNone/>
-              <ns5:defRPr sz="1200">
+              <ns5:defRPr sz="1800">
                 <ns5:solidFill>
                   <ns5:srgbClr val="000000"/>
                 </ns5:solidFill>
@@ -1911,8 +1922,8 @@
         </ns0:nvSpPr>
         <ns0:spPr>
           <ns1:xfrm xmlns:ns1="http://schemas.openxmlformats.org/drawingml/2006/main">
-            <ns1:off x="12077700" y="6610350"/>
-            <ns1:ext cx="5429250" cy="2571750"/>
+            <ns1:off x="11963400" y="7372350"/>
+            <ns1:ext cx="5181600" cy="2190750"/>
           </ns1:xfrm>
           <ns2:prstGeom xmlns:ns2="http://schemas.openxmlformats.org/drawingml/2006/main" prst="rect">
             <ns2:avLst/>
@@ -1940,8 +1951,8 @@
         </ns0:nvSpPr>
         <ns0:spPr>
           <ns1:xfrm xmlns:ns1="http://schemas.openxmlformats.org/drawingml/2006/main">
-            <ns1:off x="12077700" y="6610350"/>
-            <ns1:ext cx="5429250" cy="28575"/>
+            <ns1:off x="11963400" y="7372350"/>
+            <ns1:ext cx="5181600" cy="28575"/>
           </ns1:xfrm>
           <ns2:prstGeom xmlns:ns2="http://schemas.openxmlformats.org/drawingml/2006/main" prst="rect">
             <ns2:avLst/>
@@ -1973,8 +1984,8 @@
         </ns0:nvSpPr>
         <ns0:spPr>
           <ns2:xfrm xmlns:ns2="http://schemas.openxmlformats.org/drawingml/2006/main">
-            <ns2:off x="12306300" y="7448550"/>
-            <ns2:ext cx="4972050" cy="304800"/>
+            <ns2:off x="12192000" y="8210550"/>
+            <ns2:ext cx="4724400" cy="304800"/>
           </ns2:xfrm>
           <ns3:prstGeom xmlns:ns3="http://schemas.openxmlformats.org/drawingml/2006/main" prst="rect">
             <ns3:avLst/>
@@ -2014,8 +2025,8 @@
         </ns0:nvSpPr>
         <ns0:spPr>
           <ns2:xfrm xmlns:ns2="http://schemas.openxmlformats.org/drawingml/2006/main">
-            <ns2:off x="12306300" y="7791450"/>
-            <ns2:ext cx="4972050" cy="1238250"/>
+            <ns2:off x="12192000" y="8553450"/>
+            <ns2:ext cx="4724400" cy="857250"/>
           </ns2:xfrm>
           <ns3:prstGeom xmlns:ns3="http://schemas.openxmlformats.org/drawingml/2006/main" prst="rect">
             <ns3:avLst/>
@@ -2026,7 +2037,7 @@
           <ns5:lstStyle xmlns:ns5="http://schemas.openxmlformats.org/drawingml/2006/main">
             <ns5:lvl1pPr marL="0" indent="0" algn="l">
               <ns5:buNone/>
-              <ns5:defRPr sz="1200">
+              <ns5:defRPr sz="1800">
                 <ns5:solidFill>
                   <ns5:srgbClr val="000000"/>
                 </ns5:solidFill>
@@ -2053,8 +2064,8 @@
         </ns0:nvSpPr>
         <ns0:spPr>
           <ns2:xfrm xmlns:ns2="http://schemas.openxmlformats.org/drawingml/2006/main">
-            <ns2:off x="762000" y="9982200"/>
-            <ns2:ext cx="16764000" cy="228600"/>
+            <ns2:off x="1143000" y="9982200"/>
+            <ns2:ext cx="16002000" cy="228600"/>
           </ns2:xfrm>
           <ns3:prstGeom xmlns:ns3="http://schemas.openxmlformats.org/drawingml/2006/main" prst="rect">
             <ns3:avLst/>
@@ -2127,8 +2138,8 @@
         </ns0:nvSpPr>
         <ns0:spPr>
           <ns2:xfrm xmlns:ns2="http://schemas.openxmlformats.org/drawingml/2006/main">
-            <ns2:off x="762000" y="1714500"/>
-            <ns2:ext cx="16764000" cy="266700"/>
+            <ns2:off x="1143000" y="2428875"/>
+            <ns2:ext cx="16002000" cy="457200"/>
           </ns2:xfrm>
           <ns3:prstGeom xmlns:ns3="http://schemas.openxmlformats.org/drawingml/2006/main" prst="rect">
             <ns3:avLst/>
@@ -2139,7 +2150,7 @@
           <ns5:lstStyle xmlns:ns5="http://schemas.openxmlformats.org/drawingml/2006/main">
             <ns5:lvl1pPr marL="0" indent="0" algn="l">
               <ns5:buNone/>
-              <ns5:defRPr sz="1800" b="1" cap="all" spc="140">
+              <ns5:defRPr sz="2800" b="1" cap="all" spc="140">
                 <ns5:solidFill>
                   <ns5:srgbClr val="0F6BFF"/>
                 </ns5:solidFill>
@@ -2168,8 +2179,8 @@
         </ns0:nvSpPr>
         <ns0:spPr>
           <ns2:xfrm xmlns:ns2="http://schemas.openxmlformats.org/drawingml/2006/main">
-            <ns2:off x="762000" y="2057400"/>
-            <ns2:ext cx="16764000" cy="1047750"/>
+            <ns2:off x="1143000" y="2933700"/>
+            <ns2:ext cx="16002000" cy="1905000"/>
           </ns2:xfrm>
           <ns3:prstGeom xmlns:ns3="http://schemas.openxmlformats.org/drawingml/2006/main" prst="rect">
             <ns3:avLst/>
@@ -2179,6 +2190,9 @@
           <ns4:bodyPr xmlns:ns4="http://schemas.openxmlformats.org/drawingml/2006/main" wrap="square" rtlCol="0" anchor="t" lIns="0" tIns="0" rIns="0" bIns="0"/>
           <ns5:lstStyle xmlns:ns5="http://schemas.openxmlformats.org/drawingml/2006/main">
             <ns5:lvl1pPr marL="0" indent="0" algn="l">
+              <ns5:lnSpc>
+                <ns5:spcPct val="90000"/>
+              </ns5:lnSpc>
               <ns5:buNone/>
               <ns5:defRPr sz="6400" b="1">
                 <ns5:solidFill>
@@ -2209,8 +2223,8 @@
         </ns0:nvSpPr>
         <ns0:spPr>
           <ns2:xfrm xmlns:ns2="http://schemas.openxmlformats.org/drawingml/2006/main">
-            <ns2:off x="762000" y="3810000"/>
-            <ns2:ext cx="8382000" cy="5524500"/>
+            <ns2:off x="1143000" y="4953000"/>
+            <ns2:ext cx="7810500" cy="4381500"/>
           </ns2:xfrm>
           <ns3:prstGeom xmlns:ns3="http://schemas.openxmlformats.org/drawingml/2006/main" prst="rect">
             <ns3:avLst/>
@@ -2221,7 +2235,7 @@
           <ns5:lstStyle xmlns:ns5="http://schemas.openxmlformats.org/drawingml/2006/main">
             <ns5:lvl1pPr marL="0" indent="0" algn="l">
               <ns5:buNone/>
-              <ns5:defRPr sz="1800">
+              <ns5:defRPr sz="2200">
                 <ns5:solidFill>
                   <ns5:srgbClr val="000000"/>
                 </ns5:solidFill>
@@ -2250,8 +2264,8 @@
         </ns0:nvSpPr>
         <ns0:spPr>
           <ns2:xfrm xmlns:ns2="http://schemas.openxmlformats.org/drawingml/2006/main">
-            <ns2:off x="9334500" y="3810000"/>
-            <ns2:ext cx="8382000" cy="5524500"/>
+            <ns2:off x="9334500" y="4953000"/>
+            <ns2:ext cx="7810500" cy="4381500"/>
           </ns2:xfrm>
           <ns3:prstGeom xmlns:ns3="http://schemas.openxmlformats.org/drawingml/2006/main" prst="rect">
             <ns3:avLst/>
@@ -2262,7 +2276,7 @@
           <ns5:lstStyle xmlns:ns5="http://schemas.openxmlformats.org/drawingml/2006/main">
             <ns5:lvl1pPr marL="0" indent="0" algn="l">
               <ns5:buNone/>
-              <ns5:defRPr sz="1800">
+              <ns5:defRPr sz="2200">
                 <ns5:solidFill>
                   <ns5:srgbClr val="000000"/>
                 </ns5:solidFill>
@@ -2289,8 +2303,8 @@
         </ns0:nvSpPr>
         <ns0:spPr>
           <ns2:xfrm xmlns:ns2="http://schemas.openxmlformats.org/drawingml/2006/main">
-            <ns2:off x="762000" y="9982200"/>
-            <ns2:ext cx="16764000" cy="228600"/>
+            <ns2:off x="1143000" y="9982200"/>
+            <ns2:ext cx="16002000" cy="228600"/>
           </ns2:xfrm>
           <ns3:prstGeom xmlns:ns3="http://schemas.openxmlformats.org/drawingml/2006/main" prst="rect">
             <ns3:avLst/>
@@ -2437,8 +2451,8 @@
         </ns0:nvSpPr>
         <ns0:spPr>
           <ns2:xfrm xmlns:ns2="http://schemas.openxmlformats.org/drawingml/2006/main">
-            <ns2:off x="762000" y="1714500"/>
-            <ns2:ext cx="16764000" cy="266700"/>
+            <ns2:off x="1143000" y="2428875"/>
+            <ns2:ext cx="16002000" cy="457200"/>
           </ns2:xfrm>
           <ns3:prstGeom xmlns:ns3="http://schemas.openxmlformats.org/drawingml/2006/main" prst="rect">
             <ns3:avLst/>
@@ -2449,7 +2463,7 @@
           <ns5:lstStyle xmlns:ns5="http://schemas.openxmlformats.org/drawingml/2006/main">
             <ns5:lvl1pPr marL="0" indent="0" algn="l">
               <ns5:buNone/>
-              <ns5:defRPr sz="1800" b="1" cap="all" spc="140">
+              <ns5:defRPr sz="2800" b="1" cap="all" spc="140">
                 <ns5:solidFill>
                   <ns5:srgbClr val="0F6BFF"/>
                 </ns5:solidFill>
@@ -2478,8 +2492,8 @@
         </ns0:nvSpPr>
         <ns0:spPr>
           <ns2:xfrm xmlns:ns2="http://schemas.openxmlformats.org/drawingml/2006/main">
-            <ns2:off x="762000" y="2057400"/>
-            <ns2:ext cx="16764000" cy="1047750"/>
+            <ns2:off x="1143000" y="2933700"/>
+            <ns2:ext cx="16002000" cy="1905000"/>
           </ns2:xfrm>
           <ns3:prstGeom xmlns:ns3="http://schemas.openxmlformats.org/drawingml/2006/main" prst="rect">
             <ns3:avLst/>
@@ -2489,6 +2503,9 @@
           <ns4:bodyPr xmlns:ns4="http://schemas.openxmlformats.org/drawingml/2006/main" wrap="square" rtlCol="0" anchor="t" lIns="0" tIns="0" rIns="0" bIns="0"/>
           <ns5:lstStyle xmlns:ns5="http://schemas.openxmlformats.org/drawingml/2006/main">
             <ns5:lvl1pPr marL="0" indent="0" algn="l">
+              <ns5:lnSpc>
+                <ns5:spcPct val="90000"/>
+              </ns5:lnSpc>
               <ns5:buNone/>
               <ns5:defRPr sz="6400" b="1">
                 <ns5:solidFill>
@@ -2519,8 +2536,8 @@
         </ns0:nvSpPr>
         <ns0:spPr>
           <ns2:xfrm xmlns:ns2="http://schemas.openxmlformats.org/drawingml/2006/main">
-            <ns2:off x="762000" y="3810000"/>
-            <ns2:ext cx="16764000" cy="5715000"/>
+            <ns2:off x="1143000" y="5524500"/>
+            <ns2:ext cx="16002000" cy="3810000"/>
           </ns2:xfrm>
           <ns3:prstGeom xmlns:ns3="http://schemas.openxmlformats.org/drawingml/2006/main" prst="rect">
             <ns3:avLst/>
@@ -2558,8 +2575,206 @@
         </ns0:nvSpPr>
         <ns0:spPr>
           <ns2:xfrm xmlns:ns2="http://schemas.openxmlformats.org/drawingml/2006/main">
-            <ns2:off x="762000" y="9982200"/>
-            <ns2:ext cx="16764000" cy="228600"/>
+            <ns2:off x="1143000" y="9982200"/>
+            <ns2:ext cx="16002000" cy="228600"/>
+          </ns2:xfrm>
+          <ns3:prstGeom xmlns:ns3="http://schemas.openxmlformats.org/drawingml/2006/main" prst="rect">
+            <ns3:avLst/>
+          </ns3:prstGeom>
+        </ns0:spPr>
+        <ns0:txBody>
+          <ns4:bodyPr xmlns:ns4="http://schemas.openxmlformats.org/drawingml/2006/main" wrap="square" rtlCol="0" anchor="t" lIns="0" tIns="0" rIns="0" bIns="0"/>
+          <ns5:lstStyle xmlns:ns5="http://schemas.openxmlformats.org/drawingml/2006/main">
+            <ns5:lvl1pPr marL="0" indent="0" algn="l">
+              <ns5:buNone/>
+              <ns5:defRPr sz="900" cap="all" spc="50">
+                <ns5:solidFill>
+                  <ns5:srgbClr val="6B7280"/>
+                </ns5:solidFill>
+                <ns5:latin typeface="Aptos"/>
+              </ns5:defRPr>
+            </ns5:lvl1pPr>
+          </ns5:lstStyle>
+          <ns6:p xmlns:ns6="http://schemas.openxmlformats.org/drawingml/2006/main">
+            <ns6:r>
+              <ns6:rPr lang="en-US"/>
+              <ns6:t>OPEN COMPONENT MODEL · OCM.SOFTWARE</ns6:t>
+            </ns6:r>
+            <ns6:endParaRPr lang="en-US"/>
+          </ns6:p>
+        </ns0:txBody>
+      </ns0:sp>
+    </p:spTree>
+  </p:cSld>
+  <p:clrMapOvr>
+    <a:masterClrMapping/>
+  </p:clrMapOvr>
+</p:sldLayout>
+</file>
+
+<file path=ppt/slideLayouts/slideLayout9.xml><?xml version="1.0" encoding="utf-8"?>
+<p:sldLayout xmlns:a="http://schemas.openxmlformats.org/drawingml/2006/main" xmlns:r="http://schemas.openxmlformats.org/officeDocument/2006/relationships" xmlns:p="http://schemas.openxmlformats.org/presentationml/2006/main" type="obj" preserve="1" userDrawn="1">
+  <p:cSld name="Plain / Compact">
+    <p:bg>
+      <p:bgPr>
+        <a:solidFill>
+          <a:srgbClr val="FFFFFF"/>
+        </a:solidFill>
+        <a:effectLst/>
+      </p:bgPr>
+    </p:bg>
+    <p:spTree>
+      <p:nvGrpSpPr>
+        <p:cNvPr id="1" name=""/>
+        <p:cNvGrpSpPr/>
+        <p:nvPr/>
+      </p:nvGrpSpPr>
+      <p:grpSpPr>
+        <a:xfrm>
+          <a:off x="0" y="0"/>
+          <a:ext cx="0" cy="0"/>
+          <a:chOff x="0" y="0"/>
+          <a:chExt cx="0" cy="0"/>
+        </a:xfrm>
+      </p:grpSpPr>
+      <ns0:sp xmlns:ns0="http://schemas.openxmlformats.org/presentationml/2006/main">
+        <ns0:nvSpPr>
+          <ns0:cNvPr id="10" name="Eyebrow"/>
+          <ns0:cNvSpPr>
+            <ns1:spLocks xmlns:ns1="http://schemas.openxmlformats.org/drawingml/2006/main" noGrp="1"/>
+          </ns0:cNvSpPr>
+          <ns0:nvPr>
+            <ns0:ph type="body" idx="1"/>
+          </ns0:nvPr>
+        </ns0:nvSpPr>
+        <ns0:spPr>
+          <ns2:xfrm xmlns:ns2="http://schemas.openxmlformats.org/drawingml/2006/main">
+            <ns2:off x="1143000" y="2428875"/>
+            <ns2:ext cx="16002000" cy="457200"/>
+          </ns2:xfrm>
+          <ns3:prstGeom xmlns:ns3="http://schemas.openxmlformats.org/drawingml/2006/main" prst="rect">
+            <ns3:avLst/>
+          </ns3:prstGeom>
+        </ns0:spPr>
+        <ns0:txBody>
+          <ns4:bodyPr xmlns:ns4="http://schemas.openxmlformats.org/drawingml/2006/main" wrap="square" rtlCol="0" anchor="t" lIns="0" tIns="0" rIns="0" bIns="0"/>
+          <ns5:lstStyle xmlns:ns5="http://schemas.openxmlformats.org/drawingml/2006/main">
+            <ns5:lvl1pPr marL="0" indent="0" algn="l">
+              <ns5:buNone/>
+              <ns5:defRPr sz="2800" b="1" cap="all" spc="140">
+                <ns5:solidFill>
+                  <ns5:srgbClr val="0F6BFF"/>
+                </ns5:solidFill>
+                <ns5:latin typeface="Aptos"/>
+              </ns5:defRPr>
+            </ns5:lvl1pPr>
+          </ns5:lstStyle>
+          <ns6:p xmlns:ns6="http://schemas.openxmlformats.org/drawingml/2006/main">
+            <ns6:r>
+              <ns6:rPr lang="en-US"/>
+              <ns6:t>EYEBROW</ns6:t>
+            </ns6:r>
+            <ns6:endParaRPr lang="en-US"/>
+          </ns6:p>
+        </ns0:txBody>
+      </ns0:sp>
+      <ns0:sp xmlns:ns0="http://schemas.openxmlformats.org/presentationml/2006/main">
+        <ns0:nvSpPr>
+          <ns0:cNvPr id="11" name="Title"/>
+          <ns0:cNvSpPr>
+            <ns1:spLocks xmlns:ns1="http://schemas.openxmlformats.org/drawingml/2006/main" noGrp="1"/>
+          </ns0:cNvSpPr>
+          <ns0:nvPr>
+            <ns0:ph type="title" idx="2"/>
+          </ns0:nvPr>
+        </ns0:nvSpPr>
+        <ns0:spPr>
+          <ns2:xfrm xmlns:ns2="http://schemas.openxmlformats.org/drawingml/2006/main">
+            <ns2:off x="1143000" y="2933700"/>
+            <ns2:ext cx="16002000" cy="1905000"/>
+          </ns2:xfrm>
+          <ns3:prstGeom xmlns:ns3="http://schemas.openxmlformats.org/drawingml/2006/main" prst="rect">
+            <ns3:avLst/>
+          </ns3:prstGeom>
+        </ns0:spPr>
+        <ns0:txBody>
+          <ns4:bodyPr xmlns:ns4="http://schemas.openxmlformats.org/drawingml/2006/main" wrap="square" rtlCol="0" anchor="t" lIns="0" tIns="0" rIns="0" bIns="0"/>
+          <ns5:lstStyle xmlns:ns5="http://schemas.openxmlformats.org/drawingml/2006/main">
+            <ns5:lvl1pPr marL="0" indent="0" algn="l">
+              <ns5:lnSpc>
+                <ns5:spcPct val="90000"/>
+              </ns5:lnSpc>
+              <ns5:buNone/>
+              <ns5:defRPr sz="6400" b="1">
+                <ns5:solidFill>
+                  <ns5:srgbClr val="000000"/>
+                </ns5:solidFill>
+                <ns5:latin typeface="Aptos Display"/>
+              </ns5:defRPr>
+            </ns5:lvl1pPr>
+          </ns5:lstStyle>
+          <ns6:p xmlns:ns6="http://schemas.openxmlformats.org/drawingml/2006/main">
+            <ns6:r>
+              <ns6:rPr lang="en-US"/>
+              <ns6:t>Section title goes here.</ns6:t>
+            </ns6:r>
+            <ns6:endParaRPr lang="en-US"/>
+          </ns6:p>
+        </ns0:txBody>
+      </ns0:sp>
+      <ns0:sp xmlns:ns0="http://schemas.openxmlformats.org/presentationml/2006/main">
+        <ns0:nvSpPr>
+          <ns0:cNvPr id="12" name="Body"/>
+          <ns0:cNvSpPr>
+            <ns1:spLocks xmlns:ns1="http://schemas.openxmlformats.org/drawingml/2006/main" noGrp="1"/>
+          </ns0:cNvSpPr>
+          <ns0:nvPr>
+            <ns0:ph type="body" idx="10"/>
+          </ns0:nvPr>
+        </ns0:nvSpPr>
+        <ns0:spPr>
+          <ns2:xfrm xmlns:ns2="http://schemas.openxmlformats.org/drawingml/2006/main">
+            <ns2:off x="1143000" y="4953000"/>
+            <ns2:ext cx="16002000" cy="4381500"/>
+          </ns2:xfrm>
+          <ns3:prstGeom xmlns:ns3="http://schemas.openxmlformats.org/drawingml/2006/main" prst="rect">
+            <ns3:avLst/>
+          </ns3:prstGeom>
+        </ns0:spPr>
+        <ns0:txBody>
+          <ns4:bodyPr xmlns:ns4="http://schemas.openxmlformats.org/drawingml/2006/main" wrap="square" rtlCol="0" anchor="t" lIns="0" tIns="0" rIns="0" bIns="0"/>
+          <ns5:lstStyle xmlns:ns5="http://schemas.openxmlformats.org/drawingml/2006/main">
+            <ns5:lvl1pPr marL="0" indent="0" algn="l">
+              <ns5:buNone/>
+              <ns5:defRPr sz="2200">
+                <ns5:solidFill>
+                  <ns5:srgbClr val="000000"/>
+                </ns5:solidFill>
+                <ns5:latin typeface="Aptos"/>
+              </ns5:defRPr>
+            </ns5:lvl1pPr>
+          </ns5:lstStyle>
+          <ns6:p xmlns:ns6="http://schemas.openxmlformats.org/drawingml/2006/main">
+            <ns6:r>
+              <ns6:rPr lang="en-US"/>
+              <ns6:t>Body text.</ns6:t>
+            </ns6:r>
+            <ns6:endParaRPr lang="en-US"/>
+          </ns6:p>
+        </ns0:txBody>
+      </ns0:sp>
+      <ns0:sp xmlns:ns0="http://schemas.openxmlformats.org/presentationml/2006/main">
+        <ns0:nvSpPr>
+          <ns0:cNvPr id="13" name="Footer"/>
+          <ns0:cNvSpPr>
+            <ns1:spLocks xmlns:ns1="http://schemas.openxmlformats.org/drawingml/2006/main" noGrp="1"/>
+          </ns0:cNvSpPr>
+          <ns0:nvPr/>
+        </ns0:nvSpPr>
+        <ns0:spPr>
+          <ns2:xfrm xmlns:ns2="http://schemas.openxmlformats.org/drawingml/2006/main">
+            <ns2:off x="1143000" y="9982200"/>
+            <ns2:ext cx="16002000" cy="228600"/>
           </ns2:xfrm>
           <ns3:prstGeom xmlns:ns3="http://schemas.openxmlformats.org/drawingml/2006/main" prst="rect">
             <ns3:avLst/>
@@ -2848,6 +3063,7 @@
     <p:sldLayoutId id="2147483654" r:id="rId7"/>
     <p:sldLayoutId id="2147483655" r:id="rId8"/>
     <p:sldLayoutId id="2147483656" r:id="rId9"/>
+    <p:sldLayoutId id="2147483657" r:id="rId10"/>
   </p:sldLayoutIdLst>
   <p:txStyles>
     <p:titleStyle>
@@ -3184,7 +3400,7 @@
                   <a:srgbClr val="FFFFFF"/>
                 </a:solidFill>
               </a:rPr>
-              <a:t>Sovereign </a:t>
+              <a:t/>
             </a:r>
             <a:r>
               <a:rPr>
@@ -3203,7 +3419,7 @@
                   <a:lin ang="0" scaled="1"/>
                 </a:gradFill>
               </a:rPr>
-              <a:t>Clouds</a:t>
+              <a:t>Sovereign Clouds</a:t>
             </a:r>
           </a:p>
         </p:txBody>
@@ -3328,6 +3544,773 @@
       <p:grpSpPr/>
       <p:sp>
         <p:nvSpPr>
+          <p:cNvPr id="2" name="Text Placeholder 1"/>
+          <p:cNvSpPr>
+            <a:spLocks noGrp="1"/>
+          </p:cNvSpPr>
+          <p:nvPr>
+            <p:ph type="body" idx="1"/>
+          </p:nvPr>
+        </p:nvSpPr>
+        <p:spPr/>
+        <p:txBody>
+          <a:bodyPr/>
+          <a:lstStyle/>
+          <a:p>
+            <a:r>
+              <a:t>WHAT OCM UNLOCKS</a:t>
+            </a:r>
+          </a:p>
+        </p:txBody>
+      </p:sp>
+      <p:sp>
+        <p:nvSpPr>
+          <p:cNvPr id="3" name="Title 2"/>
+          <p:cNvSpPr>
+            <a:spLocks noGrp="1"/>
+          </p:cNvSpPr>
+          <p:nvPr>
+            <p:ph type="title" idx="2"/>
+          </p:nvPr>
+        </p:nvSpPr>
+        <p:spPr/>
+        <p:txBody>
+          <a:bodyPr/>
+          <a:lstStyle/>
+          <a:p>
+            <a:r>
+              <a:t>One model unlocks all of this.</a:t>
+            </a:r>
+          </a:p>
+        </p:txBody>
+      </p:sp>
+      <p:sp>
+        <p:nvSpPr>
+          <p:cNvPr id="4" name="Text Placeholder 3"/>
+          <p:cNvSpPr>
+            <a:spLocks noGrp="1"/>
+          </p:cNvSpPr>
+          <p:nvPr>
+            <p:ph type="body" idx="20"/>
+          </p:nvPr>
+        </p:nvSpPr>
+        <p:spPr/>
+        <p:txBody>
+          <a:bodyPr/>
+          <a:lstStyle/>
+          <a:p>
+            <a:r>
+              <a:t>Code signing across stacks</a:t>
+            </a:r>
+          </a:p>
+        </p:txBody>
+      </p:sp>
+      <p:sp>
+        <p:nvSpPr>
+          <p:cNvPr id="5" name="Text Placeholder 4"/>
+          <p:cNvSpPr>
+            <a:spLocks noGrp="1"/>
+          </p:cNvSpPr>
+          <p:nvPr>
+            <p:ph type="body" idx="21"/>
+          </p:nvPr>
+        </p:nvSpPr>
+        <p:spPr/>
+        <p:txBody>
+          <a:bodyPr/>
+          <a:lstStyle/>
+          <a:p>
+            <a:r>
+              <a:t>Sign once at source; verify everywhere, with no per-stack tooling.</a:t>
+            </a:r>
+          </a:p>
+        </p:txBody>
+      </p:sp>
+      <p:sp>
+        <p:nvSpPr>
+          <p:cNvPr id="6" name="Text Placeholder 5"/>
+          <p:cNvSpPr>
+            <a:spLocks noGrp="1"/>
+          </p:cNvSpPr>
+          <p:nvPr>
+            <p:ph type="body" idx="22"/>
+          </p:nvPr>
+        </p:nvSpPr>
+        <p:spPr/>
+        <p:txBody>
+          <a:bodyPr/>
+          <a:lstStyle/>
+          <a:p>
+            <a:r>
+              <a:t>Air-gapped delivery</a:t>
+            </a:r>
+          </a:p>
+        </p:txBody>
+      </p:sp>
+      <p:sp>
+        <p:nvSpPr>
+          <p:cNvPr id="7" name="Text Placeholder 6"/>
+          <p:cNvSpPr>
+            <a:spLocks noGrp="1"/>
+          </p:cNvSpPr>
+          <p:nvPr>
+            <p:ph type="body" idx="23"/>
+          </p:nvPr>
+        </p:nvSpPr>
+        <p:spPr/>
+        <p:txBody>
+          <a:bodyPr/>
+          <a:lstStyle/>
+          <a:p>
+            <a:r>
+              <a:t>Walk a complete component across an air gap; verify at destination.</a:t>
+            </a:r>
+          </a:p>
+        </p:txBody>
+      </p:sp>
+      <p:sp>
+        <p:nvSpPr>
+          <p:cNvPr id="8" name="Text Placeholder 7"/>
+          <p:cNvSpPr>
+            <a:spLocks noGrp="1"/>
+          </p:cNvSpPr>
+          <p:nvPr>
+            <p:ph type="body" idx="24"/>
+          </p:nvPr>
+        </p:nvSpPr>
+        <p:spPr/>
+        <p:txBody>
+          <a:bodyPr/>
+          <a:lstStyle/>
+          <a:p>
+            <a:r>
+              <a:t>Kubernetes-native deployment</a:t>
+            </a:r>
+          </a:p>
+        </p:txBody>
+      </p:sp>
+      <p:sp>
+        <p:nvSpPr>
+          <p:cNvPr id="9" name="Text Placeholder 8"/>
+          <p:cNvSpPr>
+            <a:spLocks noGrp="1"/>
+          </p:cNvSpPr>
+          <p:nvPr>
+            <p:ph type="body" idx="25"/>
+          </p:nvPr>
+        </p:nvSpPr>
+        <p:spPr/>
+        <p:txBody>
+          <a:bodyPr/>
+          <a:lstStyle/>
+          <a:p>
+            <a:r>
+              <a:t>OCM controllers deploy components directly into clusters.</a:t>
+            </a:r>
+          </a:p>
+        </p:txBody>
+      </p:sp>
+      <p:sp>
+        <p:nvSpPr>
+          <p:cNvPr id="10" name="Text Placeholder 9"/>
+          <p:cNvSpPr>
+            <a:spLocks noGrp="1"/>
+          </p:cNvSpPr>
+          <p:nvPr>
+            <p:ph type="body" idx="26"/>
+          </p:nvPr>
+        </p:nvSpPr>
+        <p:spPr/>
+        <p:txBody>
+          <a:bodyPr/>
+          <a:lstStyle/>
+          <a:p>
+            <a:r>
+              <a:t>Asynchronous security scans</a:t>
+            </a:r>
+          </a:p>
+        </p:txBody>
+      </p:sp>
+      <p:sp>
+        <p:nvSpPr>
+          <p:cNvPr id="11" name="Text Placeholder 10"/>
+          <p:cNvSpPr>
+            <a:spLocks noGrp="1"/>
+          </p:cNvSpPr>
+          <p:nvPr>
+            <p:ph type="body" idx="27"/>
+          </p:nvPr>
+        </p:nvSpPr>
+        <p:spPr/>
+        <p:txBody>
+          <a:bodyPr/>
+          <a:lstStyle/>
+          <a:p>
+            <a:r>
+              <a:t>Continuous scanning, even after release; findings tied to component identity.</a:t>
+            </a:r>
+          </a:p>
+        </p:txBody>
+      </p:sp>
+      <p:sp>
+        <p:nvSpPr>
+          <p:cNvPr id="12" name="Text Placeholder 11"/>
+          <p:cNvSpPr>
+            <a:spLocks noGrp="1"/>
+          </p:cNvSpPr>
+          <p:nvPr>
+            <p:ph type="body" idx="28"/>
+          </p:nvPr>
+        </p:nvSpPr>
+        <p:spPr/>
+        <p:txBody>
+          <a:bodyPr/>
+          <a:lstStyle/>
+          <a:p>
+            <a:r>
+              <a:t>One source of truth</a:t>
+            </a:r>
+          </a:p>
+        </p:txBody>
+      </p:sp>
+      <p:sp>
+        <p:nvSpPr>
+          <p:cNvPr id="13" name="Text Placeholder 12"/>
+          <p:cNvSpPr>
+            <a:spLocks noGrp="1"/>
+          </p:cNvSpPr>
+          <p:nvPr>
+            <p:ph type="body" idx="29"/>
+          </p:nvPr>
+        </p:nvSpPr>
+        <p:spPr/>
+        <p:txBody>
+          <a:bodyPr/>
+          <a:lstStyle/>
+          <a:p>
+            <a:r>
+              <a:t>Rebuild any landscape from a single signed descriptor.</a:t>
+            </a:r>
+          </a:p>
+        </p:txBody>
+      </p:sp>
+      <p:sp>
+        <p:nvSpPr>
+          <p:cNvPr id="14" name="Text Placeholder 13"/>
+          <p:cNvSpPr>
+            <a:spLocks noGrp="1"/>
+          </p:cNvSpPr>
+          <p:nvPr>
+            <p:ph type="body" idx="30"/>
+          </p:nvPr>
+        </p:nvSpPr>
+        <p:spPr/>
+        <p:txBody>
+          <a:bodyPr/>
+          <a:lstStyle/>
+          <a:p>
+            <a:r>
+              <a:t>Automated compliance reporting</a:t>
+            </a:r>
+          </a:p>
+        </p:txBody>
+      </p:sp>
+      <p:sp>
+        <p:nvSpPr>
+          <p:cNvPr id="15" name="Text Placeholder 14"/>
+          <p:cNvSpPr>
+            <a:spLocks noGrp="1"/>
+          </p:cNvSpPr>
+          <p:nvPr>
+            <p:ph type="body" idx="31"/>
+          </p:nvPr>
+        </p:nvSpPr>
+        <p:spPr/>
+        <p:txBody>
+          <a:bodyPr/>
+          <a:lstStyle/>
+          <a:p>
+            <a:r>
+              <a:t>Reports composed from SBoD metadata — no spreadsheet drift.</a:t>
+            </a:r>
+          </a:p>
+        </p:txBody>
+      </p:sp>
+      <p:pic>
+        <p:nvPicPr>
+          <p:cNvPr id="16" name="Picture 15" descr="lock_72.png"/>
+          <p:cNvPicPr>
+            <a:picLocks noChangeAspect="1"/>
+          </p:cNvPicPr>
+          <p:nvPr/>
+        </p:nvPicPr>
+        <p:blipFill>
+          <a:blip r:embed="rId2"/>
+          <a:stretch>
+            <a:fillRect/>
+          </a:stretch>
+        </p:blipFill>
+        <p:spPr>
+          <a:xfrm>
+            <a:off x="1371600" y="5181600"/>
+            <a:ext cx="381000" cy="381000"/>
+          </a:xfrm>
+          <a:prstGeom prst="rect">
+            <a:avLst/>
+          </a:prstGeom>
+        </p:spPr>
+      </p:pic>
+      <p:pic>
+        <p:nvPicPr>
+          <p:cNvPr id="17" name="Picture 16" descr="cloud-upload_72.png"/>
+          <p:cNvPicPr>
+            <a:picLocks noChangeAspect="1"/>
+          </p:cNvPicPr>
+          <p:nvPr/>
+        </p:nvPicPr>
+        <p:blipFill>
+          <a:blip r:embed="rId3"/>
+          <a:stretch>
+            <a:fillRect/>
+          </a:stretch>
+        </p:blipFill>
+        <p:spPr>
+          <a:xfrm>
+            <a:off x="6781800" y="5181600"/>
+            <a:ext cx="381000" cy="381000"/>
+          </a:xfrm>
+          <a:prstGeom prst="rect">
+            <a:avLst/>
+          </a:prstGeom>
+        </p:spPr>
+      </p:pic>
+      <p:pic>
+        <p:nvPicPr>
+          <p:cNvPr id="18" name="Picture 17" descr="rocket_72.png"/>
+          <p:cNvPicPr>
+            <a:picLocks noChangeAspect="1"/>
+          </p:cNvPicPr>
+          <p:nvPr/>
+        </p:nvPicPr>
+        <p:blipFill>
+          <a:blip r:embed="rId4"/>
+          <a:stretch>
+            <a:fillRect/>
+          </a:stretch>
+        </p:blipFill>
+        <p:spPr>
+          <a:xfrm>
+            <a:off x="12192000" y="5181600"/>
+            <a:ext cx="381000" cy="381000"/>
+          </a:xfrm>
+          <a:prstGeom prst="rect">
+            <a:avLst/>
+          </a:prstGeom>
+        </p:spPr>
+      </p:pic>
+      <p:pic>
+        <p:nvPicPr>
+          <p:cNvPr id="19" name="Picture 18" descr="radar_72.png"/>
+          <p:cNvPicPr>
+            <a:picLocks noChangeAspect="1"/>
+          </p:cNvPicPr>
+          <p:nvPr/>
+        </p:nvPicPr>
+        <p:blipFill>
+          <a:blip r:embed="rId5"/>
+          <a:stretch>
+            <a:fillRect/>
+          </a:stretch>
+        </p:blipFill>
+        <p:spPr>
+          <a:xfrm>
+            <a:off x="1371600" y="7600950"/>
+            <a:ext cx="381000" cy="381000"/>
+          </a:xfrm>
+          <a:prstGeom prst="rect">
+            <a:avLst/>
+          </a:prstGeom>
+        </p:spPr>
+      </p:pic>
+      <p:pic>
+        <p:nvPicPr>
+          <p:cNvPr id="20" name="Picture 19" descr="source-of-truth_72.png"/>
+          <p:cNvPicPr>
+            <a:picLocks noChangeAspect="1"/>
+          </p:cNvPicPr>
+          <p:nvPr/>
+        </p:nvPicPr>
+        <p:blipFill>
+          <a:blip r:embed="rId6"/>
+          <a:stretch>
+            <a:fillRect/>
+          </a:stretch>
+        </p:blipFill>
+        <p:spPr>
+          <a:xfrm>
+            <a:off x="6781800" y="7600950"/>
+            <a:ext cx="381000" cy="381000"/>
+          </a:xfrm>
+          <a:prstGeom prst="rect">
+            <a:avLst/>
+          </a:prstGeom>
+        </p:spPr>
+      </p:pic>
+      <p:pic>
+        <p:nvPicPr>
+          <p:cNvPr id="21" name="Picture 20" descr="report-analytics_72.png"/>
+          <p:cNvPicPr>
+            <a:picLocks noChangeAspect="1"/>
+          </p:cNvPicPr>
+          <p:nvPr/>
+        </p:nvPicPr>
+        <p:blipFill>
+          <a:blip r:embed="rId7"/>
+          <a:stretch>
+            <a:fillRect/>
+          </a:stretch>
+        </p:blipFill>
+        <p:spPr>
+          <a:xfrm>
+            <a:off x="12192000" y="7600950"/>
+            <a:ext cx="381000" cy="381000"/>
+          </a:xfrm>
+          <a:prstGeom prst="rect">
+            <a:avLst/>
+          </a:prstGeom>
+        </p:spPr>
+      </p:pic>
+    </p:spTree>
+  </p:cSld>
+  <p:clrMapOvr>
+    <a:masterClrMapping/>
+  </p:clrMapOvr>
+</p:sld>
+</file>
+
+<file path=ppt/slides/slide11.xml><?xml version="1.0" encoding="utf-8"?>
+<p:sld xmlns:a="http://schemas.openxmlformats.org/drawingml/2006/main" xmlns:p="http://schemas.openxmlformats.org/presentationml/2006/main" xmlns:r="http://schemas.openxmlformats.org/officeDocument/2006/relationships">
+  <p:cSld>
+    <p:spTree>
+      <p:nvGrpSpPr>
+        <p:cNvPr id="1" name=""/>
+        <p:cNvGrpSpPr/>
+        <p:nvPr/>
+      </p:nvGrpSpPr>
+      <p:grpSpPr/>
+      <p:sp>
+        <p:nvSpPr>
+          <p:cNvPr id="2" name="Text Placeholder 1"/>
+          <p:cNvSpPr>
+            <a:spLocks noGrp="1"/>
+          </p:cNvSpPr>
+          <p:nvPr>
+            <p:ph type="body" idx="1"/>
+          </p:nvPr>
+        </p:nvSpPr>
+        <p:spPr/>
+        <p:txBody>
+          <a:bodyPr/>
+          <a:lstStyle/>
+          <a:p>
+            <a:r>
+              <a:t>TRUSTED IN PRODUCTION</a:t>
+            </a:r>
+          </a:p>
+        </p:txBody>
+      </p:sp>
+      <p:sp>
+        <p:nvSpPr>
+          <p:cNvPr id="3" name="Title 2"/>
+          <p:cNvSpPr>
+            <a:spLocks noGrp="1"/>
+          </p:cNvSpPr>
+          <p:nvPr>
+            <p:ph type="title" idx="2"/>
+          </p:nvPr>
+        </p:nvSpPr>
+        <p:spPr/>
+        <p:txBody>
+          <a:bodyPr/>
+          <a:lstStyle/>
+          <a:p>
+            <a:r>
+              <a:t>Aligned with NeoNephos.</a:t>
+            </a:r>
+          </a:p>
+        </p:txBody>
+      </p:sp>
+      <p:sp>
+        <p:nvSpPr>
+          <p:cNvPr id="4" name="TextBox 3"/>
+          <p:cNvSpPr txBox="1"/>
+          <p:nvPr/>
+        </p:nvSpPr>
+        <p:spPr>
+          <a:xfrm>
+            <a:off x="1143000" y="4857750"/>
+            <a:ext cx="16002000" cy="342900"/>
+          </a:xfrm>
+          <a:prstGeom prst="rect">
+            <a:avLst/>
+          </a:prstGeom>
+          <a:noFill/>
+        </p:spPr>
+        <p:txBody>
+          <a:bodyPr wrap="none" lIns="0" rIns="0" tIns="0" bIns="0">
+            <a:spAutoFit/>
+          </a:bodyPr>
+          <a:lstStyle/>
+          <a:p>
+            <a:r>
+              <a:rPr sz="1800" b="1" cap="all" spc="110">
+                <a:solidFill>
+                  <a:srgbClr val="0F6BFF"/>
+                </a:solidFill>
+                <a:latin typeface="Aptos"/>
+              </a:rPr>
+              <a:t>ADOPTED BY ENTERPRISES SHIPPING INTO REGULATED ENVIRONMENTS</a:t>
+            </a:r>
+          </a:p>
+        </p:txBody>
+      </p:sp>
+      <p:pic>
+        <p:nvPicPr>
+          <p:cNvPr id="5" name="Picture 4" descr="sap-horizontal-color_640.png"/>
+          <p:cNvPicPr>
+            <a:picLocks noChangeAspect="1"/>
+          </p:cNvPicPr>
+          <p:nvPr/>
+        </p:nvPicPr>
+        <p:blipFill>
+          <a:blip r:embed="rId2"/>
+          <a:stretch>
+            <a:fillRect/>
+          </a:stretch>
+        </p:blipFill>
+        <p:spPr>
+          <a:xfrm>
+            <a:off x="3293201" y="5715000"/>
+            <a:ext cx="1538422" cy="762000"/>
+          </a:xfrm>
+          <a:prstGeom prst="rect">
+            <a:avLst/>
+          </a:prstGeom>
+        </p:spPr>
+      </p:pic>
+      <p:pic>
+        <p:nvPicPr>
+          <p:cNvPr id="6" name="Picture 5" descr="bwi-horizontal-color_640.png"/>
+          <p:cNvPicPr>
+            <a:picLocks noChangeAspect="1"/>
+          </p:cNvPicPr>
+          <p:nvPr/>
+        </p:nvPicPr>
+        <p:blipFill>
+          <a:blip r:embed="rId3"/>
+          <a:stretch>
+            <a:fillRect/>
+          </a:stretch>
+        </p:blipFill>
+        <p:spPr>
+          <a:xfrm>
+            <a:off x="8467502" y="5715000"/>
+            <a:ext cx="1343471" cy="762000"/>
+          </a:xfrm>
+          <a:prstGeom prst="rect">
+            <a:avLst/>
+          </a:prstGeom>
+        </p:spPr>
+      </p:pic>
+      <p:pic>
+        <p:nvPicPr>
+          <p:cNvPr id="7" name="Picture 6" descr="sap-ns2-getlogovector.png"/>
+          <p:cNvPicPr>
+            <a:picLocks noChangeAspect="1"/>
+          </p:cNvPicPr>
+          <p:nvPr/>
+        </p:nvPicPr>
+        <p:blipFill>
+          <a:blip r:embed="rId4"/>
+          <a:stretch>
+            <a:fillRect/>
+          </a:stretch>
+        </p:blipFill>
+        <p:spPr>
+          <a:xfrm>
+            <a:off x="13530262" y="5715000"/>
+            <a:ext cx="1371600" cy="762000"/>
+          </a:xfrm>
+          <a:prstGeom prst="rect">
+            <a:avLst/>
+          </a:prstGeom>
+        </p:spPr>
+      </p:pic>
+      <p:sp>
+        <p:nvSpPr>
+          <p:cNvPr id="8" name="TextBox 7"/>
+          <p:cNvSpPr txBox="1"/>
+          <p:nvPr/>
+        </p:nvSpPr>
+        <p:spPr>
+          <a:xfrm>
+            <a:off x="1143000" y="7048500"/>
+            <a:ext cx="16002000" cy="342900"/>
+          </a:xfrm>
+          <a:prstGeom prst="rect">
+            <a:avLst/>
+          </a:prstGeom>
+          <a:noFill/>
+        </p:spPr>
+        <p:txBody>
+          <a:bodyPr wrap="none" lIns="0" rIns="0" tIns="0" bIns="0">
+            <a:spAutoFit/>
+          </a:bodyPr>
+          <a:lstStyle/>
+          <a:p>
+            <a:r>
+              <a:rPr sz="1800" b="1" cap="all" spc="110">
+                <a:solidFill>
+                  <a:srgbClr val="0F6BFF"/>
+                </a:solidFill>
+                <a:latin typeface="Aptos"/>
+              </a:rPr>
+              <a:t>BUILT INTO THE OPEN-SOURCE ECOSYSTEM</a:t>
+            </a:r>
+          </a:p>
+        </p:txBody>
+      </p:sp>
+      <p:pic>
+        <p:nvPicPr>
+          <p:cNvPr id="9" name="Picture 8" descr="gardener-horizontal-color_640.png"/>
+          <p:cNvPicPr>
+            <a:picLocks noChangeAspect="1"/>
+          </p:cNvPicPr>
+          <p:nvPr/>
+        </p:nvPicPr>
+        <p:blipFill>
+          <a:blip r:embed="rId5"/>
+          <a:stretch>
+            <a:fillRect/>
+          </a:stretch>
+        </p:blipFill>
+        <p:spPr>
+          <a:xfrm>
+            <a:off x="2729953" y="7905750"/>
+            <a:ext cx="2664918" cy="762000"/>
+          </a:xfrm>
+          <a:prstGeom prst="rect">
+            <a:avLst/>
+          </a:prstGeom>
+        </p:spPr>
+      </p:pic>
+      <p:pic>
+        <p:nvPicPr>
+          <p:cNvPr id="10" name="Picture 9" descr="konfidence-horizontal-light_640.png"/>
+          <p:cNvPicPr>
+            <a:picLocks noChangeAspect="1"/>
+          </p:cNvPicPr>
+          <p:nvPr/>
+        </p:nvPicPr>
+        <p:blipFill>
+          <a:blip r:embed="rId6"/>
+          <a:stretch>
+            <a:fillRect/>
+          </a:stretch>
+        </p:blipFill>
+        <p:spPr>
+          <a:xfrm>
+            <a:off x="7615237" y="8108156"/>
+            <a:ext cx="3048000" cy="357187"/>
+          </a:xfrm>
+          <a:prstGeom prst="rect">
+            <a:avLst/>
+          </a:prstGeom>
+        </p:spPr>
+      </p:pic>
+      <p:pic>
+        <p:nvPicPr>
+          <p:cNvPr id="11" name="Picture 10" descr="platform-mesh-horizontal-color_640.png"/>
+          <p:cNvPicPr>
+            <a:picLocks noChangeAspect="1"/>
+          </p:cNvPicPr>
+          <p:nvPr/>
+        </p:nvPicPr>
+        <p:blipFill>
+          <a:blip r:embed="rId7"/>
+          <a:stretch>
+            <a:fillRect/>
+          </a:stretch>
+        </p:blipFill>
+        <p:spPr>
+          <a:xfrm>
+            <a:off x="12692062" y="7922419"/>
+            <a:ext cx="3048000" cy="728662"/>
+          </a:xfrm>
+          <a:prstGeom prst="rect">
+            <a:avLst/>
+          </a:prstGeom>
+        </p:spPr>
+      </p:pic>
+      <p:sp>
+        <p:nvSpPr>
+          <p:cNvPr id="12" name="TextBox 11"/>
+          <p:cNvSpPr txBox="1"/>
+          <p:nvPr/>
+        </p:nvSpPr>
+        <p:spPr>
+          <a:xfrm>
+            <a:off x="1143000" y="9239250"/>
+            <a:ext cx="16002000" cy="762000"/>
+          </a:xfrm>
+          <a:prstGeom prst="rect">
+            <a:avLst/>
+          </a:prstGeom>
+          <a:noFill/>
+        </p:spPr>
+        <p:txBody>
+          <a:bodyPr wrap="none" lIns="0" rIns="0" tIns="0" bIns="0">
+            <a:spAutoFit/>
+          </a:bodyPr>
+          <a:lstStyle/>
+          <a:p>
+            <a:pPr algn="ctr">
+              <a:lnSpc>
+                <a:spcPct val="140000"/>
+              </a:lnSpc>
+            </a:pPr>
+            <a:r>
+              <a:rPr sz="1800">
+                <a:solidFill>
+                  <a:srgbClr val="0A3A99"/>
+                </a:solidFill>
+                <a:latin typeface="Aptos"/>
+              </a:rPr>
+              <a:t>An open standard, neutrally governed — your stack stays portable, your dependencies stay yours.</a:t>
+            </a:r>
+          </a:p>
+        </p:txBody>
+      </p:sp>
+    </p:spTree>
+  </p:cSld>
+  <p:clrMapOvr>
+    <a:masterClrMapping/>
+  </p:clrMapOvr>
+</p:sld>
+</file>
+
+<file path=ppt/slides/slide12.xml><?xml version="1.0" encoding="utf-8"?>
+<p:sld xmlns:a="http://schemas.openxmlformats.org/drawingml/2006/main" xmlns:p="http://schemas.openxmlformats.org/presentationml/2006/main" xmlns:r="http://schemas.openxmlformats.org/officeDocument/2006/relationships">
+  <p:cSld>
+    <p:spTree>
+      <p:nvGrpSpPr>
+        <p:cNvPr id="1" name=""/>
+        <p:cNvGrpSpPr/>
+        <p:nvPr/>
+      </p:nvGrpSpPr>
+      <p:grpSpPr/>
+      <p:sp>
+        <p:nvSpPr>
           <p:cNvPr id="2" name="Title 1"/>
           <p:cNvSpPr>
             <a:spLocks noGrp="1"/>
@@ -3368,32 +4351,56 @@
           <a:lstStyle/>
           <a:p>
             <a:r>
+              <a:rPr b="1">
+                <a:solidFill>
+                  <a:srgbClr val="5CD6FF"/>
+                </a:solidFill>
+              </a:rPr>
+              <a:t>Try it</a:t>
+            </a:r>
+            <a:r>
               <a:rPr>
                 <a:solidFill>
                   <a:srgbClr val="FFFFFF"/>
                 </a:solidFill>
               </a:rPr>
-              <a:t>Try it — ocm.software</a:t>
-            </a:r>
-          </a:p>
-          <a:p>
+              <a:t> — ocm.software</a:t>
+            </a:r>
+          </a:p>
+          <a:p>
+            <a:r>
+              <a:rPr b="1">
+                <a:solidFill>
+                  <a:srgbClr val="5CD6FF"/>
+                </a:solidFill>
+              </a:rPr>
+              <a:t>Build with us</a:t>
+            </a:r>
             <a:r>
               <a:rPr>
                 <a:solidFill>
                   <a:srgbClr val="FFFFFF"/>
                 </a:solidFill>
               </a:rPr>
-              <a:t>Build with us — github.com/open-component-model</a:t>
-            </a:r>
-          </a:p>
-          <a:p>
+              <a:t> — github.com/open-component-model</a:t>
+            </a:r>
+          </a:p>
+          <a:p>
+            <a:r>
+              <a:rPr b="1">
+                <a:solidFill>
+                  <a:srgbClr val="5CD6FF"/>
+                </a:solidFill>
+              </a:rPr>
+              <a:t>Talk to us</a:t>
+            </a:r>
             <a:r>
               <a:rPr>
                 <a:solidFill>
                   <a:srgbClr val="FFFFFF"/>
                 </a:solidFill>
               </a:rPr>
-              <a:t>Talk to us — community channels on the website</a:t>
+              <a:t> — community channels on the website</a:t>
             </a:r>
           </a:p>
         </p:txBody>
@@ -3480,7 +4487,7 @@
           <a:lstStyle/>
           <a:p>
             <a:r>
-              <a:t>WHY NOW — V1 · SOVEREIGNTY-LED</a:t>
+              <a:t>WHY NOW</a:t>
             </a:r>
           </a:p>
         </p:txBody>
@@ -3697,21 +4704,9 @@
           </a:p>
         </p:txBody>
       </p:sp>
-      <p:sp>
-        <p:nvSpPr>
-          <p:cNvPr id="4" name="Picture Placeholder 3"/>
-          <p:cNvSpPr>
-            <a:spLocks noGrp="1"/>
-          </p:cNvSpPr>
-          <p:nvPr>
-            <p:ph type="pic" idx="10"/>
-          </p:nvPr>
-        </p:nvSpPr>
-        <p:spPr/>
-      </p:sp>
       <p:pic>
         <p:nvPicPr>
-          <p:cNvPr id="5" name="Picture 4" descr="03-fragmented_1760.png"/>
+          <p:cNvPr id="4" name="Picture 3" descr="03-fragmented_1680.png"/>
           <p:cNvPicPr>
             <a:picLocks noChangeAspect="1"/>
           </p:cNvPicPr>
@@ -3725,8 +4720,8 @@
         </p:blipFill>
         <p:spPr>
           <a:xfrm>
-            <a:off x="3265714" y="4191000"/>
-            <a:ext cx="11756571" cy="5143500"/>
+            <a:off x="3483429" y="4953000"/>
+            <a:ext cx="11321142" cy="4953000"/>
           </a:xfrm>
           <a:prstGeom prst="rect">
             <a:avLst/>
@@ -3808,63 +4803,85 @@
           <a:bodyPr/>
           <a:lstStyle/>
           <a:p>
-            <a:r>
+            <a:pPr>
+              <a:spcBef>
+                <a:spcPts val="800"/>
+              </a:spcBef>
+              <a:spcAft>
+                <a:spcPts val="800"/>
+              </a:spcAft>
+            </a:pPr>
+            <a:r>
+              <a:rPr b="1">
+                <a:solidFill>
+                  <a:srgbClr val="0F6BFF"/>
+                </a:solidFill>
+              </a:rPr>
+              <a:t>▪  </a:t>
+            </a:r>
+            <a:r>
+              <a:rPr>
+                <a:solidFill>
+                  <a:srgbClr val="000000"/>
+                </a:solidFill>
+              </a:rPr>
               <a:t>An SBOM tells you what's in your software. It was built for inventory.</a:t>
             </a:r>
           </a:p>
           <a:p>
-            <a:r>
+            <a:pPr>
+              <a:spcBef>
+                <a:spcPts val="800"/>
+              </a:spcBef>
+              <a:spcAft>
+                <a:spcPts val="800"/>
+              </a:spcAft>
+            </a:pPr>
+            <a:r>
+              <a:rPr b="1">
+                <a:solidFill>
+                  <a:srgbClr val="0F6BFF"/>
+                </a:solidFill>
+              </a:rPr>
+              <a:t>▪  </a:t>
+            </a:r>
+            <a:r>
+              <a:rPr>
+                <a:solidFill>
+                  <a:srgbClr val="000000"/>
+                </a:solidFill>
+              </a:rPr>
               <a:t>A Software Bill of Delivery (SBoD) tells you what you delivered, how to verify it, how to transport it, and how to operate it. It was built for delivery.</a:t>
             </a:r>
           </a:p>
           <a:p>
-            <a:r>
+            <a:pPr>
+              <a:spcBef>
+                <a:spcPts val="800"/>
+              </a:spcBef>
+              <a:spcAft>
+                <a:spcPts val="800"/>
+              </a:spcAft>
+            </a:pPr>
+            <a:r>
+              <a:rPr b="1">
+                <a:solidFill>
+                  <a:srgbClr val="0F6BFF"/>
+                </a:solidFill>
+              </a:rPr>
+              <a:t>▪  </a:t>
+            </a:r>
+            <a:r>
+              <a:rPr>
+                <a:solidFill>
+                  <a:srgbClr val="000000"/>
+                </a:solidFill>
+              </a:rPr>
               <a:t>The SBoD contains the SBOM. OCM doesn't replace your SBOM tooling — it gives the SBOM an envelope that's compliance-native, signed once, and travels intact across any boundary.</a:t>
             </a:r>
           </a:p>
         </p:txBody>
       </p:sp>
-      <p:sp>
-        <p:nvSpPr>
-          <p:cNvPr id="5" name="Text Placeholder 4"/>
-          <p:cNvSpPr>
-            <a:spLocks noGrp="1"/>
-          </p:cNvSpPr>
-          <p:nvPr>
-            <p:ph type="body" idx="11"/>
-          </p:nvPr>
-        </p:nvSpPr>
-        <p:spPr/>
-        <p:txBody>
-          <a:bodyPr/>
-          <a:lstStyle/>
-          <a:p/>
-        </p:txBody>
-      </p:sp>
-      <p:pic>
-        <p:nvPicPr>
-          <p:cNvPr id="6" name="Picture 5" descr="04-sbom-inside-sbod_860.png"/>
-          <p:cNvPicPr>
-            <a:picLocks noChangeAspect="1"/>
-          </p:cNvPicPr>
-          <p:nvPr/>
-        </p:nvPicPr>
-        <p:blipFill>
-          <a:blip r:embed="rId2"/>
-          <a:stretch>
-            <a:fillRect/>
-          </a:stretch>
-        </p:blipFill>
-        <p:spPr>
-          <a:xfrm>
-            <a:off x="9334500" y="3810000"/>
-            <a:ext cx="8191500" cy="3686175"/>
-          </a:xfrm>
-          <a:prstGeom prst="rect">
-            <a:avLst/>
-          </a:prstGeom>
-        </p:spPr>
-      </p:pic>
     </p:spTree>
   </p:cSld>
   <p:clrMapOvr>
@@ -3899,7 +4916,7 @@
           <a:lstStyle/>
           <a:p>
             <a:r>
-              <a:t>OCM IN ONE PICTURE</a:t>
+              <a:t>THE SHIFT — SBOM INSIDE SBoD</a:t>
             </a:r>
           </a:p>
         </p:txBody>
@@ -3920,26 +4937,14 @@
           <a:lstStyle/>
           <a:p>
             <a:r>
-              <a:t>Pack · Sign · Transport · Deploy</a:t>
+              <a:t>An envelope, not a list.</a:t>
             </a:r>
           </a:p>
         </p:txBody>
-      </p:sp>
-      <p:sp>
-        <p:nvSpPr>
-          <p:cNvPr id="4" name="Picture Placeholder 3"/>
-          <p:cNvSpPr>
-            <a:spLocks noGrp="1"/>
-          </p:cNvSpPr>
-          <p:nvPr>
-            <p:ph type="pic" idx="10"/>
-          </p:nvPr>
-        </p:nvSpPr>
-        <p:spPr/>
       </p:sp>
       <p:pic>
         <p:nvPicPr>
-          <p:cNvPr id="5" name="Picture 4" descr="05-pack-sign-transport-deploy-v2_1760.png"/>
+          <p:cNvPr id="4" name="Picture 3" descr="04-sbom-inside-sbod_1680.png"/>
           <p:cNvPicPr>
             <a:picLocks noChangeAspect="1"/>
           </p:cNvPicPr>
@@ -3953,8 +4958,8 @@
         </p:blipFill>
         <p:spPr>
           <a:xfrm>
-            <a:off x="762000" y="4191000"/>
-            <a:ext cx="16764000" cy="4714875"/>
+            <a:off x="3640667" y="4953000"/>
+            <a:ext cx="11006666" cy="4953000"/>
           </a:xfrm>
           <a:prstGeom prst="rect">
             <a:avLst/>
@@ -3995,7 +5000,7 @@
           <a:lstStyle/>
           <a:p>
             <a:r>
-              <a:t>SOVEREIGN-READY</a:t>
+              <a:t>OCM IN ONE PICTURE</a:t>
             </a:r>
           </a:p>
         </p:txBody>
@@ -4016,67 +5021,14 @@
           <a:lstStyle/>
           <a:p>
             <a:r>
-              <a:t>Trust, but verify.</a:t>
-            </a:r>
-          </a:p>
-        </p:txBody>
-      </p:sp>
-      <p:sp>
-        <p:nvSpPr>
-          <p:cNvPr id="4" name="Text Placeholder 3"/>
-          <p:cNvSpPr>
-            <a:spLocks noGrp="1"/>
-          </p:cNvSpPr>
-          <p:nvPr>
-            <p:ph type="body" idx="10"/>
-          </p:nvPr>
-        </p:nvSpPr>
-        <p:spPr/>
-        <p:txBody>
-          <a:bodyPr/>
-          <a:lstStyle/>
-          <a:p>
-            <a:r>
-              <a:t>• Identity is location-independent. A component carries its name regardless of which registry it lives in.</a:t>
-            </a:r>
-          </a:p>
-          <a:p>
-            <a:r>
-              <a:t>• Signatures are location-independent. Sign once at source; verify at the destination, or at any hop in between, with no callback upstream.</a:t>
-            </a:r>
-          </a:p>
-          <a:p>
-            <a:r>
-              <a:t>• Day-2 ops happen inside the boundary. Subscribe to the component and pull upgrades on your schedule, scale across regions, all without reaching back upstream.</a:t>
-            </a:r>
-          </a:p>
-          <a:p>
-            <a:r>
-              <a:t>• On transfer into a sovereign environment, a component can carry every artifact it needs along with it. The destination needs nothing more.</a:t>
-            </a:r>
-          </a:p>
-        </p:txBody>
-      </p:sp>
-      <p:sp>
-        <p:nvSpPr>
-          <p:cNvPr id="5" name="Text Placeholder 4"/>
-          <p:cNvSpPr>
-            <a:spLocks noGrp="1"/>
-          </p:cNvSpPr>
-          <p:nvPr>
-            <p:ph type="body" idx="11"/>
-          </p:nvPr>
-        </p:nvSpPr>
-        <p:spPr/>
-        <p:txBody>
-          <a:bodyPr/>
-          <a:lstStyle/>
-          <a:p/>
+              <a:t>Pack · Sign · Transport · Deploy</a:t>
+            </a:r>
+          </a:p>
         </p:txBody>
       </p:sp>
       <p:pic>
         <p:nvPicPr>
-          <p:cNvPr id="6" name="Picture 5" descr="06-sovereign-airgap_860.png"/>
+          <p:cNvPr id="4" name="Picture 3" descr="05-pack-sign-transport-deploy-v2_1680.png"/>
           <p:cNvPicPr>
             <a:picLocks noChangeAspect="1"/>
           </p:cNvPicPr>
@@ -4090,8 +5042,8 @@
         </p:blipFill>
         <p:spPr>
           <a:xfrm>
-            <a:off x="9334500" y="3810000"/>
-            <a:ext cx="8191500" cy="3590925"/>
+            <a:off x="1143000" y="4953000"/>
+            <a:ext cx="16002000" cy="4505325"/>
           </a:xfrm>
           <a:prstGeom prst="rect">
             <a:avLst/>
@@ -4132,7 +5084,7 @@
           <a:lstStyle/>
           <a:p>
             <a:r>
-              <a:t>SCAN — COMPLIANCE-NATIVE WITH OPEN DELIVERY GEAR</a:t>
+              <a:t>SOVEREIGN-READY</a:t>
             </a:r>
           </a:p>
         </p:txBody>
@@ -4153,12 +5105,7 @@
           <a:lstStyle/>
           <a:p>
             <a:r>
-              <a:t>Compliance as a system property —</a:t>
-            </a:r>
-          </a:p>
-          <a:p>
-            <a:r>
-              <a:t>not a quarterly project.</a:t>
+              <a:t>Trust, but verify.</a:t>
             </a:r>
           </a:p>
         </p:txBody>
@@ -4178,28 +5125,107 @@
           <a:bodyPr/>
           <a:lstStyle/>
           <a:p>
-            <a:r>
-              <a:t>• Open Delivery Gear (ODG) is OCM's compliance automation engine.</a:t>
-            </a:r>
-          </a:p>
-          <a:p>
-            <a:r>
-              <a:t>• The Compliance Dashboard is your entry point: every component, every finding, every signature in one view.</a:t>
-            </a:r>
-          </a:p>
-          <a:p>
-            <a:r>
-              <a:t>• Continuous scans run asynchronously — even after release.</a:t>
-            </a:r>
-          </a:p>
-          <a:p>
-            <a:r>
-              <a:t>• Findings get rescored against contextual risk, so your team patches what actually matters.</a:t>
-            </a:r>
-          </a:p>
-          <a:p>
-            <a:r>
-              <a:t>• Every compliance signal correlates by component identity. Auditors get evidence, not spreadsheets.</a:t>
+            <a:pPr>
+              <a:spcBef>
+                <a:spcPts val="800"/>
+              </a:spcBef>
+              <a:spcAft>
+                <a:spcPts val="800"/>
+              </a:spcAft>
+            </a:pPr>
+            <a:r>
+              <a:rPr b="1">
+                <a:solidFill>
+                  <a:srgbClr val="0F6BFF"/>
+                </a:solidFill>
+              </a:rPr>
+              <a:t>▪  </a:t>
+            </a:r>
+            <a:r>
+              <a:rPr>
+                <a:solidFill>
+                  <a:srgbClr val="000000"/>
+                </a:solidFill>
+              </a:rPr>
+              <a:t>Identity is location-independent. A component carries its name regardless of which registry it lives in.</a:t>
+            </a:r>
+          </a:p>
+          <a:p>
+            <a:pPr>
+              <a:spcBef>
+                <a:spcPts val="800"/>
+              </a:spcBef>
+              <a:spcAft>
+                <a:spcPts val="800"/>
+              </a:spcAft>
+            </a:pPr>
+            <a:r>
+              <a:rPr b="1">
+                <a:solidFill>
+                  <a:srgbClr val="0F6BFF"/>
+                </a:solidFill>
+              </a:rPr>
+              <a:t>▪  </a:t>
+            </a:r>
+            <a:r>
+              <a:rPr>
+                <a:solidFill>
+                  <a:srgbClr val="000000"/>
+                </a:solidFill>
+              </a:rPr>
+              <a:t>Signatures are location-independent. Sign once at source; verify at the destination, or at any hop in between, with no callback upstream.</a:t>
+            </a:r>
+          </a:p>
+          <a:p>
+            <a:pPr>
+              <a:spcBef>
+                <a:spcPts val="800"/>
+              </a:spcBef>
+              <a:spcAft>
+                <a:spcPts val="800"/>
+              </a:spcAft>
+            </a:pPr>
+            <a:r>
+              <a:rPr b="1">
+                <a:solidFill>
+                  <a:srgbClr val="0F6BFF"/>
+                </a:solidFill>
+              </a:rPr>
+              <a:t>▪  </a:t>
+            </a:r>
+            <a:r>
+              <a:rPr>
+                <a:solidFill>
+                  <a:srgbClr val="000000"/>
+                </a:solidFill>
+              </a:rPr>
+              <a:t>Day-2 ops happen inside the boundary. Subscribe to the component and pull upgrades on your schedule, scale across regions, all without reaching back upstream.</a:t>
+            </a:r>
+          </a:p>
+          <a:p>
+            <a:pPr>
+              <a:spcBef>
+                <a:spcPts val="800"/>
+              </a:spcBef>
+              <a:spcAft>
+                <a:spcPts val="800"/>
+              </a:spcAft>
+            </a:pPr>
+            <a:r>
+              <a:rPr b="1">
+                <a:solidFill>
+                  <a:srgbClr val="0F6BFF"/>
+                </a:solidFill>
+              </a:rPr>
+              <a:t>▪  </a:t>
+            </a:r>
+            <a:r>
+              <a:rPr>
+                <a:solidFill>
+                  <a:srgbClr val="000000"/>
+                </a:solidFill>
+              </a:rPr>
+              <a:t>On transfer into a sovereign environment, a component can carry every artifact it needs along with it. The destination needs nothing more.</a:t>
             </a:r>
           </a:p>
         </p:txBody>
@@ -4238,7 +5264,7 @@
           <a:lstStyle/>
           <a:p>
             <a:r>
-              <a:t>WHAT OCM UNLOCKS</a:t>
+              <a:t>SOVEREIGN-READY — AIR-GAP</a:t>
             </a:r>
           </a:p>
         </p:txBody>
@@ -4259,266 +5285,14 @@
           <a:lstStyle/>
           <a:p>
             <a:r>
-              <a:t>One model unlocks all of this.</a:t>
-            </a:r>
-          </a:p>
-        </p:txBody>
-      </p:sp>
-      <p:sp>
-        <p:nvSpPr>
-          <p:cNvPr id="4" name="Text Placeholder 3"/>
-          <p:cNvSpPr>
-            <a:spLocks noGrp="1"/>
-          </p:cNvSpPr>
-          <p:nvPr>
-            <p:ph type="body" idx="20"/>
-          </p:nvPr>
-        </p:nvSpPr>
-        <p:spPr/>
-        <p:txBody>
-          <a:bodyPr/>
-          <a:lstStyle/>
-          <a:p>
-            <a:r>
-              <a:t>Code signing across stacks</a:t>
-            </a:r>
-          </a:p>
-        </p:txBody>
-      </p:sp>
-      <p:sp>
-        <p:nvSpPr>
-          <p:cNvPr id="5" name="Text Placeholder 4"/>
-          <p:cNvSpPr>
-            <a:spLocks noGrp="1"/>
-          </p:cNvSpPr>
-          <p:nvPr>
-            <p:ph type="body" idx="21"/>
-          </p:nvPr>
-        </p:nvSpPr>
-        <p:spPr/>
-        <p:txBody>
-          <a:bodyPr/>
-          <a:lstStyle/>
-          <a:p>
-            <a:r>
-              <a:t>Sign once at source; verify everywhere, with no per-stack tooling.</a:t>
-            </a:r>
-          </a:p>
-        </p:txBody>
-      </p:sp>
-      <p:sp>
-        <p:nvSpPr>
-          <p:cNvPr id="6" name="Text Placeholder 5"/>
-          <p:cNvSpPr>
-            <a:spLocks noGrp="1"/>
-          </p:cNvSpPr>
-          <p:nvPr>
-            <p:ph type="body" idx="22"/>
-          </p:nvPr>
-        </p:nvSpPr>
-        <p:spPr/>
-        <p:txBody>
-          <a:bodyPr/>
-          <a:lstStyle/>
-          <a:p>
-            <a:r>
-              <a:t>Air-gapped delivery</a:t>
-            </a:r>
-          </a:p>
-        </p:txBody>
-      </p:sp>
-      <p:sp>
-        <p:nvSpPr>
-          <p:cNvPr id="7" name="Text Placeholder 6"/>
-          <p:cNvSpPr>
-            <a:spLocks noGrp="1"/>
-          </p:cNvSpPr>
-          <p:nvPr>
-            <p:ph type="body" idx="23"/>
-          </p:nvPr>
-        </p:nvSpPr>
-        <p:spPr/>
-        <p:txBody>
-          <a:bodyPr/>
-          <a:lstStyle/>
-          <a:p>
-            <a:r>
-              <a:t>Walk a complete component across an air gap; verify at destination.</a:t>
-            </a:r>
-          </a:p>
-        </p:txBody>
-      </p:sp>
-      <p:sp>
-        <p:nvSpPr>
-          <p:cNvPr id="8" name="Text Placeholder 7"/>
-          <p:cNvSpPr>
-            <a:spLocks noGrp="1"/>
-          </p:cNvSpPr>
-          <p:nvPr>
-            <p:ph type="body" idx="24"/>
-          </p:nvPr>
-        </p:nvSpPr>
-        <p:spPr/>
-        <p:txBody>
-          <a:bodyPr/>
-          <a:lstStyle/>
-          <a:p>
-            <a:r>
-              <a:t>Kubernetes-native deployment</a:t>
-            </a:r>
-          </a:p>
-        </p:txBody>
-      </p:sp>
-      <p:sp>
-        <p:nvSpPr>
-          <p:cNvPr id="9" name="Text Placeholder 8"/>
-          <p:cNvSpPr>
-            <a:spLocks noGrp="1"/>
-          </p:cNvSpPr>
-          <p:nvPr>
-            <p:ph type="body" idx="25"/>
-          </p:nvPr>
-        </p:nvSpPr>
-        <p:spPr/>
-        <p:txBody>
-          <a:bodyPr/>
-          <a:lstStyle/>
-          <a:p>
-            <a:r>
-              <a:t>OCM controllers deploy components directly into clusters.</a:t>
-            </a:r>
-          </a:p>
-        </p:txBody>
-      </p:sp>
-      <p:sp>
-        <p:nvSpPr>
-          <p:cNvPr id="10" name="Text Placeholder 9"/>
-          <p:cNvSpPr>
-            <a:spLocks noGrp="1"/>
-          </p:cNvSpPr>
-          <p:nvPr>
-            <p:ph type="body" idx="26"/>
-          </p:nvPr>
-        </p:nvSpPr>
-        <p:spPr/>
-        <p:txBody>
-          <a:bodyPr/>
-          <a:lstStyle/>
-          <a:p>
-            <a:r>
-              <a:t>Asynchronous security scans</a:t>
-            </a:r>
-          </a:p>
-        </p:txBody>
-      </p:sp>
-      <p:sp>
-        <p:nvSpPr>
-          <p:cNvPr id="11" name="Text Placeholder 10"/>
-          <p:cNvSpPr>
-            <a:spLocks noGrp="1"/>
-          </p:cNvSpPr>
-          <p:nvPr>
-            <p:ph type="body" idx="27"/>
-          </p:nvPr>
-        </p:nvSpPr>
-        <p:spPr/>
-        <p:txBody>
-          <a:bodyPr/>
-          <a:lstStyle/>
-          <a:p>
-            <a:r>
-              <a:t>Continuous scanning, even after release; findings tied to component identity.</a:t>
-            </a:r>
-          </a:p>
-        </p:txBody>
-      </p:sp>
-      <p:sp>
-        <p:nvSpPr>
-          <p:cNvPr id="12" name="Text Placeholder 11"/>
-          <p:cNvSpPr>
-            <a:spLocks noGrp="1"/>
-          </p:cNvSpPr>
-          <p:nvPr>
-            <p:ph type="body" idx="28"/>
-          </p:nvPr>
-        </p:nvSpPr>
-        <p:spPr/>
-        <p:txBody>
-          <a:bodyPr/>
-          <a:lstStyle/>
-          <a:p>
-            <a:r>
-              <a:t>One source of truth</a:t>
-            </a:r>
-          </a:p>
-        </p:txBody>
-      </p:sp>
-      <p:sp>
-        <p:nvSpPr>
-          <p:cNvPr id="13" name="Text Placeholder 12"/>
-          <p:cNvSpPr>
-            <a:spLocks noGrp="1"/>
-          </p:cNvSpPr>
-          <p:nvPr>
-            <p:ph type="body" idx="29"/>
-          </p:nvPr>
-        </p:nvSpPr>
-        <p:spPr/>
-        <p:txBody>
-          <a:bodyPr/>
-          <a:lstStyle/>
-          <a:p>
-            <a:r>
-              <a:t>Rebuild any landscape from a single signed descriptor.</a:t>
-            </a:r>
-          </a:p>
-        </p:txBody>
-      </p:sp>
-      <p:sp>
-        <p:nvSpPr>
-          <p:cNvPr id="14" name="Text Placeholder 13"/>
-          <p:cNvSpPr>
-            <a:spLocks noGrp="1"/>
-          </p:cNvSpPr>
-          <p:nvPr>
-            <p:ph type="body" idx="30"/>
-          </p:nvPr>
-        </p:nvSpPr>
-        <p:spPr/>
-        <p:txBody>
-          <a:bodyPr/>
-          <a:lstStyle/>
-          <a:p>
-            <a:r>
-              <a:t>Automated compliance reporting</a:t>
-            </a:r>
-          </a:p>
-        </p:txBody>
-      </p:sp>
-      <p:sp>
-        <p:nvSpPr>
-          <p:cNvPr id="15" name="Text Placeholder 14"/>
-          <p:cNvSpPr>
-            <a:spLocks noGrp="1"/>
-          </p:cNvSpPr>
-          <p:nvPr>
-            <p:ph type="body" idx="31"/>
-          </p:nvPr>
-        </p:nvSpPr>
-        <p:spPr/>
-        <p:txBody>
-          <a:bodyPr/>
-          <a:lstStyle/>
-          <a:p>
-            <a:r>
-              <a:t>Reports composed from SBoD metadata — no spreadsheet drift.</a:t>
+              <a:t>Trust travels with the component.</a:t>
             </a:r>
           </a:p>
         </p:txBody>
       </p:sp>
       <p:pic>
         <p:nvPicPr>
-          <p:cNvPr id="16" name="Picture 15" descr="lock_72.png"/>
+          <p:cNvPr id="4" name="Picture 3" descr="06-sovereign-airgap_1680.png"/>
           <p:cNvPicPr>
             <a:picLocks noChangeAspect="1"/>
           </p:cNvPicPr>
@@ -4532,128 +5306,8 @@
         </p:blipFill>
         <p:spPr>
           <a:xfrm>
-            <a:off x="990600" y="4038600"/>
-            <a:ext cx="381000" cy="381000"/>
-          </a:xfrm>
-          <a:prstGeom prst="rect">
-            <a:avLst/>
-          </a:prstGeom>
-        </p:spPr>
-      </p:pic>
-      <p:pic>
-        <p:nvPicPr>
-          <p:cNvPr id="17" name="Picture 16" descr="cloud-upload_72.png"/>
-          <p:cNvPicPr>
-            <a:picLocks noChangeAspect="1"/>
-          </p:cNvPicPr>
-          <p:nvPr/>
-        </p:nvPicPr>
-        <p:blipFill>
-          <a:blip r:embed="rId3"/>
-          <a:stretch>
-            <a:fillRect/>
-          </a:stretch>
-        </p:blipFill>
-        <p:spPr>
-          <a:xfrm>
-            <a:off x="6648450" y="4038600"/>
-            <a:ext cx="381000" cy="381000"/>
-          </a:xfrm>
-          <a:prstGeom prst="rect">
-            <a:avLst/>
-          </a:prstGeom>
-        </p:spPr>
-      </p:pic>
-      <p:pic>
-        <p:nvPicPr>
-          <p:cNvPr id="18" name="Picture 17" descr="rocket_72.png"/>
-          <p:cNvPicPr>
-            <a:picLocks noChangeAspect="1"/>
-          </p:cNvPicPr>
-          <p:nvPr/>
-        </p:nvPicPr>
-        <p:blipFill>
-          <a:blip r:embed="rId4"/>
-          <a:stretch>
-            <a:fillRect/>
-          </a:stretch>
-        </p:blipFill>
-        <p:spPr>
-          <a:xfrm>
-            <a:off x="12306300" y="4038600"/>
-            <a:ext cx="381000" cy="381000"/>
-          </a:xfrm>
-          <a:prstGeom prst="rect">
-            <a:avLst/>
-          </a:prstGeom>
-        </p:spPr>
-      </p:pic>
-      <p:pic>
-        <p:nvPicPr>
-          <p:cNvPr id="19" name="Picture 18" descr="radar_72.png"/>
-          <p:cNvPicPr>
-            <a:picLocks noChangeAspect="1"/>
-          </p:cNvPicPr>
-          <p:nvPr/>
-        </p:nvPicPr>
-        <p:blipFill>
-          <a:blip r:embed="rId5"/>
-          <a:stretch>
-            <a:fillRect/>
-          </a:stretch>
-        </p:blipFill>
-        <p:spPr>
-          <a:xfrm>
-            <a:off x="990600" y="6838950"/>
-            <a:ext cx="381000" cy="381000"/>
-          </a:xfrm>
-          <a:prstGeom prst="rect">
-            <a:avLst/>
-          </a:prstGeom>
-        </p:spPr>
-      </p:pic>
-      <p:pic>
-        <p:nvPicPr>
-          <p:cNvPr id="20" name="Picture 19" descr="source-of-truth_72.png"/>
-          <p:cNvPicPr>
-            <a:picLocks noChangeAspect="1"/>
-          </p:cNvPicPr>
-          <p:nvPr/>
-        </p:nvPicPr>
-        <p:blipFill>
-          <a:blip r:embed="rId6"/>
-          <a:stretch>
-            <a:fillRect/>
-          </a:stretch>
-        </p:blipFill>
-        <p:spPr>
-          <a:xfrm>
-            <a:off x="6648450" y="6838950"/>
-            <a:ext cx="381000" cy="381000"/>
-          </a:xfrm>
-          <a:prstGeom prst="rect">
-            <a:avLst/>
-          </a:prstGeom>
-        </p:spPr>
-      </p:pic>
-      <p:pic>
-        <p:nvPicPr>
-          <p:cNvPr id="21" name="Picture 20" descr="report-analytics_72.png"/>
-          <p:cNvPicPr>
-            <a:picLocks noChangeAspect="1"/>
-          </p:cNvPicPr>
-          <p:nvPr/>
-        </p:nvPicPr>
-        <p:blipFill>
-          <a:blip r:embed="rId7"/>
-          <a:stretch>
-            <a:fillRect/>
-          </a:stretch>
-        </p:blipFill>
-        <p:spPr>
-          <a:xfrm>
-            <a:off x="12306300" y="6838950"/>
-            <a:ext cx="381000" cy="381000"/>
+            <a:off x="3483429" y="4953000"/>
+            <a:ext cx="11321142" cy="4953000"/>
           </a:xfrm>
           <a:prstGeom prst="rect">
             <a:avLst/>
@@ -4694,7 +5348,7 @@
           <a:lstStyle/>
           <a:p>
             <a:r>
-              <a:t>TRUSTED IN PRODUCTION</a:t>
+              <a:t>SCAN — COMPLIANCE-NATIVE WITH OPEN DELIVERY GEAR</a:t>
             </a:r>
           </a:p>
         </p:txBody>
@@ -4715,7 +5369,12 @@
           <a:lstStyle/>
           <a:p>
             <a:r>
-              <a:t>Aligned with NeoNephos.</a:t>
+              <a:t>Compliance as a system property —</a:t>
+            </a:r>
+          </a:p>
+          <a:p>
+            <a:r>
+              <a:t>not a quarterly project.</a:t>
             </a:r>
           </a:p>
         </p:txBody>
@@ -4735,259 +5394,133 @@
           <a:bodyPr/>
           <a:lstStyle/>
           <a:p>
-            <a:r>
-              <a:t/>
-            </a:r>
-          </a:p>
-        </p:txBody>
-      </p:sp>
-      <p:sp>
-        <p:nvSpPr>
-          <p:cNvPr id="5" name="TextBox 4"/>
-          <p:cNvSpPr txBox="1"/>
-          <p:nvPr/>
-        </p:nvSpPr>
-        <p:spPr>
-          <a:xfrm>
-            <a:off x="762000" y="3619500"/>
-            <a:ext cx="16764000" cy="266700"/>
-          </a:xfrm>
-          <a:prstGeom prst="rect">
-            <a:avLst/>
-          </a:prstGeom>
-          <a:noFill/>
-        </p:spPr>
-        <p:txBody>
-          <a:bodyPr wrap="none" lIns="0" rIns="0" tIns="0" bIns="0">
-            <a:spAutoFit/>
-          </a:bodyPr>
-          <a:lstStyle/>
-          <a:p>
-            <a:r>
-              <a:rPr sz="1400" b="1" cap="all" spc="110">
+            <a:pPr>
+              <a:spcBef>
+                <a:spcPts val="800"/>
+              </a:spcBef>
+              <a:spcAft>
+                <a:spcPts val="800"/>
+              </a:spcAft>
+            </a:pPr>
+            <a:r>
+              <a:rPr b="1">
                 <a:solidFill>
                   <a:srgbClr val="0F6BFF"/>
                 </a:solidFill>
-                <a:latin typeface="Aptos"/>
               </a:rPr>
-              <a:t>ADOPTED BY ENTERPRISES SHIPPING INTO REGULATED ENVIRONMENTS</a:t>
-            </a:r>
-          </a:p>
-        </p:txBody>
-      </p:sp>
-      <p:pic>
-        <p:nvPicPr>
-          <p:cNvPr id="6" name="Picture 5" descr="sap-horizontal-color_640.png"/>
-          <p:cNvPicPr>
-            <a:picLocks noChangeAspect="1"/>
-          </p:cNvPicPr>
-          <p:nvPr/>
-        </p:nvPicPr>
-        <p:blipFill>
-          <a:blip r:embed="rId2"/>
-          <a:stretch>
-            <a:fillRect/>
-          </a:stretch>
-        </p:blipFill>
-        <p:spPr>
-          <a:xfrm>
-            <a:off x="3100898" y="4095750"/>
-            <a:ext cx="1923029" cy="952500"/>
-          </a:xfrm>
-          <a:prstGeom prst="rect">
-            <a:avLst/>
-          </a:prstGeom>
-        </p:spPr>
-      </p:pic>
-      <p:pic>
-        <p:nvPicPr>
-          <p:cNvPr id="7" name="Picture 6" descr="bwi-horizontal-color_640.png"/>
-          <p:cNvPicPr>
-            <a:picLocks noChangeAspect="1"/>
-          </p:cNvPicPr>
-          <p:nvPr/>
-        </p:nvPicPr>
-        <p:blipFill>
-          <a:blip r:embed="rId3"/>
-          <a:stretch>
-            <a:fillRect/>
-          </a:stretch>
-        </p:blipFill>
-        <p:spPr>
-          <a:xfrm>
-            <a:off x="8299568" y="4095750"/>
-            <a:ext cx="1679338" cy="952500"/>
-          </a:xfrm>
-          <a:prstGeom prst="rect">
-            <a:avLst/>
-          </a:prstGeom>
-        </p:spPr>
-      </p:pic>
-      <p:pic>
-        <p:nvPicPr>
-          <p:cNvPr id="8" name="Picture 7" descr="sap-ns2-getlogovector.png"/>
-          <p:cNvPicPr>
-            <a:picLocks noChangeAspect="1"/>
-          </p:cNvPicPr>
-          <p:nvPr/>
-        </p:nvPicPr>
-        <p:blipFill>
-          <a:blip r:embed="rId4"/>
-          <a:stretch>
-            <a:fillRect/>
-          </a:stretch>
-        </p:blipFill>
-        <p:spPr>
-          <a:xfrm>
-            <a:off x="13358812" y="4095750"/>
-            <a:ext cx="1714500" cy="952500"/>
-          </a:xfrm>
-          <a:prstGeom prst="rect">
-            <a:avLst/>
-          </a:prstGeom>
-        </p:spPr>
-      </p:pic>
-      <p:sp>
-        <p:nvSpPr>
-          <p:cNvPr id="9" name="TextBox 8"/>
-          <p:cNvSpPr txBox="1"/>
-          <p:nvPr/>
-        </p:nvSpPr>
-        <p:spPr>
-          <a:xfrm>
-            <a:off x="762000" y="5905500"/>
-            <a:ext cx="16764000" cy="266700"/>
-          </a:xfrm>
-          <a:prstGeom prst="rect">
-            <a:avLst/>
-          </a:prstGeom>
-          <a:noFill/>
-        </p:spPr>
-        <p:txBody>
-          <a:bodyPr wrap="none" lIns="0" rIns="0" tIns="0" bIns="0">
-            <a:spAutoFit/>
-          </a:bodyPr>
-          <a:lstStyle/>
-          <a:p>
-            <a:r>
-              <a:rPr sz="1400" b="1" cap="all" spc="110">
+              <a:t>▪  </a:t>
+            </a:r>
+            <a:r>
+              <a:rPr>
+                <a:solidFill>
+                  <a:srgbClr val="000000"/>
+                </a:solidFill>
+              </a:rPr>
+              <a:t>Open Delivery Gear (ODG) is OCM's compliance automation engine.</a:t>
+            </a:r>
+          </a:p>
+          <a:p>
+            <a:pPr>
+              <a:spcBef>
+                <a:spcPts val="800"/>
+              </a:spcBef>
+              <a:spcAft>
+                <a:spcPts val="800"/>
+              </a:spcAft>
+            </a:pPr>
+            <a:r>
+              <a:rPr b="1">
                 <a:solidFill>
                   <a:srgbClr val="0F6BFF"/>
                 </a:solidFill>
-                <a:latin typeface="Aptos"/>
               </a:rPr>
-              <a:t>BUILT INTO THE OPEN-SOURCE ECOSYSTEM</a:t>
-            </a:r>
-          </a:p>
-        </p:txBody>
-      </p:sp>
-      <p:pic>
-        <p:nvPicPr>
-          <p:cNvPr id="10" name="Picture 9" descr="gardener-horizontal-color_640.png"/>
-          <p:cNvPicPr>
-            <a:picLocks noChangeAspect="1"/>
-          </p:cNvPicPr>
-          <p:nvPr/>
-        </p:nvPicPr>
-        <p:blipFill>
-          <a:blip r:embed="rId5"/>
-          <a:stretch>
-            <a:fillRect/>
-          </a:stretch>
-        </p:blipFill>
-        <p:spPr>
-          <a:xfrm>
-            <a:off x="2538412" y="6422231"/>
-            <a:ext cx="3048000" cy="871538"/>
-          </a:xfrm>
-          <a:prstGeom prst="rect">
-            <a:avLst/>
-          </a:prstGeom>
-        </p:spPr>
-      </p:pic>
-      <p:pic>
-        <p:nvPicPr>
-          <p:cNvPr id="11" name="Picture 10" descr="konfidence-horizontal-light_640.png"/>
-          <p:cNvPicPr>
-            <a:picLocks noChangeAspect="1"/>
-          </p:cNvPicPr>
-          <p:nvPr/>
-        </p:nvPicPr>
-        <p:blipFill>
-          <a:blip r:embed="rId6"/>
-          <a:stretch>
-            <a:fillRect/>
-          </a:stretch>
-        </p:blipFill>
-        <p:spPr>
-          <a:xfrm>
-            <a:off x="7615237" y="6679406"/>
-            <a:ext cx="3048000" cy="357188"/>
-          </a:xfrm>
-          <a:prstGeom prst="rect">
-            <a:avLst/>
-          </a:prstGeom>
-        </p:spPr>
-      </p:pic>
-      <p:pic>
-        <p:nvPicPr>
-          <p:cNvPr id="12" name="Picture 11" descr="platform-mesh-horizontal-color_640.png"/>
-          <p:cNvPicPr>
-            <a:picLocks noChangeAspect="1"/>
-          </p:cNvPicPr>
-          <p:nvPr/>
-        </p:nvPicPr>
-        <p:blipFill>
-          <a:blip r:embed="rId7"/>
-          <a:stretch>
-            <a:fillRect/>
-          </a:stretch>
-        </p:blipFill>
-        <p:spPr>
-          <a:xfrm>
-            <a:off x="12692062" y="6493669"/>
-            <a:ext cx="3048000" cy="728662"/>
-          </a:xfrm>
-          <a:prstGeom prst="rect">
-            <a:avLst/>
-          </a:prstGeom>
-        </p:spPr>
-      </p:pic>
-      <p:sp>
-        <p:nvSpPr>
-          <p:cNvPr id="13" name="TextBox 12"/>
-          <p:cNvSpPr txBox="1"/>
-          <p:nvPr/>
-        </p:nvSpPr>
-        <p:spPr>
-          <a:xfrm>
-            <a:off x="762000" y="8191500"/>
-            <a:ext cx="16764000" cy="762000"/>
-          </a:xfrm>
-          <a:prstGeom prst="rect">
-            <a:avLst/>
-          </a:prstGeom>
-          <a:noFill/>
-        </p:spPr>
-        <p:txBody>
-          <a:bodyPr wrap="none" lIns="0" rIns="0" tIns="0" bIns="0">
-            <a:spAutoFit/>
-          </a:bodyPr>
-          <a:lstStyle/>
-          <a:p>
-            <a:pPr algn="ctr">
-              <a:lnSpc>
-                <a:spcPct val="140000"/>
-              </a:lnSpc>
+              <a:t>▪  </a:t>
+            </a:r>
+            <a:r>
+              <a:rPr>
+                <a:solidFill>
+                  <a:srgbClr val="000000"/>
+                </a:solidFill>
+              </a:rPr>
+              <a:t>The Compliance Dashboard is your entry point: every component, every finding, every signature in one view.</a:t>
+            </a:r>
+          </a:p>
+          <a:p>
+            <a:pPr>
+              <a:spcBef>
+                <a:spcPts val="800"/>
+              </a:spcBef>
+              <a:spcAft>
+                <a:spcPts val="800"/>
+              </a:spcAft>
             </a:pPr>
             <a:r>
-              <a:rPr sz="1800">
+              <a:rPr b="1">
                 <a:solidFill>
-                  <a:srgbClr val="0A3A99"/>
+                  <a:srgbClr val="0F6BFF"/>
                 </a:solidFill>
-                <a:latin typeface="Aptos"/>
               </a:rPr>
-              <a:t>An open standard, neutrally governed — your stack stays portable, your dependencies stay yours.</a:t>
+              <a:t>▪  </a:t>
+            </a:r>
+            <a:r>
+              <a:rPr>
+                <a:solidFill>
+                  <a:srgbClr val="000000"/>
+                </a:solidFill>
+              </a:rPr>
+              <a:t>Continuous scans run asynchronously — even after release.</a:t>
+            </a:r>
+          </a:p>
+          <a:p>
+            <a:pPr>
+              <a:spcBef>
+                <a:spcPts val="800"/>
+              </a:spcBef>
+              <a:spcAft>
+                <a:spcPts val="800"/>
+              </a:spcAft>
+            </a:pPr>
+            <a:r>
+              <a:rPr b="1">
+                <a:solidFill>
+                  <a:srgbClr val="0F6BFF"/>
+                </a:solidFill>
+              </a:rPr>
+              <a:t>▪  </a:t>
+            </a:r>
+            <a:r>
+              <a:rPr>
+                <a:solidFill>
+                  <a:srgbClr val="000000"/>
+                </a:solidFill>
+              </a:rPr>
+              <a:t>Findings get rescored against contextual risk, so your team patches what actually matters.</a:t>
+            </a:r>
+          </a:p>
+          <a:p>
+            <a:pPr>
+              <a:spcBef>
+                <a:spcPts val="800"/>
+              </a:spcBef>
+              <a:spcAft>
+                <a:spcPts val="800"/>
+              </a:spcAft>
+            </a:pPr>
+            <a:r>
+              <a:rPr b="1">
+                <a:solidFill>
+                  <a:srgbClr val="0F6BFF"/>
+                </a:solidFill>
+              </a:rPr>
+              <a:t>▪  </a:t>
+            </a:r>
+            <a:r>
+              <a:rPr>
+                <a:solidFill>
+                  <a:srgbClr val="000000"/>
+                </a:solidFill>
+              </a:rPr>
+              <a:t>Every compliance signal correlates by component identity. Auditors get evidence, not spreadsheets.</a:t>
             </a:r>
           </a:p>
         </p:txBody>

</xml_diff>

<commit_message>
create first final decks and new narratives. restructure folder
Signed-off-by: Gerald Morrison (SAP) <gerald.morrison@sap.com>
</commit_message>
<xml_diff>
--- a/docs/community/marketing/decks/exec-phase1/OCM-Sovereign-Delivery-Exec.pptx
+++ b/docs/community/marketing/decks/exec-phase1/OCM-Sovereign-Delivery-Exec.pptx
@@ -17,6 +17,7 @@
     <p:sldId id="265" r:id="rId16"/>
     <p:sldId id="266" r:id="rId17"/>
     <p:sldId id="267" r:id="rId18"/>
+    <p:sldId id="268" r:id="rId19"/>
   </p:sldIdLst>
   <p:sldSz cx="18288000" cy="10287000"/>
   <p:notesSz cx="6858000" cy="9144000"/>
@@ -155,7 +156,7 @@
         </ns0:nvSpPr>
         <ns0:spPr>
           <ns2:xfrm xmlns:ns2="http://schemas.openxmlformats.org/drawingml/2006/main">
-            <ns2:off x="914400" y="1590675"/>
+            <ns2:off x="914400" y="1524000"/>
             <ns2:ext cx="16192500" cy="1905000"/>
           </ns2:xfrm>
           <ns3:prstGeom xmlns:ns3="http://schemas.openxmlformats.org/drawingml/2006/main" prst="rect">
@@ -163,7 +164,9 @@
           </ns3:prstGeom>
         </ns0:spPr>
         <ns0:txBody>
-          <ns4:bodyPr xmlns:ns4="http://schemas.openxmlformats.org/drawingml/2006/main" wrap="square" rtlCol="0" anchor="t" lIns="0" tIns="0" rIns="0" bIns="0"/>
+          <ns4:bodyPr xmlns:ns4="http://schemas.openxmlformats.org/drawingml/2006/main" wrap="square" rtlCol="0" anchor="t" lIns="0" tIns="0" rIns="0" bIns="0">
+            <ns4:noAutofit/>
+          </ns4:bodyPr>
           <ns5:lstStyle xmlns:ns5="http://schemas.openxmlformats.org/drawingml/2006/main">
             <ns5:lvl1pPr marL="0" indent="0" algn="l">
               <ns5:buNone/>
@@ -196,15 +199,17 @@
         </ns0:nvSpPr>
         <ns0:spPr>
           <ns2:xfrm xmlns:ns2="http://schemas.openxmlformats.org/drawingml/2006/main">
-            <ns2:off x="914400" y="3067050"/>
-            <ns2:ext cx="16192500" cy="1905000"/>
+            <ns2:off x="914400" y="3619500"/>
+            <ns2:ext cx="16192500" cy="1524000"/>
           </ns2:xfrm>
           <ns3:prstGeom xmlns:ns3="http://schemas.openxmlformats.org/drawingml/2006/main" prst="rect">
             <ns3:avLst/>
           </ns3:prstGeom>
         </ns0:spPr>
         <ns0:txBody>
-          <ns4:bodyPr xmlns:ns4="http://schemas.openxmlformats.org/drawingml/2006/main" wrap="square" rtlCol="0" anchor="t" lIns="0" tIns="0" rIns="0" bIns="0"/>
+          <ns4:bodyPr xmlns:ns4="http://schemas.openxmlformats.org/drawingml/2006/main" wrap="square" rtlCol="0" anchor="t" lIns="0" tIns="0" rIns="0" bIns="0">
+            <ns4:noAutofit/>
+          </ns4:bodyPr>
           <ns5:lstStyle xmlns:ns5="http://schemas.openxmlformats.org/drawingml/2006/main">
             <ns5:lvl1pPr marL="0" indent="0" algn="l">
               <ns5:buNone/>
@@ -237,19 +242,24 @@
         </ns0:nvSpPr>
         <ns0:spPr>
           <ns2:xfrm xmlns:ns2="http://schemas.openxmlformats.org/drawingml/2006/main">
-            <ns2:off x="914400" y="5257800"/>
-            <ns2:ext cx="16192500" cy="571500"/>
+            <ns2:off x="914400" y="5715000"/>
+            <ns2:ext cx="16192500" cy="1143000"/>
           </ns2:xfrm>
           <ns3:prstGeom xmlns:ns3="http://schemas.openxmlformats.org/drawingml/2006/main" prst="rect">
             <ns3:avLst/>
           </ns3:prstGeom>
         </ns0:spPr>
         <ns0:txBody>
-          <ns4:bodyPr xmlns:ns4="http://schemas.openxmlformats.org/drawingml/2006/main" wrap="square" rtlCol="0" anchor="t" lIns="0" tIns="0" rIns="0" bIns="0"/>
+          <ns4:bodyPr xmlns:ns4="http://schemas.openxmlformats.org/drawingml/2006/main" wrap="square" rtlCol="0" anchor="t" lIns="0" tIns="0" rIns="0" bIns="0">
+            <ns4:noAutofit/>
+          </ns4:bodyPr>
           <ns5:lstStyle xmlns:ns5="http://schemas.openxmlformats.org/drawingml/2006/main">
             <ns5:lvl1pPr marL="0" indent="0" algn="l">
+              <ns5:lnSpc>
+                <ns5:spcPct val="114999"/>
+              </ns5:lnSpc>
               <ns5:buNone/>
-              <ns5:defRPr sz="3600">
+              <ns5:defRPr sz="3000">
                 <ns5:solidFill>
                   <ns5:srgbClr val="5CD6FF"/>
                 </ns5:solidFill>
@@ -278,19 +288,21 @@
         </ns0:nvSpPr>
         <ns0:spPr>
           <ns2:xfrm xmlns:ns2="http://schemas.openxmlformats.org/drawingml/2006/main">
-            <ns2:off x="914400" y="6067425"/>
-            <ns2:ext cx="16192500" cy="476250"/>
+            <ns2:off x="914400" y="8191500"/>
+            <ns2:ext cx="16192500" cy="571500"/>
           </ns2:xfrm>
           <ns3:prstGeom xmlns:ns3="http://schemas.openxmlformats.org/drawingml/2006/main" prst="rect">
             <ns3:avLst/>
           </ns3:prstGeom>
         </ns0:spPr>
         <ns0:txBody>
-          <ns4:bodyPr xmlns:ns4="http://schemas.openxmlformats.org/drawingml/2006/main" wrap="square" rtlCol="0" anchor="t" lIns="0" tIns="0" rIns="0" bIns="0"/>
+          <ns4:bodyPr xmlns:ns4="http://schemas.openxmlformats.org/drawingml/2006/main" wrap="square" rtlCol="0" anchor="t" lIns="0" tIns="0" rIns="0" bIns="0">
+            <ns4:noAutofit/>
+          </ns4:bodyPr>
           <ns5:lstStyle xmlns:ns5="http://schemas.openxmlformats.org/drawingml/2006/main">
             <ns5:lvl1pPr marL="0" indent="0" algn="l">
               <ns5:buNone/>
-              <ns5:defRPr sz="2800">
+              <ns5:defRPr sz="2400">
                 <ns5:solidFill>
                   <ns5:srgbClr val="FFFFFF"/>
                 </ns5:solidFill>
@@ -315,7 +327,456 @@
 </p:sldLayout>
 </file>
 
+<file path=ppt/slideLayouts/slideLayout10.xml><?xml version="1.0" encoding="utf-8"?>
+<p:sldLayout xmlns:a="http://schemas.openxmlformats.org/drawingml/2006/main" xmlns:r="http://schemas.openxmlformats.org/officeDocument/2006/relationships" xmlns:p="http://schemas.openxmlformats.org/presentationml/2006/main" type="obj" preserve="1" userDrawn="1">
+  <p:cSld name="Plain / Compact">
+    <p:bg>
+      <p:bgPr>
+        <a:solidFill>
+          <a:srgbClr val="FFFFFF"/>
+        </a:solidFill>
+        <a:effectLst/>
+      </p:bgPr>
+    </p:bg>
+    <p:spTree>
+      <p:nvGrpSpPr>
+        <p:cNvPr id="1" name=""/>
+        <p:cNvGrpSpPr/>
+        <p:nvPr/>
+      </p:nvGrpSpPr>
+      <p:grpSpPr>
+        <a:xfrm>
+          <a:off x="0" y="0"/>
+          <a:ext cx="0" cy="0"/>
+          <a:chOff x="0" y="0"/>
+          <a:chExt cx="0" cy="0"/>
+        </a:xfrm>
+      </p:grpSpPr>
+      <ns0:sp xmlns:ns0="http://schemas.openxmlformats.org/presentationml/2006/main">
+        <ns0:nvSpPr>
+          <ns0:cNvPr id="10" name="Eyebrow"/>
+          <ns0:cNvSpPr>
+            <ns1:spLocks xmlns:ns1="http://schemas.openxmlformats.org/drawingml/2006/main" noGrp="1"/>
+          </ns0:cNvSpPr>
+          <ns0:nvPr>
+            <ns0:ph type="body" idx="1"/>
+          </ns0:nvPr>
+        </ns0:nvSpPr>
+        <ns0:spPr>
+          <ns2:xfrm xmlns:ns2="http://schemas.openxmlformats.org/drawingml/2006/main">
+            <ns2:off x="1143000" y="2428875"/>
+            <ns2:ext cx="16002000" cy="457200"/>
+          </ns2:xfrm>
+          <ns3:prstGeom xmlns:ns3="http://schemas.openxmlformats.org/drawingml/2006/main" prst="rect">
+            <ns3:avLst/>
+          </ns3:prstGeom>
+        </ns0:spPr>
+        <ns0:txBody>
+          <ns4:bodyPr xmlns:ns4="http://schemas.openxmlformats.org/drawingml/2006/main" wrap="square" rtlCol="0" anchor="t" lIns="0" tIns="0" rIns="0" bIns="0"/>
+          <ns5:lstStyle xmlns:ns5="http://schemas.openxmlformats.org/drawingml/2006/main">
+            <ns5:lvl1pPr marL="0" indent="0" algn="l">
+              <ns5:buNone/>
+              <ns5:defRPr sz="2800" b="1" cap="all" spc="140">
+                <ns5:solidFill>
+                  <ns5:srgbClr val="0F6BFF"/>
+                </ns5:solidFill>
+                <ns5:latin typeface="Aptos"/>
+              </ns5:defRPr>
+            </ns5:lvl1pPr>
+          </ns5:lstStyle>
+          <ns6:p xmlns:ns6="http://schemas.openxmlformats.org/drawingml/2006/main">
+            <ns6:r>
+              <ns6:rPr lang="en-US"/>
+              <ns6:t>EYEBROW</ns6:t>
+            </ns6:r>
+            <ns6:endParaRPr lang="en-US"/>
+          </ns6:p>
+        </ns0:txBody>
+      </ns0:sp>
+      <ns0:sp xmlns:ns0="http://schemas.openxmlformats.org/presentationml/2006/main">
+        <ns0:nvSpPr>
+          <ns0:cNvPr id="11" name="Title"/>
+          <ns0:cNvSpPr>
+            <ns1:spLocks xmlns:ns1="http://schemas.openxmlformats.org/drawingml/2006/main" noGrp="1"/>
+          </ns0:cNvSpPr>
+          <ns0:nvPr>
+            <ns0:ph type="title" idx="2"/>
+          </ns0:nvPr>
+        </ns0:nvSpPr>
+        <ns0:spPr>
+          <ns2:xfrm xmlns:ns2="http://schemas.openxmlformats.org/drawingml/2006/main">
+            <ns2:off x="1143000" y="2933700"/>
+            <ns2:ext cx="16002000" cy="1905000"/>
+          </ns2:xfrm>
+          <ns3:prstGeom xmlns:ns3="http://schemas.openxmlformats.org/drawingml/2006/main" prst="rect">
+            <ns3:avLst/>
+          </ns3:prstGeom>
+        </ns0:spPr>
+        <ns0:txBody>
+          <ns4:bodyPr xmlns:ns4="http://schemas.openxmlformats.org/drawingml/2006/main" wrap="square" rtlCol="0" anchor="t" lIns="0" tIns="0" rIns="0" bIns="0"/>
+          <ns5:lstStyle xmlns:ns5="http://schemas.openxmlformats.org/drawingml/2006/main">
+            <ns5:lvl1pPr marL="0" indent="0" algn="l">
+              <ns5:lnSpc>
+                <ns5:spcPct val="90000"/>
+              </ns5:lnSpc>
+              <ns5:buNone/>
+              <ns5:defRPr sz="6400" b="1">
+                <ns5:solidFill>
+                  <ns5:srgbClr val="000000"/>
+                </ns5:solidFill>
+                <ns5:latin typeface="Aptos Display"/>
+              </ns5:defRPr>
+            </ns5:lvl1pPr>
+          </ns5:lstStyle>
+          <ns6:p xmlns:ns6="http://schemas.openxmlformats.org/drawingml/2006/main">
+            <ns6:r>
+              <ns6:rPr lang="en-US"/>
+              <ns6:t>Section title goes here.</ns6:t>
+            </ns6:r>
+            <ns6:endParaRPr lang="en-US"/>
+          </ns6:p>
+        </ns0:txBody>
+      </ns0:sp>
+      <ns0:sp xmlns:ns0="http://schemas.openxmlformats.org/presentationml/2006/main">
+        <ns0:nvSpPr>
+          <ns0:cNvPr id="12" name="Body"/>
+          <ns0:cNvSpPr>
+            <ns1:spLocks xmlns:ns1="http://schemas.openxmlformats.org/drawingml/2006/main" noGrp="1"/>
+          </ns0:cNvSpPr>
+          <ns0:nvPr>
+            <ns0:ph type="body" idx="10"/>
+          </ns0:nvPr>
+        </ns0:nvSpPr>
+        <ns0:spPr>
+          <ns2:xfrm xmlns:ns2="http://schemas.openxmlformats.org/drawingml/2006/main">
+            <ns2:off x="1143000" y="4953000"/>
+            <ns2:ext cx="16002000" cy="4381500"/>
+          </ns2:xfrm>
+          <ns3:prstGeom xmlns:ns3="http://schemas.openxmlformats.org/drawingml/2006/main" prst="rect">
+            <ns3:avLst/>
+          </ns3:prstGeom>
+        </ns0:spPr>
+        <ns0:txBody>
+          <ns4:bodyPr xmlns:ns4="http://schemas.openxmlformats.org/drawingml/2006/main" wrap="square" rtlCol="0" anchor="t" lIns="0" tIns="0" rIns="0" bIns="0"/>
+          <ns5:lstStyle xmlns:ns5="http://schemas.openxmlformats.org/drawingml/2006/main">
+            <ns5:lvl1pPr marL="0" indent="0" algn="l">
+              <ns5:buNone/>
+              <ns5:defRPr sz="2200">
+                <ns5:solidFill>
+                  <ns5:srgbClr val="000000"/>
+                </ns5:solidFill>
+                <ns5:latin typeface="Aptos"/>
+              </ns5:defRPr>
+            </ns5:lvl1pPr>
+          </ns5:lstStyle>
+          <ns6:p xmlns:ns6="http://schemas.openxmlformats.org/drawingml/2006/main">
+            <ns6:r>
+              <ns6:rPr lang="en-US"/>
+              <ns6:t>Body text.</ns6:t>
+            </ns6:r>
+            <ns6:endParaRPr lang="en-US"/>
+          </ns6:p>
+        </ns0:txBody>
+      </ns0:sp>
+      <ns0:sp xmlns:ns0="http://schemas.openxmlformats.org/presentationml/2006/main">
+        <ns0:nvSpPr>
+          <ns0:cNvPr id="13" name="Footer"/>
+          <ns0:cNvSpPr>
+            <ns1:spLocks xmlns:ns1="http://schemas.openxmlformats.org/drawingml/2006/main" noGrp="1"/>
+          </ns0:cNvSpPr>
+          <ns0:nvPr/>
+        </ns0:nvSpPr>
+        <ns0:spPr>
+          <ns2:xfrm xmlns:ns2="http://schemas.openxmlformats.org/drawingml/2006/main">
+            <ns2:off x="1143000" y="9982200"/>
+            <ns2:ext cx="16002000" cy="228600"/>
+          </ns2:xfrm>
+          <ns3:prstGeom xmlns:ns3="http://schemas.openxmlformats.org/drawingml/2006/main" prst="rect">
+            <ns3:avLst/>
+          </ns3:prstGeom>
+        </ns0:spPr>
+        <ns0:txBody>
+          <ns4:bodyPr xmlns:ns4="http://schemas.openxmlformats.org/drawingml/2006/main" wrap="square" rtlCol="0" anchor="t" lIns="0" tIns="0" rIns="0" bIns="0"/>
+          <ns5:lstStyle xmlns:ns5="http://schemas.openxmlformats.org/drawingml/2006/main">
+            <ns5:lvl1pPr marL="0" indent="0" algn="l">
+              <ns5:buNone/>
+              <ns5:defRPr sz="900" cap="all" spc="50">
+                <ns5:solidFill>
+                  <ns5:srgbClr val="6B7280"/>
+                </ns5:solidFill>
+                <ns5:latin typeface="Aptos"/>
+              </ns5:defRPr>
+            </ns5:lvl1pPr>
+          </ns5:lstStyle>
+          <ns6:p xmlns:ns6="http://schemas.openxmlformats.org/drawingml/2006/main">
+            <ns6:r>
+              <ns6:rPr lang="en-US"/>
+              <ns6:t>OPEN COMPONENT MODEL · OCM.SOFTWARE</ns6:t>
+            </ns6:r>
+            <ns6:endParaRPr lang="en-US"/>
+          </ns6:p>
+        </ns0:txBody>
+      </ns0:sp>
+    </p:spTree>
+  </p:cSld>
+  <p:clrMapOvr>
+    <a:masterClrMapping/>
+  </p:clrMapOvr>
+</p:sldLayout>
+</file>
+
 <file path=ppt/slideLayouts/slideLayout2.xml><?xml version="1.0" encoding="utf-8"?>
+<p:sldLayout xmlns:a="http://schemas.openxmlformats.org/drawingml/2006/main" xmlns:r="http://schemas.openxmlformats.org/officeDocument/2006/relationships" xmlns:p="http://schemas.openxmlformats.org/presentationml/2006/main" type="title" preserve="1" userDrawn="1">
+  <p:cSld name="Hero / 3-Line">
+    <p:bg>
+      <p:bgPr>
+        <a:solidFill>
+          <a:srgbClr val="0A1530"/>
+        </a:solidFill>
+        <a:effectLst/>
+      </p:bgPr>
+    </p:bg>
+    <p:spTree>
+      <p:nvGrpSpPr>
+        <p:cNvPr id="1" name=""/>
+        <p:cNvGrpSpPr/>
+        <p:nvPr/>
+      </p:nvGrpSpPr>
+      <p:grpSpPr>
+        <a:xfrm>
+          <a:off x="0" y="0"/>
+          <a:ext cx="0" cy="0"/>
+          <a:chOff x="0" y="0"/>
+          <a:chExt cx="0" cy="0"/>
+        </a:xfrm>
+      </p:grpSpPr>
+      <ns0:sp xmlns:ns0="http://schemas.openxmlformats.org/presentationml/2006/main">
+        <ns0:nvSpPr>
+          <ns0:cNvPr id="10" name="Hero Title Line 1"/>
+          <ns0:cNvSpPr>
+            <ns1:spLocks xmlns:ns1="http://schemas.openxmlformats.org/drawingml/2006/main" noGrp="1"/>
+          </ns0:cNvSpPr>
+          <ns0:nvPr>
+            <ns0:ph type="title" idx="1"/>
+          </ns0:nvPr>
+        </ns0:nvSpPr>
+        <ns0:spPr>
+          <ns2:xfrm xmlns:ns2="http://schemas.openxmlformats.org/drawingml/2006/main">
+            <ns2:off x="914400" y="1143000"/>
+            <ns2:ext cx="16192500" cy="1333500"/>
+          </ns2:xfrm>
+          <ns3:prstGeom xmlns:ns3="http://schemas.openxmlformats.org/drawingml/2006/main" prst="rect">
+            <ns3:avLst/>
+          </ns3:prstGeom>
+        </ns0:spPr>
+        <ns0:txBody>
+          <ns4:bodyPr xmlns:ns4="http://schemas.openxmlformats.org/drawingml/2006/main" wrap="square" rtlCol="0" anchor="t" lIns="0" tIns="0" rIns="0" bIns="0">
+            <ns4:noAutofit/>
+          </ns4:bodyPr>
+          <ns5:lstStyle xmlns:ns5="http://schemas.openxmlformats.org/drawingml/2006/main">
+            <ns5:lvl1pPr marL="0" indent="0" algn="l">
+              <ns5:buNone/>
+              <ns5:defRPr sz="11500" b="1">
+                <ns5:solidFill>
+                  <ns5:srgbClr val="FFFFFF"/>
+                </ns5:solidFill>
+                <ns5:latin typeface="Aptos Display"/>
+              </ns5:defRPr>
+            </ns5:lvl1pPr>
+          </ns5:lstStyle>
+          <ns6:p xmlns:ns6="http://schemas.openxmlformats.org/drawingml/2006/main">
+            <ns6:r>
+              <ns6:rPr lang="en-US"/>
+              <ns6:t>Three minutes from now,</ns6:t>
+            </ns6:r>
+            <ns6:endParaRPr lang="en-US"/>
+          </ns6:p>
+        </ns0:txBody>
+      </ns0:sp>
+      <ns0:sp xmlns:ns0="http://schemas.openxmlformats.org/presentationml/2006/main">
+        <ns0:nvSpPr>
+          <ns0:cNvPr id="11" name="Hero Title Line 2"/>
+          <ns0:cNvSpPr>
+            <ns1:spLocks xmlns:ns1="http://schemas.openxmlformats.org/drawingml/2006/main" noGrp="1"/>
+          </ns0:cNvSpPr>
+          <ns0:nvPr>
+            <ns0:ph type="body" idx="2"/>
+          </ns0:nvPr>
+        </ns0:nvSpPr>
+        <ns0:spPr>
+          <ns2:xfrm xmlns:ns2="http://schemas.openxmlformats.org/drawingml/2006/main">
+            <ns2:off x="914400" y="2571750"/>
+            <ns2:ext cx="16192500" cy="1333500"/>
+          </ns2:xfrm>
+          <ns3:prstGeom xmlns:ns3="http://schemas.openxmlformats.org/drawingml/2006/main" prst="rect">
+            <ns3:avLst/>
+          </ns3:prstGeom>
+        </ns0:spPr>
+        <ns0:txBody>
+          <ns4:bodyPr xmlns:ns4="http://schemas.openxmlformats.org/drawingml/2006/main" wrap="square" rtlCol="0" anchor="t" lIns="0" tIns="0" rIns="0" bIns="0">
+            <ns4:noAutofit/>
+          </ns4:bodyPr>
+          <ns5:lstStyle xmlns:ns5="http://schemas.openxmlformats.org/drawingml/2006/main">
+            <ns5:lvl1pPr marL="0" indent="0" algn="l">
+              <ns5:buNone/>
+              <ns5:defRPr sz="11500" b="1">
+                <ns5:solidFill>
+                  <ns5:srgbClr val="FFFFFF"/>
+                </ns5:solidFill>
+                <ns5:latin typeface="Aptos Display"/>
+              </ns5:defRPr>
+            </ns5:lvl1pPr>
+          </ns5:lstStyle>
+          <ns6:p xmlns:ns6="http://schemas.openxmlformats.org/drawingml/2006/main">
+            <ns6:r>
+              <ns6:rPr lang="en-US"/>
+              <ns6:t>you'll know what your</ns6:t>
+            </ns6:r>
+            <ns6:endParaRPr lang="en-US"/>
+          </ns6:p>
+        </ns0:txBody>
+      </ns0:sp>
+      <ns0:sp xmlns:ns0="http://schemas.openxmlformats.org/presentationml/2006/main">
+        <ns0:nvSpPr>
+          <ns0:cNvPr id="12" name="Hero Title Line 3 (Gradient)"/>
+          <ns0:cNvSpPr>
+            <ns1:spLocks xmlns:ns1="http://schemas.openxmlformats.org/drawingml/2006/main" noGrp="1"/>
+          </ns0:cNvSpPr>
+          <ns0:nvPr>
+            <ns0:ph type="body" idx="3"/>
+          </ns0:nvPr>
+        </ns0:nvSpPr>
+        <ns0:spPr>
+          <ns2:xfrm xmlns:ns2="http://schemas.openxmlformats.org/drawingml/2006/main">
+            <ns2:off x="914400" y="4000500"/>
+            <ns2:ext cx="16192500" cy="1333500"/>
+          </ns2:xfrm>
+          <ns3:prstGeom xmlns:ns3="http://schemas.openxmlformats.org/drawingml/2006/main" prst="rect">
+            <ns3:avLst/>
+          </ns3:prstGeom>
+        </ns0:spPr>
+        <ns0:txBody>
+          <ns4:bodyPr xmlns:ns4="http://schemas.openxmlformats.org/drawingml/2006/main" wrap="square" rtlCol="0" anchor="t" lIns="0" tIns="0" rIns="0" bIns="0">
+            <ns4:noAutofit/>
+          </ns4:bodyPr>
+          <ns5:lstStyle xmlns:ns5="http://schemas.openxmlformats.org/drawingml/2006/main">
+            <ns5:lvl1pPr marL="0" indent="0" algn="l">
+              <ns5:buNone/>
+              <ns5:defRPr sz="11500" b="1">
+                <ns5:solidFill>
+                  <ns5:srgbClr val="5CD6FF"/>
+                </ns5:solidFill>
+                <ns5:latin typeface="Aptos Display"/>
+              </ns5:defRPr>
+            </ns5:lvl1pPr>
+          </ns5:lstStyle>
+          <ns6:p xmlns:ns6="http://schemas.openxmlformats.org/drawingml/2006/main">
+            <ns6:r>
+              <ns6:rPr lang="en-US"/>
+              <ns6:t>supply chain doesn't</ns6:t>
+            </ns6:r>
+            <ns6:endParaRPr lang="en-US"/>
+          </ns6:p>
+        </ns0:txBody>
+      </ns0:sp>
+      <ns0:sp xmlns:ns0="http://schemas.openxmlformats.org/presentationml/2006/main">
+        <ns0:nvSpPr>
+          <ns0:cNvPr id="13" name="Hero Subtitle"/>
+          <ns0:cNvSpPr>
+            <ns1:spLocks xmlns:ns1="http://schemas.openxmlformats.org/drawingml/2006/main" noGrp="1"/>
+          </ns0:cNvSpPr>
+          <ns0:nvPr>
+            <ns0:ph type="body" idx="4"/>
+          </ns0:nvPr>
+        </ns0:nvSpPr>
+        <ns0:spPr>
+          <ns2:xfrm xmlns:ns2="http://schemas.openxmlformats.org/drawingml/2006/main">
+            <ns2:off x="914400" y="5905500"/>
+            <ns2:ext cx="16192500" cy="1143000"/>
+          </ns2:xfrm>
+          <ns3:prstGeom xmlns:ns3="http://schemas.openxmlformats.org/drawingml/2006/main" prst="rect">
+            <ns3:avLst/>
+          </ns3:prstGeom>
+        </ns0:spPr>
+        <ns0:txBody>
+          <ns4:bodyPr xmlns:ns4="http://schemas.openxmlformats.org/drawingml/2006/main" wrap="square" rtlCol="0" anchor="t" lIns="0" tIns="0" rIns="0" bIns="0">
+            <ns4:noAutofit/>
+          </ns4:bodyPr>
+          <ns5:lstStyle xmlns:ns5="http://schemas.openxmlformats.org/drawingml/2006/main">
+            <ns5:lvl1pPr marL="0" indent="0" algn="l">
+              <ns5:lnSpc>
+                <ns5:spcPct val="114999"/>
+              </ns5:lnSpc>
+              <ns5:buNone/>
+              <ns5:defRPr sz="3000">
+                <ns5:solidFill>
+                  <ns5:srgbClr val="5CD6FF"/>
+                </ns5:solidFill>
+                <ns5:latin typeface="Aptos"/>
+              </ns5:defRPr>
+            </ns5:lvl1pPr>
+          </ns5:lstStyle>
+          <ns6:p xmlns:ns6="http://schemas.openxmlformats.org/drawingml/2006/main">
+            <ns6:r>
+              <ns6:rPr lang="en-US"/>
+              <ns6:t>Subtitle — one sentence describing the deck.</ns6:t>
+            </ns6:r>
+            <ns6:endParaRPr lang="en-US"/>
+          </ns6:p>
+        </ns0:txBody>
+      </ns0:sp>
+      <ns0:sp xmlns:ns0="http://schemas.openxmlformats.org/presentationml/2006/main">
+        <ns0:nvSpPr>
+          <ns0:cNvPr id="14" name="Hero Org Line"/>
+          <ns0:cNvSpPr>
+            <ns1:spLocks xmlns:ns1="http://schemas.openxmlformats.org/drawingml/2006/main" noGrp="1"/>
+          </ns0:cNvSpPr>
+          <ns0:nvPr>
+            <ns0:ph type="body" idx="5"/>
+          </ns0:nvPr>
+        </ns0:nvSpPr>
+        <ns0:spPr>
+          <ns2:xfrm xmlns:ns2="http://schemas.openxmlformats.org/drawingml/2006/main">
+            <ns2:off x="914400" y="8191500"/>
+            <ns2:ext cx="16192500" cy="571500"/>
+          </ns2:xfrm>
+          <ns3:prstGeom xmlns:ns3="http://schemas.openxmlformats.org/drawingml/2006/main" prst="rect">
+            <ns3:avLst/>
+          </ns3:prstGeom>
+        </ns0:spPr>
+        <ns0:txBody>
+          <ns4:bodyPr xmlns:ns4="http://schemas.openxmlformats.org/drawingml/2006/main" wrap="square" rtlCol="0" anchor="t" lIns="0" tIns="0" rIns="0" bIns="0">
+            <ns4:noAutofit/>
+          </ns4:bodyPr>
+          <ns5:lstStyle xmlns:ns5="http://schemas.openxmlformats.org/drawingml/2006/main">
+            <ns5:lvl1pPr marL="0" indent="0" algn="l">
+              <ns5:buNone/>
+              <ns5:defRPr sz="2400">
+                <ns5:solidFill>
+                  <ns5:srgbClr val="FFFFFF"/>
+                </ns5:solidFill>
+                <ns5:latin typeface="Aptos"/>
+              </ns5:defRPr>
+            </ns5:lvl1pPr>
+          </ns5:lstStyle>
+          <ns6:p xmlns:ns6="http://schemas.openxmlformats.org/drawingml/2006/main">
+            <ns6:r>
+              <ns6:rPr lang="en-US"/>
+              <ns6:t>Open Component Model — open source, NeoNephos Foundation.</ns6:t>
+            </ns6:r>
+            <ns6:endParaRPr lang="en-US"/>
+          </ns6:p>
+        </ns0:txBody>
+      </ns0:sp>
+    </p:spTree>
+  </p:cSld>
+  <p:clrMapOvr>
+    <a:masterClrMapping/>
+  </p:clrMapOvr>
+</p:sldLayout>
+</file>
+
+<file path=ppt/slideLayouts/slideLayout3.xml><?xml version="1.0" encoding="utf-8"?>
 <p:sldLayout xmlns:a="http://schemas.openxmlformats.org/drawingml/2006/main" xmlns:r="http://schemas.openxmlformats.org/officeDocument/2006/relationships" xmlns:p="http://schemas.openxmlformats.org/presentationml/2006/main" type="obj" preserve="1" userDrawn="1">
   <p:cSld name="CTA">
     <p:bg>
@@ -430,7 +891,7 @@
 </p:sldLayout>
 </file>
 
-<file path=ppt/slideLayouts/slideLayout3.xml><?xml version="1.0" encoding="utf-8"?>
+<file path=ppt/slideLayouts/slideLayout4.xml><?xml version="1.0" encoding="utf-8"?>
 <p:sldLayout xmlns:a="http://schemas.openxmlformats.org/drawingml/2006/main" xmlns:r="http://schemas.openxmlformats.org/officeDocument/2006/relationships" xmlns:p="http://schemas.openxmlformats.org/presentationml/2006/main" type="obj" preserve="1" userDrawn="1">
   <p:cSld name="Content / 3-Column">
     <p:bg>
@@ -582,14 +1043,16 @@
         <ns0:spPr>
           <ns2:xfrm xmlns:ns2="http://schemas.openxmlformats.org/drawingml/2006/main">
             <ns2:off x="1143000" y="5105400"/>
-            <ns2:ext cx="4972050" cy="342900"/>
+            <ns2:ext cx="4972050" cy="533400"/>
           </ns2:xfrm>
           <ns3:prstGeom xmlns:ns3="http://schemas.openxmlformats.org/drawingml/2006/main" prst="rect">
             <ns3:avLst/>
           </ns3:prstGeom>
         </ns0:spPr>
         <ns0:txBody>
-          <ns4:bodyPr xmlns:ns4="http://schemas.openxmlformats.org/drawingml/2006/main" wrap="square" rtlCol="0" anchor="t" lIns="0" tIns="0" rIns="0" bIns="0"/>
+          <ns4:bodyPr xmlns:ns4="http://schemas.openxmlformats.org/drawingml/2006/main" wrap="square" rtlCol="0" anchor="t" lIns="0" tIns="0" rIns="0" bIns="0">
+            <ns4:noAutofit/>
+          </ns4:bodyPr>
           <ns5:lstStyle xmlns:ns5="http://schemas.openxmlformats.org/drawingml/2006/main">
             <ns5:lvl1pPr marL="0" indent="0" algn="l">
               <ns5:buNone/>
@@ -622,8 +1085,8 @@
         </ns0:nvSpPr>
         <ns0:spPr>
           <ns2:xfrm xmlns:ns2="http://schemas.openxmlformats.org/drawingml/2006/main">
-            <ns2:off x="1143000" y="5524500"/>
-            <ns2:ext cx="4972050" cy="4572000"/>
+            <ns2:off x="1143000" y="5753100"/>
+            <ns2:ext cx="4972050" cy="4381500"/>
           </ns2:xfrm>
           <ns3:prstGeom xmlns:ns3="http://schemas.openxmlformats.org/drawingml/2006/main" prst="rect">
             <ns3:avLst/>
@@ -693,14 +1156,16 @@
         <ns0:spPr>
           <ns2:xfrm xmlns:ns2="http://schemas.openxmlformats.org/drawingml/2006/main">
             <ns2:off x="6648450" y="5105400"/>
-            <ns2:ext cx="4972050" cy="342900"/>
+            <ns2:ext cx="4972050" cy="533400"/>
           </ns2:xfrm>
           <ns3:prstGeom xmlns:ns3="http://schemas.openxmlformats.org/drawingml/2006/main" prst="rect">
             <ns3:avLst/>
           </ns3:prstGeom>
         </ns0:spPr>
         <ns0:txBody>
-          <ns4:bodyPr xmlns:ns4="http://schemas.openxmlformats.org/drawingml/2006/main" wrap="square" rtlCol="0" anchor="t" lIns="0" tIns="0" rIns="0" bIns="0"/>
+          <ns4:bodyPr xmlns:ns4="http://schemas.openxmlformats.org/drawingml/2006/main" wrap="square" rtlCol="0" anchor="t" lIns="0" tIns="0" rIns="0" bIns="0">
+            <ns4:noAutofit/>
+          </ns4:bodyPr>
           <ns5:lstStyle xmlns:ns5="http://schemas.openxmlformats.org/drawingml/2006/main">
             <ns5:lvl1pPr marL="0" indent="0" algn="l">
               <ns5:buNone/>
@@ -733,8 +1198,8 @@
         </ns0:nvSpPr>
         <ns0:spPr>
           <ns2:xfrm xmlns:ns2="http://schemas.openxmlformats.org/drawingml/2006/main">
-            <ns2:off x="6648450" y="5524500"/>
-            <ns2:ext cx="4972050" cy="4572000"/>
+            <ns2:off x="6648450" y="5753100"/>
+            <ns2:ext cx="4972050" cy="4381500"/>
           </ns2:xfrm>
           <ns3:prstGeom xmlns:ns3="http://schemas.openxmlformats.org/drawingml/2006/main" prst="rect">
             <ns3:avLst/>
@@ -804,14 +1269,16 @@
         <ns0:spPr>
           <ns2:xfrm xmlns:ns2="http://schemas.openxmlformats.org/drawingml/2006/main">
             <ns2:off x="12153900" y="5105400"/>
-            <ns2:ext cx="4972050" cy="342900"/>
+            <ns2:ext cx="4972050" cy="533400"/>
           </ns2:xfrm>
           <ns3:prstGeom xmlns:ns3="http://schemas.openxmlformats.org/drawingml/2006/main" prst="rect">
             <ns3:avLst/>
           </ns3:prstGeom>
         </ns0:spPr>
         <ns0:txBody>
-          <ns4:bodyPr xmlns:ns4="http://schemas.openxmlformats.org/drawingml/2006/main" wrap="square" rtlCol="0" anchor="t" lIns="0" tIns="0" rIns="0" bIns="0"/>
+          <ns4:bodyPr xmlns:ns4="http://schemas.openxmlformats.org/drawingml/2006/main" wrap="square" rtlCol="0" anchor="t" lIns="0" tIns="0" rIns="0" bIns="0">
+            <ns4:noAutofit/>
+          </ns4:bodyPr>
           <ns5:lstStyle xmlns:ns5="http://schemas.openxmlformats.org/drawingml/2006/main">
             <ns5:lvl1pPr marL="0" indent="0" algn="l">
               <ns5:buNone/>
@@ -844,8 +1311,8 @@
         </ns0:nvSpPr>
         <ns0:spPr>
           <ns2:xfrm xmlns:ns2="http://schemas.openxmlformats.org/drawingml/2006/main">
-            <ns2:off x="12153900" y="5524500"/>
-            <ns2:ext cx="4972050" cy="4572000"/>
+            <ns2:off x="12153900" y="5753100"/>
+            <ns2:ext cx="4972050" cy="4381500"/>
           </ns2:xfrm>
           <ns3:prstGeom xmlns:ns3="http://schemas.openxmlformats.org/drawingml/2006/main" prst="rect">
             <ns3:avLst/>
@@ -920,7 +1387,7 @@
 </p:sldLayout>
 </file>
 
-<file path=ppt/slideLayouts/slideLayout4.xml><?xml version="1.0" encoding="utf-8"?>
+<file path=ppt/slideLayouts/slideLayout5.xml><?xml version="1.0" encoding="utf-8"?>
 <p:sldLayout xmlns:a="http://schemas.openxmlformats.org/drawingml/2006/main" xmlns:r="http://schemas.openxmlformats.org/officeDocument/2006/relationships" xmlns:p="http://schemas.openxmlformats.org/presentationml/2006/main" type="obj" preserve="1" userDrawn="1">
   <p:cSld name="Content / Diagram">
     <p:bg>
@@ -999,7 +1466,7 @@
         <ns0:spPr>
           <ns2:xfrm xmlns:ns2="http://schemas.openxmlformats.org/drawingml/2006/main">
             <ns2:off x="1143000" y="2933700"/>
-            <ns2:ext cx="16002000" cy="1905000"/>
+            <ns2:ext cx="16002000" cy="1143000"/>
           </ns2:xfrm>
           <ns3:prstGeom xmlns:ns3="http://schemas.openxmlformats.org/drawingml/2006/main" prst="rect">
             <ns3:avLst/>
@@ -1042,8 +1509,8 @@
         </ns0:nvSpPr>
         <ns0:spPr>
           <ns2:xfrm xmlns:ns2="http://schemas.openxmlformats.org/drawingml/2006/main">
-            <ns2:off x="1143000" y="4953000"/>
-            <ns2:ext cx="16002000" cy="4381500"/>
+            <ns2:off x="762000" y="4381500"/>
+            <ns2:ext cx="16764000" cy="5334000"/>
           </ns2:xfrm>
           <ns3:prstGeom xmlns:ns3="http://schemas.openxmlformats.org/drawingml/2006/main" prst="rect">
             <ns3:avLst/>
@@ -1104,7 +1571,7 @@
 </p:sldLayout>
 </file>
 
-<file path=ppt/slideLayouts/slideLayout5.xml><?xml version="1.0" encoding="utf-8"?>
+<file path=ppt/slideLayouts/slideLayout6.xml><?xml version="1.0" encoding="utf-8"?>
 <p:sldLayout xmlns:a="http://schemas.openxmlformats.org/drawingml/2006/main" xmlns:r="http://schemas.openxmlformats.org/officeDocument/2006/relationships" xmlns:p="http://schemas.openxmlformats.org/presentationml/2006/main" type="obj" preserve="1" userDrawn="1">
   <p:cSld name="Content / Tiles">
     <p:bg>
@@ -2101,7 +2568,7 @@
 </p:sldLayout>
 </file>
 
-<file path=ppt/slideLayouts/slideLayout6.xml><?xml version="1.0" encoding="utf-8"?>
+<file path=ppt/slideLayouts/slideLayout7.xml><?xml version="1.0" encoding="utf-8"?>
 <p:sldLayout xmlns:a="http://schemas.openxmlformats.org/drawingml/2006/main" xmlns:r="http://schemas.openxmlformats.org/officeDocument/2006/relationships" xmlns:p="http://schemas.openxmlformats.org/presentationml/2006/main" type="twoObj" preserve="1" userDrawn="1">
   <p:cSld name="Content / 2-Column">
     <p:bg>
@@ -2340,7 +2807,7 @@
 </p:sldLayout>
 </file>
 
-<file path=ppt/slideLayouts/slideLayout7.xml><?xml version="1.0" encoding="utf-8"?>
+<file path=ppt/slideLayouts/slideLayout8.xml><?xml version="1.0" encoding="utf-8"?>
 <p:sldLayout xmlns:a="http://schemas.openxmlformats.org/drawingml/2006/main" xmlns:r="http://schemas.openxmlformats.org/officeDocument/2006/relationships" xmlns:p="http://schemas.openxmlformats.org/presentationml/2006/main" type="secHead" preserve="1" userDrawn="1">
   <p:cSld name="Section Divider">
     <p:bg>
@@ -2414,7 +2881,7 @@
 </p:sldLayout>
 </file>
 
-<file path=ppt/slideLayouts/slideLayout8.xml><?xml version="1.0" encoding="utf-8"?>
+<file path=ppt/slideLayouts/slideLayout9.xml><?xml version="1.0" encoding="utf-8"?>
 <p:sldLayout xmlns:a="http://schemas.openxmlformats.org/drawingml/2006/main" xmlns:r="http://schemas.openxmlformats.org/officeDocument/2006/relationships" xmlns:p="http://schemas.openxmlformats.org/presentationml/2006/main" type="obj" preserve="1" userDrawn="1">
   <p:cSld name="Plain">
     <p:bg>
@@ -2538,204 +3005,6 @@
           <ns2:xfrm xmlns:ns2="http://schemas.openxmlformats.org/drawingml/2006/main">
             <ns2:off x="1143000" y="5524500"/>
             <ns2:ext cx="16002000" cy="3810000"/>
-          </ns2:xfrm>
-          <ns3:prstGeom xmlns:ns3="http://schemas.openxmlformats.org/drawingml/2006/main" prst="rect">
-            <ns3:avLst/>
-          </ns3:prstGeom>
-        </ns0:spPr>
-        <ns0:txBody>
-          <ns4:bodyPr xmlns:ns4="http://schemas.openxmlformats.org/drawingml/2006/main" wrap="square" rtlCol="0" anchor="t" lIns="0" tIns="0" rIns="0" bIns="0"/>
-          <ns5:lstStyle xmlns:ns5="http://schemas.openxmlformats.org/drawingml/2006/main">
-            <ns5:lvl1pPr marL="0" indent="0" algn="l">
-              <ns5:buNone/>
-              <ns5:defRPr sz="2200">
-                <ns5:solidFill>
-                  <ns5:srgbClr val="000000"/>
-                </ns5:solidFill>
-                <ns5:latin typeface="Aptos"/>
-              </ns5:defRPr>
-            </ns5:lvl1pPr>
-          </ns5:lstStyle>
-          <ns6:p xmlns:ns6="http://schemas.openxmlformats.org/drawingml/2006/main">
-            <ns6:r>
-              <ns6:rPr lang="en-US"/>
-              <ns6:t>Body text.</ns6:t>
-            </ns6:r>
-            <ns6:endParaRPr lang="en-US"/>
-          </ns6:p>
-        </ns0:txBody>
-      </ns0:sp>
-      <ns0:sp xmlns:ns0="http://schemas.openxmlformats.org/presentationml/2006/main">
-        <ns0:nvSpPr>
-          <ns0:cNvPr id="13" name="Footer"/>
-          <ns0:cNvSpPr>
-            <ns1:spLocks xmlns:ns1="http://schemas.openxmlformats.org/drawingml/2006/main" noGrp="1"/>
-          </ns0:cNvSpPr>
-          <ns0:nvPr/>
-        </ns0:nvSpPr>
-        <ns0:spPr>
-          <ns2:xfrm xmlns:ns2="http://schemas.openxmlformats.org/drawingml/2006/main">
-            <ns2:off x="1143000" y="9982200"/>
-            <ns2:ext cx="16002000" cy="228600"/>
-          </ns2:xfrm>
-          <ns3:prstGeom xmlns:ns3="http://schemas.openxmlformats.org/drawingml/2006/main" prst="rect">
-            <ns3:avLst/>
-          </ns3:prstGeom>
-        </ns0:spPr>
-        <ns0:txBody>
-          <ns4:bodyPr xmlns:ns4="http://schemas.openxmlformats.org/drawingml/2006/main" wrap="square" rtlCol="0" anchor="t" lIns="0" tIns="0" rIns="0" bIns="0"/>
-          <ns5:lstStyle xmlns:ns5="http://schemas.openxmlformats.org/drawingml/2006/main">
-            <ns5:lvl1pPr marL="0" indent="0" algn="l">
-              <ns5:buNone/>
-              <ns5:defRPr sz="900" cap="all" spc="50">
-                <ns5:solidFill>
-                  <ns5:srgbClr val="6B7280"/>
-                </ns5:solidFill>
-                <ns5:latin typeface="Aptos"/>
-              </ns5:defRPr>
-            </ns5:lvl1pPr>
-          </ns5:lstStyle>
-          <ns6:p xmlns:ns6="http://schemas.openxmlformats.org/drawingml/2006/main">
-            <ns6:r>
-              <ns6:rPr lang="en-US"/>
-              <ns6:t>OPEN COMPONENT MODEL · OCM.SOFTWARE</ns6:t>
-            </ns6:r>
-            <ns6:endParaRPr lang="en-US"/>
-          </ns6:p>
-        </ns0:txBody>
-      </ns0:sp>
-    </p:spTree>
-  </p:cSld>
-  <p:clrMapOvr>
-    <a:masterClrMapping/>
-  </p:clrMapOvr>
-</p:sldLayout>
-</file>
-
-<file path=ppt/slideLayouts/slideLayout9.xml><?xml version="1.0" encoding="utf-8"?>
-<p:sldLayout xmlns:a="http://schemas.openxmlformats.org/drawingml/2006/main" xmlns:r="http://schemas.openxmlformats.org/officeDocument/2006/relationships" xmlns:p="http://schemas.openxmlformats.org/presentationml/2006/main" type="obj" preserve="1" userDrawn="1">
-  <p:cSld name="Plain / Compact">
-    <p:bg>
-      <p:bgPr>
-        <a:solidFill>
-          <a:srgbClr val="FFFFFF"/>
-        </a:solidFill>
-        <a:effectLst/>
-      </p:bgPr>
-    </p:bg>
-    <p:spTree>
-      <p:nvGrpSpPr>
-        <p:cNvPr id="1" name=""/>
-        <p:cNvGrpSpPr/>
-        <p:nvPr/>
-      </p:nvGrpSpPr>
-      <p:grpSpPr>
-        <a:xfrm>
-          <a:off x="0" y="0"/>
-          <a:ext cx="0" cy="0"/>
-          <a:chOff x="0" y="0"/>
-          <a:chExt cx="0" cy="0"/>
-        </a:xfrm>
-      </p:grpSpPr>
-      <ns0:sp xmlns:ns0="http://schemas.openxmlformats.org/presentationml/2006/main">
-        <ns0:nvSpPr>
-          <ns0:cNvPr id="10" name="Eyebrow"/>
-          <ns0:cNvSpPr>
-            <ns1:spLocks xmlns:ns1="http://schemas.openxmlformats.org/drawingml/2006/main" noGrp="1"/>
-          </ns0:cNvSpPr>
-          <ns0:nvPr>
-            <ns0:ph type="body" idx="1"/>
-          </ns0:nvPr>
-        </ns0:nvSpPr>
-        <ns0:spPr>
-          <ns2:xfrm xmlns:ns2="http://schemas.openxmlformats.org/drawingml/2006/main">
-            <ns2:off x="1143000" y="2428875"/>
-            <ns2:ext cx="16002000" cy="457200"/>
-          </ns2:xfrm>
-          <ns3:prstGeom xmlns:ns3="http://schemas.openxmlformats.org/drawingml/2006/main" prst="rect">
-            <ns3:avLst/>
-          </ns3:prstGeom>
-        </ns0:spPr>
-        <ns0:txBody>
-          <ns4:bodyPr xmlns:ns4="http://schemas.openxmlformats.org/drawingml/2006/main" wrap="square" rtlCol="0" anchor="t" lIns="0" tIns="0" rIns="0" bIns="0"/>
-          <ns5:lstStyle xmlns:ns5="http://schemas.openxmlformats.org/drawingml/2006/main">
-            <ns5:lvl1pPr marL="0" indent="0" algn="l">
-              <ns5:buNone/>
-              <ns5:defRPr sz="2800" b="1" cap="all" spc="140">
-                <ns5:solidFill>
-                  <ns5:srgbClr val="0F6BFF"/>
-                </ns5:solidFill>
-                <ns5:latin typeface="Aptos"/>
-              </ns5:defRPr>
-            </ns5:lvl1pPr>
-          </ns5:lstStyle>
-          <ns6:p xmlns:ns6="http://schemas.openxmlformats.org/drawingml/2006/main">
-            <ns6:r>
-              <ns6:rPr lang="en-US"/>
-              <ns6:t>EYEBROW</ns6:t>
-            </ns6:r>
-            <ns6:endParaRPr lang="en-US"/>
-          </ns6:p>
-        </ns0:txBody>
-      </ns0:sp>
-      <ns0:sp xmlns:ns0="http://schemas.openxmlformats.org/presentationml/2006/main">
-        <ns0:nvSpPr>
-          <ns0:cNvPr id="11" name="Title"/>
-          <ns0:cNvSpPr>
-            <ns1:spLocks xmlns:ns1="http://schemas.openxmlformats.org/drawingml/2006/main" noGrp="1"/>
-          </ns0:cNvSpPr>
-          <ns0:nvPr>
-            <ns0:ph type="title" idx="2"/>
-          </ns0:nvPr>
-        </ns0:nvSpPr>
-        <ns0:spPr>
-          <ns2:xfrm xmlns:ns2="http://schemas.openxmlformats.org/drawingml/2006/main">
-            <ns2:off x="1143000" y="2933700"/>
-            <ns2:ext cx="16002000" cy="1905000"/>
-          </ns2:xfrm>
-          <ns3:prstGeom xmlns:ns3="http://schemas.openxmlformats.org/drawingml/2006/main" prst="rect">
-            <ns3:avLst/>
-          </ns3:prstGeom>
-        </ns0:spPr>
-        <ns0:txBody>
-          <ns4:bodyPr xmlns:ns4="http://schemas.openxmlformats.org/drawingml/2006/main" wrap="square" rtlCol="0" anchor="t" lIns="0" tIns="0" rIns="0" bIns="0"/>
-          <ns5:lstStyle xmlns:ns5="http://schemas.openxmlformats.org/drawingml/2006/main">
-            <ns5:lvl1pPr marL="0" indent="0" algn="l">
-              <ns5:lnSpc>
-                <ns5:spcPct val="90000"/>
-              </ns5:lnSpc>
-              <ns5:buNone/>
-              <ns5:defRPr sz="6400" b="1">
-                <ns5:solidFill>
-                  <ns5:srgbClr val="000000"/>
-                </ns5:solidFill>
-                <ns5:latin typeface="Aptos Display"/>
-              </ns5:defRPr>
-            </ns5:lvl1pPr>
-          </ns5:lstStyle>
-          <ns6:p xmlns:ns6="http://schemas.openxmlformats.org/drawingml/2006/main">
-            <ns6:r>
-              <ns6:rPr lang="en-US"/>
-              <ns6:t>Section title goes here.</ns6:t>
-            </ns6:r>
-            <ns6:endParaRPr lang="en-US"/>
-          </ns6:p>
-        </ns0:txBody>
-      </ns0:sp>
-      <ns0:sp xmlns:ns0="http://schemas.openxmlformats.org/presentationml/2006/main">
-        <ns0:nvSpPr>
-          <ns0:cNvPr id="12" name="Body"/>
-          <ns0:cNvSpPr>
-            <ns1:spLocks xmlns:ns1="http://schemas.openxmlformats.org/drawingml/2006/main" noGrp="1"/>
-          </ns0:cNvSpPr>
-          <ns0:nvPr>
-            <ns0:ph type="body" idx="10"/>
-          </ns0:nvPr>
-        </ns0:nvSpPr>
-        <ns0:spPr>
-          <ns2:xfrm xmlns:ns2="http://schemas.openxmlformats.org/drawingml/2006/main">
-            <ns2:off x="1143000" y="4953000"/>
-            <ns2:ext cx="16002000" cy="4381500"/>
           </ns2:xfrm>
           <ns3:prstGeom xmlns:ns3="http://schemas.openxmlformats.org/drawingml/2006/main" prst="rect">
             <ns3:avLst/>
@@ -3064,6 +3333,7 @@
     <p:sldLayoutId id="2147483655" r:id="rId8"/>
     <p:sldLayoutId id="2147483656" r:id="rId9"/>
     <p:sldLayoutId id="2147483657" r:id="rId10"/>
+    <p:sldLayoutId id="2147483658" r:id="rId11"/>
   </p:sldLayoutIdLst>
   <p:txStyles>
     <p:titleStyle>
@@ -3330,7 +3600,7 @@
       <p:grpSpPr/>
       <p:pic>
         <p:nvPicPr>
-          <p:cNvPr id="6" name="Picture 5" descr="OCM-Banner.png"/>
+          <p:cNvPr id="7" name="Picture 6" descr="OCM-Banner.png"/>
           <p:cNvPicPr>
             <a:picLocks noChangeAspect="1"/>
           </p:cNvPicPr>
@@ -3373,7 +3643,7 @@
                   <a:srgbClr val="FFFFFF"/>
                 </a:solidFill>
               </a:rPr>
-              <a:t>Secure Delivery for</a:t>
+              <a:t>Three minutes from now,</a:t>
             </a:r>
           </a:p>
         </p:txBody>
@@ -3386,6 +3656,32 @@
           </p:cNvSpPr>
           <p:nvPr>
             <p:ph type="body" idx="2"/>
+          </p:nvPr>
+        </p:nvSpPr>
+        <p:spPr/>
+        <p:txBody>
+          <a:bodyPr/>
+          <a:lstStyle/>
+          <a:p>
+            <a:r>
+              <a:rPr>
+                <a:solidFill>
+                  <a:srgbClr val="FFFFFF"/>
+                </a:solidFill>
+              </a:rPr>
+              <a:t>you'll know what your</a:t>
+            </a:r>
+          </a:p>
+        </p:txBody>
+      </p:sp>
+      <p:sp>
+        <p:nvSpPr>
+          <p:cNvPr id="4" name="Text Placeholder 3"/>
+          <p:cNvSpPr>
+            <a:spLocks noGrp="1"/>
+          </p:cNvSpPr>
+          <p:nvPr>
+            <p:ph type="body" idx="3"/>
           </p:nvPr>
         </p:nvSpPr>
         <p:spPr/>
@@ -3419,33 +3715,7 @@
                   <a:lin ang="0" scaled="1"/>
                 </a:gradFill>
               </a:rPr>
-              <a:t>Sovereign Clouds</a:t>
-            </a:r>
-          </a:p>
-        </p:txBody>
-      </p:sp>
-      <p:sp>
-        <p:nvSpPr>
-          <p:cNvPr id="4" name="Text Placeholder 3"/>
-          <p:cNvSpPr>
-            <a:spLocks noGrp="1"/>
-          </p:cNvSpPr>
-          <p:nvPr>
-            <p:ph type="body" idx="3"/>
-          </p:nvPr>
-        </p:nvSpPr>
-        <p:spPr/>
-        <p:txBody>
-          <a:bodyPr/>
-          <a:lstStyle/>
-          <a:p>
-            <a:r>
-              <a:rPr>
-                <a:solidFill>
-                  <a:srgbClr val="5CD6FF"/>
-                </a:solidFill>
-              </a:rPr>
-              <a:t>Deliver and deploy your software securely. Anywhere, at any scale.</a:t>
+              <a:t>supply chain doesn't</a:t>
             </a:r>
           </a:p>
         </p:txBody>
@@ -3468,6 +3738,32 @@
             <a:r>
               <a:rPr>
                 <a:solidFill>
+                  <a:srgbClr val="5CD6FF"/>
+                </a:solidFill>
+              </a:rPr>
+              <a:t>A new model for delivering software the auditor can verify, the operator can run, and the regulator already requires.</a:t>
+            </a:r>
+          </a:p>
+        </p:txBody>
+      </p:sp>
+      <p:sp>
+        <p:nvSpPr>
+          <p:cNvPr id="6" name="Text Placeholder 5"/>
+          <p:cNvSpPr>
+            <a:spLocks noGrp="1"/>
+          </p:cNvSpPr>
+          <p:nvPr>
+            <p:ph type="body" idx="5"/>
+          </p:nvPr>
+        </p:nvSpPr>
+        <p:spPr/>
+        <p:txBody>
+          <a:bodyPr/>
+          <a:lstStyle/>
+          <a:p>
+            <a:r>
+              <a:rPr>
+                <a:solidFill>
                   <a:srgbClr val="FFFFFF"/>
                 </a:solidFill>
               </a:rPr>
@@ -3478,7 +3774,7 @@
       </p:sp>
       <p:pic>
         <p:nvPicPr>
-          <p:cNvPr id="7" name="Picture 6" descr="ocm-horizontal-white_400.png"/>
+          <p:cNvPr id="8" name="Picture 7" descr="ocm-horizontal-white_400.png"/>
           <p:cNvPicPr>
             <a:picLocks noChangeAspect="1"/>
           </p:cNvPicPr>
@@ -3502,7 +3798,7 @@
       </p:pic>
       <p:pic>
         <p:nvPicPr>
-          <p:cNvPr id="8" name="Picture 7" descr="neonephos-foundation-horizontal-white_400.png"/>
+          <p:cNvPr id="9" name="Picture 8" descr="neonephos-foundation-horizontal-white_400.png"/>
           <p:cNvPicPr>
             <a:picLocks noChangeAspect="1"/>
           </p:cNvPicPr>
@@ -3533,6 +3829,217 @@
 </file>
 
 <file path=ppt/slides/slide10.xml><?xml version="1.0" encoding="utf-8"?>
+<p:sld xmlns:a="http://schemas.openxmlformats.org/drawingml/2006/main" xmlns:p="http://schemas.openxmlformats.org/presentationml/2006/main" xmlns:r="http://schemas.openxmlformats.org/officeDocument/2006/relationships">
+  <p:cSld>
+    <p:spTree>
+      <p:nvGrpSpPr>
+        <p:cNvPr id="1" name=""/>
+        <p:cNvGrpSpPr/>
+        <p:nvPr/>
+      </p:nvGrpSpPr>
+      <p:grpSpPr/>
+      <p:sp>
+        <p:nvSpPr>
+          <p:cNvPr id="2" name="Text Placeholder 1"/>
+          <p:cNvSpPr>
+            <a:spLocks noGrp="1"/>
+          </p:cNvSpPr>
+          <p:nvPr>
+            <p:ph type="body" idx="1"/>
+          </p:nvPr>
+        </p:nvSpPr>
+        <p:spPr/>
+        <p:txBody>
+          <a:bodyPr/>
+          <a:lstStyle/>
+          <a:p>
+            <a:r>
+              <a:t>SCAN — COMPLIANCE-NATIVE WITH OPEN DELIVERY GEAR</a:t>
+            </a:r>
+          </a:p>
+        </p:txBody>
+      </p:sp>
+      <p:sp>
+        <p:nvSpPr>
+          <p:cNvPr id="3" name="Title 2"/>
+          <p:cNvSpPr>
+            <a:spLocks noGrp="1"/>
+          </p:cNvSpPr>
+          <p:nvPr>
+            <p:ph type="title" idx="2"/>
+          </p:nvPr>
+        </p:nvSpPr>
+        <p:spPr/>
+        <p:txBody>
+          <a:bodyPr/>
+          <a:lstStyle/>
+          <a:p>
+            <a:r>
+              <a:t>Compliance as a system property —</a:t>
+            </a:r>
+          </a:p>
+          <a:p>
+            <a:r>
+              <a:t>not a quarterly retrofit.</a:t>
+            </a:r>
+          </a:p>
+        </p:txBody>
+      </p:sp>
+      <p:sp>
+        <p:nvSpPr>
+          <p:cNvPr id="4" name="Text Placeholder 3"/>
+          <p:cNvSpPr>
+            <a:spLocks noGrp="1"/>
+          </p:cNvSpPr>
+          <p:nvPr>
+            <p:ph type="body" idx="10"/>
+          </p:nvPr>
+        </p:nvSpPr>
+        <p:spPr/>
+        <p:txBody>
+          <a:bodyPr/>
+          <a:lstStyle/>
+          <a:p>
+            <a:pPr>
+              <a:spcBef>
+                <a:spcPts val="800"/>
+              </a:spcBef>
+              <a:spcAft>
+                <a:spcPts val="800"/>
+              </a:spcAft>
+            </a:pPr>
+            <a:r>
+              <a:rPr b="1">
+                <a:solidFill>
+                  <a:srgbClr val="0F6BFF"/>
+                </a:solidFill>
+              </a:rPr>
+              <a:t>▪  </a:t>
+            </a:r>
+            <a:r>
+              <a:rPr>
+                <a:solidFill>
+                  <a:srgbClr val="000000"/>
+                </a:solidFill>
+              </a:rPr>
+              <a:t>Open Delivery Gear (ODG) is OCM's compliance automation engine.</a:t>
+            </a:r>
+          </a:p>
+          <a:p>
+            <a:pPr>
+              <a:spcBef>
+                <a:spcPts val="800"/>
+              </a:spcBef>
+              <a:spcAft>
+                <a:spcPts val="800"/>
+              </a:spcAft>
+            </a:pPr>
+            <a:r>
+              <a:rPr b="1">
+                <a:solidFill>
+                  <a:srgbClr val="0F6BFF"/>
+                </a:solidFill>
+              </a:rPr>
+              <a:t>▪  </a:t>
+            </a:r>
+            <a:r>
+              <a:rPr>
+                <a:solidFill>
+                  <a:srgbClr val="000000"/>
+                </a:solidFill>
+              </a:rPr>
+              <a:t>The Compliance Dashboard is your entry point: every component, every finding, every signature in one view.</a:t>
+            </a:r>
+          </a:p>
+          <a:p>
+            <a:pPr>
+              <a:spcBef>
+                <a:spcPts val="800"/>
+              </a:spcBef>
+              <a:spcAft>
+                <a:spcPts val="800"/>
+              </a:spcAft>
+            </a:pPr>
+            <a:r>
+              <a:rPr b="1">
+                <a:solidFill>
+                  <a:srgbClr val="0F6BFF"/>
+                </a:solidFill>
+              </a:rPr>
+              <a:t>▪  </a:t>
+            </a:r>
+            <a:r>
+              <a:rPr>
+                <a:solidFill>
+                  <a:srgbClr val="000000"/>
+                </a:solidFill>
+              </a:rPr>
+              <a:t>Continuous scans run asynchronously — even after release.</a:t>
+            </a:r>
+          </a:p>
+          <a:p>
+            <a:pPr>
+              <a:spcBef>
+                <a:spcPts val="800"/>
+              </a:spcBef>
+              <a:spcAft>
+                <a:spcPts val="800"/>
+              </a:spcAft>
+            </a:pPr>
+            <a:r>
+              <a:rPr b="1">
+                <a:solidFill>
+                  <a:srgbClr val="0F6BFF"/>
+                </a:solidFill>
+              </a:rPr>
+              <a:t>▪  </a:t>
+            </a:r>
+            <a:r>
+              <a:rPr>
+                <a:solidFill>
+                  <a:srgbClr val="000000"/>
+                </a:solidFill>
+              </a:rPr>
+              <a:t>Findings get rescored against contextual risk, so your team patches what actually matters.</a:t>
+            </a:r>
+          </a:p>
+          <a:p>
+            <a:pPr>
+              <a:spcBef>
+                <a:spcPts val="800"/>
+              </a:spcBef>
+              <a:spcAft>
+                <a:spcPts val="800"/>
+              </a:spcAft>
+            </a:pPr>
+            <a:r>
+              <a:rPr b="1">
+                <a:solidFill>
+                  <a:srgbClr val="0F6BFF"/>
+                </a:solidFill>
+              </a:rPr>
+              <a:t>▪  </a:t>
+            </a:r>
+            <a:r>
+              <a:rPr>
+                <a:solidFill>
+                  <a:srgbClr val="000000"/>
+                </a:solidFill>
+              </a:rPr>
+              <a:t>Every compliance signal correlates by component identity. Auditors get evidence, not spreadsheets.</a:t>
+            </a:r>
+          </a:p>
+        </p:txBody>
+      </p:sp>
+    </p:spTree>
+  </p:cSld>
+  <p:clrMapOvr>
+    <a:masterClrMapping/>
+  </p:clrMapOvr>
+</p:sld>
+</file>
+
+<file path=ppt/slides/slide11.xml><?xml version="1.0" encoding="utf-8"?>
 <p:sld xmlns:a="http://schemas.openxmlformats.org/drawingml/2006/main" xmlns:p="http://schemas.openxmlformats.org/presentationml/2006/main" xmlns:r="http://schemas.openxmlformats.org/officeDocument/2006/relationships">
   <p:cSld>
     <p:spTree>
@@ -3988,7 +4495,7 @@
 </p:sld>
 </file>
 
-<file path=ppt/slides/slide11.xml><?xml version="1.0" encoding="utf-8"?>
+<file path=ppt/slides/slide12.xml><?xml version="1.0" encoding="utf-8"?>
 <p:sld xmlns:a="http://schemas.openxmlformats.org/drawingml/2006/main" xmlns:p="http://schemas.openxmlformats.org/presentationml/2006/main" xmlns:r="http://schemas.openxmlformats.org/officeDocument/2006/relationships">
   <p:cSld>
     <p:spTree>
@@ -4076,7 +4583,7 @@
       </p:sp>
       <p:pic>
         <p:nvPicPr>
-          <p:cNvPr id="5" name="Picture 4" descr="sap-horizontal-color_640.png"/>
+          <p:cNvPr id="5" name="Picture 4" descr="sap-horizontal-color_640_crop.png"/>
           <p:cNvPicPr>
             <a:picLocks noChangeAspect="1"/>
           </p:cNvPicPr>
@@ -4100,7 +4607,7 @@
       </p:pic>
       <p:pic>
         <p:nvPicPr>
-          <p:cNvPr id="6" name="Picture 5" descr="bwi-horizontal-color_640.png"/>
+          <p:cNvPr id="6" name="Picture 5" descr="bwi-horizontal-color_640_crop.png"/>
           <p:cNvPicPr>
             <a:picLocks noChangeAspect="1"/>
           </p:cNvPicPr>
@@ -4114,8 +4621,8 @@
         </p:blipFill>
         <p:spPr>
           <a:xfrm>
-            <a:off x="8467502" y="5715000"/>
-            <a:ext cx="1343471" cy="762000"/>
+            <a:off x="8317603" y="5715000"/>
+            <a:ext cx="1643269" cy="762000"/>
           </a:xfrm>
           <a:prstGeom prst="rect">
             <a:avLst/>
@@ -4124,7 +4631,7 @@
       </p:pic>
       <p:pic>
         <p:nvPicPr>
-          <p:cNvPr id="7" name="Picture 6" descr="sap-ns2-getlogovector.png"/>
+          <p:cNvPr id="7" name="Picture 6" descr="sap-ns2-getlogovector_crop.png"/>
           <p:cNvPicPr>
             <a:picLocks noChangeAspect="1"/>
           </p:cNvPicPr>
@@ -4138,8 +4645,8 @@
         </p:blipFill>
         <p:spPr>
           <a:xfrm>
-            <a:off x="13530262" y="5715000"/>
-            <a:ext cx="1371600" cy="762000"/>
+            <a:off x="12936673" y="5715000"/>
+            <a:ext cx="2558778" cy="762000"/>
           </a:xfrm>
           <a:prstGeom prst="rect">
             <a:avLst/>
@@ -4182,7 +4689,7 @@
       </p:sp>
       <p:pic>
         <p:nvPicPr>
-          <p:cNvPr id="9" name="Picture 8" descr="gardener-horizontal-color_640.png"/>
+          <p:cNvPr id="9" name="Picture 8" descr="gardener-horizontal-color_640_crop.png"/>
           <p:cNvPicPr>
             <a:picLocks noChangeAspect="1"/>
           </p:cNvPicPr>
@@ -4196,8 +4703,8 @@
         </p:blipFill>
         <p:spPr>
           <a:xfrm>
-            <a:off x="2729953" y="7905750"/>
-            <a:ext cx="2664918" cy="762000"/>
+            <a:off x="2538412" y="7955322"/>
+            <a:ext cx="3048000" cy="662855"/>
           </a:xfrm>
           <a:prstGeom prst="rect">
             <a:avLst/>
@@ -4206,7 +4713,7 @@
       </p:pic>
       <p:pic>
         <p:nvPicPr>
-          <p:cNvPr id="10" name="Picture 9" descr="konfidence-horizontal-light_640.png"/>
+          <p:cNvPr id="10" name="Picture 9" descr="konfidence-horizontal-light_640_crop.png"/>
           <p:cNvPicPr>
             <a:picLocks noChangeAspect="1"/>
           </p:cNvPicPr>
@@ -4220,8 +4727,8 @@
         </p:blipFill>
         <p:spPr>
           <a:xfrm>
-            <a:off x="7615237" y="8108156"/>
-            <a:ext cx="3048000" cy="357187"/>
+            <a:off x="7615237" y="8134848"/>
+            <a:ext cx="3048000" cy="303803"/>
           </a:xfrm>
           <a:prstGeom prst="rect">
             <a:avLst/>
@@ -4230,7 +4737,7 @@
       </p:pic>
       <p:pic>
         <p:nvPicPr>
-          <p:cNvPr id="11" name="Picture 10" descr="platform-mesh-horizontal-color_640.png"/>
+          <p:cNvPr id="11" name="Picture 10" descr="platform-mesh-horizontal-color_640_crop.png"/>
           <p:cNvPicPr>
             <a:picLocks noChangeAspect="1"/>
           </p:cNvPicPr>
@@ -4299,7 +4806,7 @@
 </p:sld>
 </file>
 
-<file path=ppt/slides/slide12.xml><?xml version="1.0" encoding="utf-8"?>
+<file path=ppt/slides/slide13.xml><?xml version="1.0" encoding="utf-8"?>
 <p:sld xmlns:a="http://schemas.openxmlformats.org/drawingml/2006/main" xmlns:p="http://schemas.openxmlformats.org/presentationml/2006/main" xmlns:r="http://schemas.openxmlformats.org/officeDocument/2006/relationships">
   <p:cSld>
     <p:spTree>
@@ -4592,7 +5099,7 @@
           <a:lstStyle/>
           <a:p>
             <a:r>
-              <a:t>EU DORA · NIS2 · GDPR. Provable supply-chain control, not best effort.</a:t>
+              <a:t>EU DORA · NIS2 · CRA. Provable supply-chain control, not best effort.</a:t>
             </a:r>
           </a:p>
         </p:txBody>
@@ -4673,7 +5180,7 @@
           <a:lstStyle/>
           <a:p>
             <a:r>
-              <a:t>THE PAIN</a:t>
+              <a:t>THE ANSWER</a:t>
             </a:r>
           </a:p>
         </p:txBody>
@@ -4694,19 +5201,14 @@
           <a:lstStyle/>
           <a:p>
             <a:r>
-              <a:t>Software delivery is fragmented.</a:t>
-            </a:r>
-          </a:p>
-          <a:p>
-            <a:r>
-              <a:t>Compliance retrofits don't scale.</a:t>
+              <a:t>Meet OCM. One identity, every boundary.</a:t>
             </a:r>
           </a:p>
         </p:txBody>
       </p:sp>
       <p:pic>
         <p:nvPicPr>
-          <p:cNvPr id="4" name="Picture 3" descr="03-fragmented_1680.png"/>
+          <p:cNvPr id="4" name="Picture 3" descr="03-meet-ocm-hub-and-spoke_1760.png"/>
           <p:cNvPicPr>
             <a:picLocks noChangeAspect="1"/>
           </p:cNvPicPr>
@@ -4720,8 +5222,8 @@
         </p:blipFill>
         <p:spPr>
           <a:xfrm>
-            <a:off x="3483429" y="4953000"/>
-            <a:ext cx="11321142" cy="4953000"/>
+            <a:off x="762000" y="4381500"/>
+            <a:ext cx="16764000" cy="5143500"/>
           </a:xfrm>
           <a:prstGeom prst="rect">
             <a:avLst/>
@@ -4944,7 +5446,7 @@
       </p:sp>
       <p:pic>
         <p:nvPicPr>
-          <p:cNvPr id="4" name="Picture 3" descr="04-sbom-inside-sbod_1680.png"/>
+          <p:cNvPr id="4" name="Picture 3" descr="04-sbom-inside-sbod_1760.png"/>
           <p:cNvPicPr>
             <a:picLocks noChangeAspect="1"/>
           </p:cNvPicPr>
@@ -4958,8 +5460,8 @@
         </p:blipFill>
         <p:spPr>
           <a:xfrm>
-            <a:off x="3640667" y="4953000"/>
-            <a:ext cx="11006666" cy="4953000"/>
+            <a:off x="3217333" y="4381500"/>
+            <a:ext cx="11853333" cy="5334000"/>
           </a:xfrm>
           <a:prstGeom prst="rect">
             <a:avLst/>
@@ -5000,7 +5502,7 @@
           <a:lstStyle/>
           <a:p>
             <a:r>
-              <a:t>OCM IN ONE PICTURE</a:t>
+              <a:t>HOW OCM COMPOSES</a:t>
             </a:r>
           </a:p>
         </p:txBody>
@@ -5021,35 +5523,137 @@
           <a:lstStyle/>
           <a:p>
             <a:r>
-              <a:t>Pack · Sign · Transport · Deploy</a:t>
-            </a:r>
-          </a:p>
-        </p:txBody>
-      </p:sp>
-      <p:pic>
-        <p:nvPicPr>
-          <p:cNvPr id="4" name="Picture 3" descr="05-pack-sign-transport-deploy-v2_1680.png"/>
-          <p:cNvPicPr>
-            <a:picLocks noChangeAspect="1"/>
-          </p:cNvPicPr>
-          <p:nvPr/>
-        </p:nvPicPr>
-        <p:blipFill>
-          <a:blip r:embed="rId2"/>
-          <a:stretch>
-            <a:fillRect/>
-          </a:stretch>
-        </p:blipFill>
-        <p:spPr>
-          <a:xfrm>
-            <a:off x="1143000" y="4953000"/>
-            <a:ext cx="16002000" cy="4505325"/>
-          </a:xfrm>
-          <a:prstGeom prst="rect">
-            <a:avLst/>
-          </a:prstGeom>
-        </p:spPr>
-      </p:pic>
+              <a:t>OCM doesn't replace your tools. It gives them something to sign together.</a:t>
+            </a:r>
+          </a:p>
+        </p:txBody>
+      </p:sp>
+      <p:sp>
+        <p:nvSpPr>
+          <p:cNvPr id="4" name="Text Placeholder 3"/>
+          <p:cNvSpPr>
+            <a:spLocks noGrp="1"/>
+          </p:cNvSpPr>
+          <p:nvPr>
+            <p:ph type="body" idx="10"/>
+          </p:nvPr>
+        </p:nvSpPr>
+        <p:spPr/>
+        <p:txBody>
+          <a:bodyPr/>
+          <a:lstStyle/>
+          <a:p>
+            <a:r>
+              <a:t>KEYLESS (SIGSTORE) / KEY-BASED (YOUR PKI)</a:t>
+            </a:r>
+          </a:p>
+        </p:txBody>
+      </p:sp>
+      <p:sp>
+        <p:nvSpPr>
+          <p:cNvPr id="5" name="Text Placeholder 4"/>
+          <p:cNvSpPr>
+            <a:spLocks noGrp="1"/>
+          </p:cNvSpPr>
+          <p:nvPr>
+            <p:ph type="body" idx="11"/>
+          </p:nvPr>
+        </p:nvSpPr>
+        <p:spPr/>
+        <p:txBody>
+          <a:bodyPr/>
+          <a:lstStyle/>
+          <a:p>
+            <a:r>
+              <a:t>Only signs one artifact. OCM gives them the complete SBoD to sign. One signature, covering every artifact in the delivery, by digest. Your existing keys still work.</a:t>
+            </a:r>
+          </a:p>
+        </p:txBody>
+      </p:sp>
+      <p:sp>
+        <p:nvSpPr>
+          <p:cNvPr id="6" name="Text Placeholder 5"/>
+          <p:cNvSpPr>
+            <a:spLocks noGrp="1"/>
+          </p:cNvSpPr>
+          <p:nvPr>
+            <p:ph type="body" idx="12"/>
+          </p:nvPr>
+        </p:nvSpPr>
+        <p:spPr/>
+        <p:txBody>
+          <a:bodyPr/>
+          <a:lstStyle/>
+          <a:p>
+            <a:r>
+              <a:t>YOUR SBOM TOOL OR FORMAT (SYFT, CYCLONEDX, SPDX)</a:t>
+            </a:r>
+          </a:p>
+        </p:txBody>
+      </p:sp>
+      <p:sp>
+        <p:nvSpPr>
+          <p:cNvPr id="7" name="Text Placeholder 6"/>
+          <p:cNvSpPr>
+            <a:spLocks noGrp="1"/>
+          </p:cNvSpPr>
+          <p:nvPr>
+            <p:ph type="body" idx="13"/>
+          </p:nvPr>
+        </p:nvSpPr>
+        <p:spPr/>
+        <p:txBody>
+          <a:bodyPr/>
+          <a:lstStyle/>
+          <a:p>
+            <a:r>
+              <a:t>Lists what's in your software. The SBoD contains or references it. Your SBOM tool is unchanged; the SBOM now travels with the signature.</a:t>
+            </a:r>
+          </a:p>
+        </p:txBody>
+      </p:sp>
+      <p:sp>
+        <p:nvSpPr>
+          <p:cNvPr id="8" name="Text Placeholder 7"/>
+          <p:cNvSpPr>
+            <a:spLocks noGrp="1"/>
+          </p:cNvSpPr>
+          <p:nvPr>
+            <p:ph type="body" idx="14"/>
+          </p:nvPr>
+        </p:nvSpPr>
+        <p:spPr/>
+        <p:txBody>
+          <a:bodyPr/>
+          <a:lstStyle/>
+          <a:p>
+            <a:r>
+              <a:t>A BIT OF OCI + SIGSTORE + YOUR OWN SCRIPTS</a:t>
+            </a:r>
+          </a:p>
+        </p:txBody>
+      </p:sp>
+      <p:sp>
+        <p:nvSpPr>
+          <p:cNvPr id="9" name="Text Placeholder 8"/>
+          <p:cNvSpPr>
+            <a:spLocks noGrp="1"/>
+          </p:cNvSpPr>
+          <p:nvPr>
+            <p:ph type="body" idx="15"/>
+          </p:nvPr>
+        </p:nvSpPr>
+        <p:spPr/>
+        <p:txBody>
+          <a:bodyPr/>
+          <a:lstStyle/>
+          <a:p>
+            <a:r>
+              <a:t>Can almost get you there, in pieces. OCM is the standardised version, openly governed, with conformance tests and the SBoD vocabulary your auditors are starting to expect.</a:t>
+            </a:r>
+          </a:p>
+        </p:txBody>
+      </p:sp>
     </p:spTree>
   </p:cSld>
   <p:clrMapOvr>
@@ -5084,7 +5688,7 @@
           <a:lstStyle/>
           <a:p>
             <a:r>
-              <a:t>SOVEREIGN-READY</a:t>
+              <a:t>OCM IN ONE PICTURE</a:t>
             </a:r>
           </a:p>
         </p:txBody>
@@ -5105,131 +5709,35 @@
           <a:lstStyle/>
           <a:p>
             <a:r>
-              <a:t>Trust, but verify.</a:t>
-            </a:r>
-          </a:p>
-        </p:txBody>
-      </p:sp>
-      <p:sp>
-        <p:nvSpPr>
-          <p:cNvPr id="4" name="Text Placeholder 3"/>
-          <p:cNvSpPr>
-            <a:spLocks noGrp="1"/>
-          </p:cNvSpPr>
-          <p:nvPr>
-            <p:ph type="body" idx="10"/>
-          </p:nvPr>
-        </p:nvSpPr>
-        <p:spPr/>
-        <p:txBody>
-          <a:bodyPr/>
-          <a:lstStyle/>
-          <a:p>
-            <a:pPr>
-              <a:spcBef>
-                <a:spcPts val="800"/>
-              </a:spcBef>
-              <a:spcAft>
-                <a:spcPts val="800"/>
-              </a:spcAft>
-            </a:pPr>
-            <a:r>
-              <a:rPr b="1">
-                <a:solidFill>
-                  <a:srgbClr val="0F6BFF"/>
-                </a:solidFill>
-              </a:rPr>
-              <a:t>▪  </a:t>
-            </a:r>
-            <a:r>
-              <a:rPr>
-                <a:solidFill>
-                  <a:srgbClr val="000000"/>
-                </a:solidFill>
-              </a:rPr>
-              <a:t>Identity is location-independent. A component carries its name regardless of which registry it lives in.</a:t>
-            </a:r>
-          </a:p>
-          <a:p>
-            <a:pPr>
-              <a:spcBef>
-                <a:spcPts val="800"/>
-              </a:spcBef>
-              <a:spcAft>
-                <a:spcPts val="800"/>
-              </a:spcAft>
-            </a:pPr>
-            <a:r>
-              <a:rPr b="1">
-                <a:solidFill>
-                  <a:srgbClr val="0F6BFF"/>
-                </a:solidFill>
-              </a:rPr>
-              <a:t>▪  </a:t>
-            </a:r>
-            <a:r>
-              <a:rPr>
-                <a:solidFill>
-                  <a:srgbClr val="000000"/>
-                </a:solidFill>
-              </a:rPr>
-              <a:t>Signatures are location-independent. Sign once at source; verify at the destination, or at any hop in between, with no callback upstream.</a:t>
-            </a:r>
-          </a:p>
-          <a:p>
-            <a:pPr>
-              <a:spcBef>
-                <a:spcPts val="800"/>
-              </a:spcBef>
-              <a:spcAft>
-                <a:spcPts val="800"/>
-              </a:spcAft>
-            </a:pPr>
-            <a:r>
-              <a:rPr b="1">
-                <a:solidFill>
-                  <a:srgbClr val="0F6BFF"/>
-                </a:solidFill>
-              </a:rPr>
-              <a:t>▪  </a:t>
-            </a:r>
-            <a:r>
-              <a:rPr>
-                <a:solidFill>
-                  <a:srgbClr val="000000"/>
-                </a:solidFill>
-              </a:rPr>
-              <a:t>Day-2 ops happen inside the boundary. Subscribe to the component and pull upgrades on your schedule, scale across regions, all without reaching back upstream.</a:t>
-            </a:r>
-          </a:p>
-          <a:p>
-            <a:pPr>
-              <a:spcBef>
-                <a:spcPts val="800"/>
-              </a:spcBef>
-              <a:spcAft>
-                <a:spcPts val="800"/>
-              </a:spcAft>
-            </a:pPr>
-            <a:r>
-              <a:rPr b="1">
-                <a:solidFill>
-                  <a:srgbClr val="0F6BFF"/>
-                </a:solidFill>
-              </a:rPr>
-              <a:t>▪  </a:t>
-            </a:r>
-            <a:r>
-              <a:rPr>
-                <a:solidFill>
-                  <a:srgbClr val="000000"/>
-                </a:solidFill>
-              </a:rPr>
-              <a:t>On transfer into a sovereign environment, a component can carry every artifact it needs along with it. The destination needs nothing more.</a:t>
-            </a:r>
-          </a:p>
-        </p:txBody>
-      </p:sp>
+              <a:t>Pack · Sign · Transport · Deploy</a:t>
+            </a:r>
+          </a:p>
+        </p:txBody>
+      </p:sp>
+      <p:pic>
+        <p:nvPicPr>
+          <p:cNvPr id="4" name="Picture 3" descr="05-pack-sign-transport-deploy-v2_1760.png"/>
+          <p:cNvPicPr>
+            <a:picLocks noChangeAspect="1"/>
+          </p:cNvPicPr>
+          <p:nvPr/>
+        </p:nvPicPr>
+        <p:blipFill>
+          <a:blip r:embed="rId2"/>
+          <a:stretch>
+            <a:fillRect/>
+          </a:stretch>
+        </p:blipFill>
+        <p:spPr>
+          <a:xfrm>
+            <a:off x="762000" y="4381500"/>
+            <a:ext cx="16764000" cy="4714875"/>
+          </a:xfrm>
+          <a:prstGeom prst="rect">
+            <a:avLst/>
+          </a:prstGeom>
+        </p:spPr>
+      </p:pic>
     </p:spTree>
   </p:cSld>
   <p:clrMapOvr>
@@ -5264,7 +5772,7 @@
           <a:lstStyle/>
           <a:p>
             <a:r>
-              <a:t>SOVEREIGN-READY — AIR-GAP</a:t>
+              <a:t>SOVEREIGN-READY</a:t>
             </a:r>
           </a:p>
         </p:txBody>
@@ -5285,35 +5793,131 @@
           <a:lstStyle/>
           <a:p>
             <a:r>
-              <a:t>Trust travels with the component.</a:t>
-            </a:r>
-          </a:p>
-        </p:txBody>
-      </p:sp>
-      <p:pic>
-        <p:nvPicPr>
-          <p:cNvPr id="4" name="Picture 3" descr="06-sovereign-airgap_1680.png"/>
-          <p:cNvPicPr>
-            <a:picLocks noChangeAspect="1"/>
-          </p:cNvPicPr>
-          <p:nvPr/>
-        </p:nvPicPr>
-        <p:blipFill>
-          <a:blip r:embed="rId2"/>
-          <a:stretch>
-            <a:fillRect/>
-          </a:stretch>
-        </p:blipFill>
-        <p:spPr>
-          <a:xfrm>
-            <a:off x="3483429" y="4953000"/>
-            <a:ext cx="11321142" cy="4953000"/>
-          </a:xfrm>
-          <a:prstGeom prst="rect">
-            <a:avLst/>
-          </a:prstGeom>
-        </p:spPr>
-      </p:pic>
+              <a:t>Trust, but verify.</a:t>
+            </a:r>
+          </a:p>
+        </p:txBody>
+      </p:sp>
+      <p:sp>
+        <p:nvSpPr>
+          <p:cNvPr id="4" name="Text Placeholder 3"/>
+          <p:cNvSpPr>
+            <a:spLocks noGrp="1"/>
+          </p:cNvSpPr>
+          <p:nvPr>
+            <p:ph type="body" idx="10"/>
+          </p:nvPr>
+        </p:nvSpPr>
+        <p:spPr/>
+        <p:txBody>
+          <a:bodyPr/>
+          <a:lstStyle/>
+          <a:p>
+            <a:pPr>
+              <a:spcBef>
+                <a:spcPts val="800"/>
+              </a:spcBef>
+              <a:spcAft>
+                <a:spcPts val="800"/>
+              </a:spcAft>
+            </a:pPr>
+            <a:r>
+              <a:rPr b="1">
+                <a:solidFill>
+                  <a:srgbClr val="0F6BFF"/>
+                </a:solidFill>
+              </a:rPr>
+              <a:t>▪  </a:t>
+            </a:r>
+            <a:r>
+              <a:rPr>
+                <a:solidFill>
+                  <a:srgbClr val="000000"/>
+                </a:solidFill>
+              </a:rPr>
+              <a:t>Identity is location-independent. A component carries its name regardless of which registry it lives in.</a:t>
+            </a:r>
+          </a:p>
+          <a:p>
+            <a:pPr>
+              <a:spcBef>
+                <a:spcPts val="800"/>
+              </a:spcBef>
+              <a:spcAft>
+                <a:spcPts val="800"/>
+              </a:spcAft>
+            </a:pPr>
+            <a:r>
+              <a:rPr b="1">
+                <a:solidFill>
+                  <a:srgbClr val="0F6BFF"/>
+                </a:solidFill>
+              </a:rPr>
+              <a:t>▪  </a:t>
+            </a:r>
+            <a:r>
+              <a:rPr>
+                <a:solidFill>
+                  <a:srgbClr val="000000"/>
+                </a:solidFill>
+              </a:rPr>
+              <a:t>Signatures are location-independent. Sign once at source; verify at the destination, or at any hop in between, with no callback upstream.</a:t>
+            </a:r>
+          </a:p>
+          <a:p>
+            <a:pPr>
+              <a:spcBef>
+                <a:spcPts val="800"/>
+              </a:spcBef>
+              <a:spcAft>
+                <a:spcPts val="800"/>
+              </a:spcAft>
+            </a:pPr>
+            <a:r>
+              <a:rPr b="1">
+                <a:solidFill>
+                  <a:srgbClr val="0F6BFF"/>
+                </a:solidFill>
+              </a:rPr>
+              <a:t>▪  </a:t>
+            </a:r>
+            <a:r>
+              <a:rPr>
+                <a:solidFill>
+                  <a:srgbClr val="000000"/>
+                </a:solidFill>
+              </a:rPr>
+              <a:t>Day-2 ops happen inside the boundary. Subscribe to the component and pull upgrades on your schedule, scale across regions, all without reaching back upstream.</a:t>
+            </a:r>
+          </a:p>
+          <a:p>
+            <a:pPr>
+              <a:spcBef>
+                <a:spcPts val="800"/>
+              </a:spcBef>
+              <a:spcAft>
+                <a:spcPts val="800"/>
+              </a:spcAft>
+            </a:pPr>
+            <a:r>
+              <a:rPr b="1">
+                <a:solidFill>
+                  <a:srgbClr val="0F6BFF"/>
+                </a:solidFill>
+              </a:rPr>
+              <a:t>▪  </a:t>
+            </a:r>
+            <a:r>
+              <a:rPr>
+                <a:solidFill>
+                  <a:srgbClr val="000000"/>
+                </a:solidFill>
+              </a:rPr>
+              <a:t>On transfer into a sovereign environment, a component can carry every artifact it needs along with it. The destination needs nothing more.</a:t>
+            </a:r>
+          </a:p>
+        </p:txBody>
+      </p:sp>
     </p:spTree>
   </p:cSld>
   <p:clrMapOvr>
@@ -5348,7 +5952,7 @@
           <a:lstStyle/>
           <a:p>
             <a:r>
-              <a:t>SCAN — COMPLIANCE-NATIVE WITH OPEN DELIVERY GEAR</a:t>
+              <a:t>SOVEREIGN-READY — AIR-GAP</a:t>
             </a:r>
           </a:p>
         </p:txBody>
@@ -5369,162 +5973,35 @@
           <a:lstStyle/>
           <a:p>
             <a:r>
-              <a:t>Compliance as a system property —</a:t>
-            </a:r>
-          </a:p>
-          <a:p>
-            <a:r>
-              <a:t>not a quarterly project.</a:t>
-            </a:r>
-          </a:p>
-        </p:txBody>
-      </p:sp>
-      <p:sp>
-        <p:nvSpPr>
-          <p:cNvPr id="4" name="Text Placeholder 3"/>
-          <p:cNvSpPr>
-            <a:spLocks noGrp="1"/>
-          </p:cNvSpPr>
-          <p:nvPr>
-            <p:ph type="body" idx="10"/>
-          </p:nvPr>
-        </p:nvSpPr>
-        <p:spPr/>
-        <p:txBody>
-          <a:bodyPr/>
-          <a:lstStyle/>
-          <a:p>
-            <a:pPr>
-              <a:spcBef>
-                <a:spcPts val="800"/>
-              </a:spcBef>
-              <a:spcAft>
-                <a:spcPts val="800"/>
-              </a:spcAft>
-            </a:pPr>
-            <a:r>
-              <a:rPr b="1">
-                <a:solidFill>
-                  <a:srgbClr val="0F6BFF"/>
-                </a:solidFill>
-              </a:rPr>
-              <a:t>▪  </a:t>
-            </a:r>
-            <a:r>
-              <a:rPr>
-                <a:solidFill>
-                  <a:srgbClr val="000000"/>
-                </a:solidFill>
-              </a:rPr>
-              <a:t>Open Delivery Gear (ODG) is OCM's compliance automation engine.</a:t>
-            </a:r>
-          </a:p>
-          <a:p>
-            <a:pPr>
-              <a:spcBef>
-                <a:spcPts val="800"/>
-              </a:spcBef>
-              <a:spcAft>
-                <a:spcPts val="800"/>
-              </a:spcAft>
-            </a:pPr>
-            <a:r>
-              <a:rPr b="1">
-                <a:solidFill>
-                  <a:srgbClr val="0F6BFF"/>
-                </a:solidFill>
-              </a:rPr>
-              <a:t>▪  </a:t>
-            </a:r>
-            <a:r>
-              <a:rPr>
-                <a:solidFill>
-                  <a:srgbClr val="000000"/>
-                </a:solidFill>
-              </a:rPr>
-              <a:t>The Compliance Dashboard is your entry point: every component, every finding, every signature in one view.</a:t>
-            </a:r>
-          </a:p>
-          <a:p>
-            <a:pPr>
-              <a:spcBef>
-                <a:spcPts val="800"/>
-              </a:spcBef>
-              <a:spcAft>
-                <a:spcPts val="800"/>
-              </a:spcAft>
-            </a:pPr>
-            <a:r>
-              <a:rPr b="1">
-                <a:solidFill>
-                  <a:srgbClr val="0F6BFF"/>
-                </a:solidFill>
-              </a:rPr>
-              <a:t>▪  </a:t>
-            </a:r>
-            <a:r>
-              <a:rPr>
-                <a:solidFill>
-                  <a:srgbClr val="000000"/>
-                </a:solidFill>
-              </a:rPr>
-              <a:t>Continuous scans run asynchronously — even after release.</a:t>
-            </a:r>
-          </a:p>
-          <a:p>
-            <a:pPr>
-              <a:spcBef>
-                <a:spcPts val="800"/>
-              </a:spcBef>
-              <a:spcAft>
-                <a:spcPts val="800"/>
-              </a:spcAft>
-            </a:pPr>
-            <a:r>
-              <a:rPr b="1">
-                <a:solidFill>
-                  <a:srgbClr val="0F6BFF"/>
-                </a:solidFill>
-              </a:rPr>
-              <a:t>▪  </a:t>
-            </a:r>
-            <a:r>
-              <a:rPr>
-                <a:solidFill>
-                  <a:srgbClr val="000000"/>
-                </a:solidFill>
-              </a:rPr>
-              <a:t>Findings get rescored against contextual risk, so your team patches what actually matters.</a:t>
-            </a:r>
-          </a:p>
-          <a:p>
-            <a:pPr>
-              <a:spcBef>
-                <a:spcPts val="800"/>
-              </a:spcBef>
-              <a:spcAft>
-                <a:spcPts val="800"/>
-              </a:spcAft>
-            </a:pPr>
-            <a:r>
-              <a:rPr b="1">
-                <a:solidFill>
-                  <a:srgbClr val="0F6BFF"/>
-                </a:solidFill>
-              </a:rPr>
-              <a:t>▪  </a:t>
-            </a:r>
-            <a:r>
-              <a:rPr>
-                <a:solidFill>
-                  <a:srgbClr val="000000"/>
-                </a:solidFill>
-              </a:rPr>
-              <a:t>Every compliance signal correlates by component identity. Auditors get evidence, not spreadsheets.</a:t>
-            </a:r>
-          </a:p>
-        </p:txBody>
-      </p:sp>
+              <a:t>Trust travels with the component.</a:t>
+            </a:r>
+          </a:p>
+        </p:txBody>
+      </p:sp>
+      <p:pic>
+        <p:nvPicPr>
+          <p:cNvPr id="4" name="Picture 3" descr="06-sovereign-airgap_1760.png"/>
+          <p:cNvPicPr>
+            <a:picLocks noChangeAspect="1"/>
+          </p:cNvPicPr>
+          <p:nvPr/>
+        </p:nvPicPr>
+        <p:blipFill>
+          <a:blip r:embed="rId2"/>
+          <a:stretch>
+            <a:fillRect/>
+          </a:stretch>
+        </p:blipFill>
+        <p:spPr>
+          <a:xfrm>
+            <a:off x="3048000" y="4381500"/>
+            <a:ext cx="12192000" cy="5334000"/>
+          </a:xfrm>
+          <a:prstGeom prst="rect">
+            <a:avLst/>
+          </a:prstGeom>
+        </p:spPr>
+      </p:pic>
     </p:spTree>
   </p:cSld>
   <p:clrMapOvr>

</xml_diff>

<commit_message>
update slides and icons
</commit_message>
<xml_diff>
--- a/docs/community/marketing/decks/exec-phase1/OCM-Sovereign-Delivery-Exec.pptx
+++ b/docs/community/marketing/decks/exec-phase1/OCM-Sovereign-Delivery-Exec.pptx
@@ -19,6 +19,7 @@
     <p:sldId id="267" r:id="rId18"/>
     <p:sldId id="268" r:id="rId19"/>
     <p:sldId id="269" r:id="rId20"/>
+    <p:sldId id="270" r:id="rId21"/>
   </p:sldIdLst>
   <p:sldSz cx="18288000" cy="10287000"/>
   <p:notesSz cx="6858000" cy="9144000"/>
@@ -200,7 +201,7 @@
         </ns0:nvSpPr>
         <ns0:spPr>
           <ns2:xfrm xmlns:ns2="http://schemas.openxmlformats.org/drawingml/2006/main">
-            <ns2:off x="914400" y="3524250"/>
+            <ns2:off x="914400" y="3286125"/>
             <ns2:ext cx="16192500" cy="1524000"/>
           </ns2:xfrm>
           <ns3:prstGeom xmlns:ns3="http://schemas.openxmlformats.org/drawingml/2006/main" prst="rect">
@@ -3754,41 +3755,6 @@
           </a:p>
         </p:txBody>
       </p:sp>
-      <p:sp>
-        <p:nvSpPr>
-          <p:cNvPr id="5" name="TextBox 4"/>
-          <p:cNvSpPr txBox="1"/>
-          <p:nvPr/>
-        </p:nvSpPr>
-        <p:spPr>
-          <a:xfrm>
-            <a:off x="1143000" y="9715500"/>
-            <a:ext cx="16002000" cy="381000"/>
-          </a:xfrm>
-          <a:prstGeom prst="rect">
-            <a:avLst/>
-          </a:prstGeom>
-          <a:noFill/>
-        </p:spPr>
-        <p:txBody>
-          <a:bodyPr wrap="none" lIns="0" rIns="0" tIns="0" bIns="0">
-            <a:spAutoFit/>
-          </a:bodyPr>
-          <a:lstStyle/>
-          <a:p>
-            <a:pPr algn="ctr"/>
-            <a:r>
-              <a:rPr sz="1300">
-                <a:solidFill>
-                  <a:srgbClr val="6B7280"/>
-                </a:solidFill>
-                <a:latin typeface="Aptos"/>
-              </a:rPr>
-              <a:t>github.com/open-component-model/open-delivery-gear</a:t>
-            </a:r>
-          </a:p>
-        </p:txBody>
-      </p:sp>
     </p:spTree>
   </p:cSld>
   <p:clrMapOvr>
@@ -4127,7 +4093,7 @@
       </p:pic>
       <p:pic>
         <p:nvPicPr>
-          <p:cNvPr id="17" name="Picture 16" descr="cloud-upload_72.png"/>
+          <p:cNvPr id="17" name="Picture 16" descr="package-export_72.png"/>
           <p:cNvPicPr>
             <a:picLocks noChangeAspect="1"/>
           </p:cNvPicPr>
@@ -4334,14 +4300,14 @@
                 </a:solidFill>
                 <a:latin typeface="Aptos"/>
               </a:rPr>
-              <a:t>ADOPTED BY ENTERPRISES SHIPPING INTO REGULATED ENVIRONMENTS</a:t>
+              <a:t>ADOPTED BY ENTERPRISES SHIPPING INTO REGULATED ENVIRONMENTS AND THE OPEN-SOURCE ECOSYSTEM</a:t>
             </a:r>
           </a:p>
         </p:txBody>
       </p:sp>
       <p:pic>
         <p:nvPicPr>
-          <p:cNvPr id="5" name="Picture 4" descr="sap-horizontal-color_640_crop.png">
+          <p:cNvPr id="5" name="Picture 4" descr="neonephos-foundation-horizontal-color_520_crop.png">
             <a:hlinkClick r:id="rId3"/>
           </p:cNvPr>
           <p:cNvPicPr>
@@ -4357,17 +4323,53 @@
         </p:blipFill>
         <p:spPr>
           <a:xfrm>
-            <a:off x="3293201" y="5715000"/>
-            <a:ext cx="1538422" cy="762000"/>
+            <a:off x="2190750" y="5858888"/>
+            <a:ext cx="2476500" cy="474223"/>
           </a:xfrm>
           <a:prstGeom prst="rect">
             <a:avLst/>
           </a:prstGeom>
         </p:spPr>
       </p:pic>
+      <p:sp>
+        <p:nvSpPr>
+          <p:cNvPr id="6" name="TextBox 5"/>
+          <p:cNvSpPr txBox="1"/>
+          <p:nvPr/>
+        </p:nvSpPr>
+        <p:spPr>
+          <a:xfrm>
+            <a:off x="1524000" y="6724650"/>
+            <a:ext cx="3810000" cy="266700"/>
+          </a:xfrm>
+          <a:prstGeom prst="rect">
+            <a:avLst/>
+          </a:prstGeom>
+          <a:noFill/>
+        </p:spPr>
+        <p:txBody>
+          <a:bodyPr wrap="none" lIns="0" rIns="0" tIns="0" bIns="0">
+            <a:spAutoFit/>
+          </a:bodyPr>
+          <a:lstStyle/>
+          <a:p>
+            <a:pPr algn="ctr"/>
+            <a:r>
+              <a:rPr sz="2000">
+                <a:solidFill>
+                  <a:srgbClr val="6B7280"/>
+                </a:solidFill>
+                <a:latin typeface="Aptos"/>
+                <a:hlinkClick r:id="rId3"/>
+              </a:rPr>
+              <a:t>NeoNephos</a:t>
+            </a:r>
+          </a:p>
+        </p:txBody>
+      </p:sp>
       <p:pic>
         <p:nvPicPr>
-          <p:cNvPr id="6" name="Picture 5" descr="bwi-horizontal-color_640_crop.png">
+          <p:cNvPr id="7" name="Picture 6" descr="sap-horizontal-color_520_crop.png">
             <a:hlinkClick r:id="rId5"/>
           </p:cNvPr>
           <p:cNvPicPr>
@@ -4383,17 +4385,53 @@
         </p:blipFill>
         <p:spPr>
           <a:xfrm>
-            <a:off x="8317603" y="5715000"/>
-            <a:ext cx="1643269" cy="762000"/>
+            <a:off x="6547884" y="5753100"/>
+            <a:ext cx="1382232" cy="685800"/>
           </a:xfrm>
           <a:prstGeom prst="rect">
             <a:avLst/>
           </a:prstGeom>
         </p:spPr>
       </p:pic>
+      <p:sp>
+        <p:nvSpPr>
+          <p:cNvPr id="8" name="TextBox 7"/>
+          <p:cNvSpPr txBox="1"/>
+          <p:nvPr/>
+        </p:nvSpPr>
+        <p:spPr>
+          <a:xfrm>
+            <a:off x="5334000" y="6724650"/>
+            <a:ext cx="3810000" cy="266700"/>
+          </a:xfrm>
+          <a:prstGeom prst="rect">
+            <a:avLst/>
+          </a:prstGeom>
+          <a:noFill/>
+        </p:spPr>
+        <p:txBody>
+          <a:bodyPr wrap="none" lIns="0" rIns="0" tIns="0" bIns="0">
+            <a:spAutoFit/>
+          </a:bodyPr>
+          <a:lstStyle/>
+          <a:p>
+            <a:pPr algn="ctr"/>
+            <a:r>
+              <a:rPr sz="2000">
+                <a:solidFill>
+                  <a:srgbClr val="6B7280"/>
+                </a:solidFill>
+                <a:latin typeface="Aptos"/>
+                <a:hlinkClick r:id="rId5"/>
+              </a:rPr>
+              <a:t>SAP</a:t>
+            </a:r>
+          </a:p>
+        </p:txBody>
+      </p:sp>
       <p:pic>
         <p:nvPicPr>
-          <p:cNvPr id="7" name="Picture 6" descr="sap-ns2-getlogovector_crop.png">
+          <p:cNvPr id="9" name="Picture 8" descr="bwi-horizontal-color_520_crop.png">
             <a:hlinkClick r:id="rId7"/>
           </p:cNvPr>
           <p:cNvPicPr>
@@ -4409,8 +4447,8 @@
         </p:blipFill>
         <p:spPr>
           <a:xfrm>
-            <a:off x="12936673" y="5715000"/>
-            <a:ext cx="2558778" cy="762000"/>
+            <a:off x="10308189" y="5753100"/>
+            <a:ext cx="1481621" cy="685800"/>
           </a:xfrm>
           <a:prstGeom prst="rect">
             <a:avLst/>
@@ -4419,14 +4457,14 @@
       </p:pic>
       <p:sp>
         <p:nvSpPr>
-          <p:cNvPr id="8" name="TextBox 7"/>
+          <p:cNvPr id="10" name="TextBox 9"/>
           <p:cNvSpPr txBox="1"/>
           <p:nvPr/>
         </p:nvSpPr>
         <p:spPr>
           <a:xfrm>
-            <a:off x="1143000" y="7048500"/>
-            <a:ext cx="16002000" cy="342900"/>
+            <a:off x="9144000" y="6724650"/>
+            <a:ext cx="3810000" cy="266700"/>
           </a:xfrm>
           <a:prstGeom prst="rect">
             <a:avLst/>
@@ -4439,21 +4477,23 @@
           </a:bodyPr>
           <a:lstStyle/>
           <a:p>
-            <a:r>
-              <a:rPr sz="1800" b="1" cap="all" spc="110">
+            <a:pPr algn="ctr"/>
+            <a:r>
+              <a:rPr sz="2000">
                 <a:solidFill>
-                  <a:srgbClr val="0F6BFF"/>
+                  <a:srgbClr val="6B7280"/>
                 </a:solidFill>
                 <a:latin typeface="Aptos"/>
+                <a:hlinkClick r:id="rId7"/>
               </a:rPr>
-              <a:t>BUILT INTO THE OPEN-SOURCE ECOSYSTEM</a:t>
+              <a:t>BWI</a:t>
             </a:r>
           </a:p>
         </p:txBody>
       </p:sp>
       <p:pic>
         <p:nvPicPr>
-          <p:cNvPr id="9" name="Picture 8" descr="gardener-horizontal-color_640_crop.png">
+          <p:cNvPr id="11" name="Picture 10" descr="sap-ns2-getlogovector_crop.png">
             <a:hlinkClick r:id="rId9"/>
           </p:cNvPr>
           <p:cNvPicPr>
@@ -4469,17 +4509,53 @@
         </p:blipFill>
         <p:spPr>
           <a:xfrm>
-            <a:off x="1905000" y="7955322"/>
-            <a:ext cx="3048000" cy="662855"/>
+            <a:off x="13707550" y="5753100"/>
+            <a:ext cx="2302900" cy="685800"/>
           </a:xfrm>
           <a:prstGeom prst="rect">
             <a:avLst/>
           </a:prstGeom>
         </p:spPr>
       </p:pic>
+      <p:sp>
+        <p:nvSpPr>
+          <p:cNvPr id="12" name="TextBox 11"/>
+          <p:cNvSpPr txBox="1"/>
+          <p:nvPr/>
+        </p:nvSpPr>
+        <p:spPr>
+          <a:xfrm>
+            <a:off x="12954000" y="6724650"/>
+            <a:ext cx="3810000" cy="266700"/>
+          </a:xfrm>
+          <a:prstGeom prst="rect">
+            <a:avLst/>
+          </a:prstGeom>
+          <a:noFill/>
+        </p:spPr>
+        <p:txBody>
+          <a:bodyPr wrap="none" lIns="0" rIns="0" tIns="0" bIns="0">
+            <a:spAutoFit/>
+          </a:bodyPr>
+          <a:lstStyle/>
+          <a:p>
+            <a:pPr algn="ctr"/>
+            <a:r>
+              <a:rPr sz="2000">
+                <a:solidFill>
+                  <a:srgbClr val="6B7280"/>
+                </a:solidFill>
+                <a:latin typeface="Aptos"/>
+                <a:hlinkClick r:id="rId9"/>
+              </a:rPr>
+              <a:t>SAP NS2</a:t>
+            </a:r>
+          </a:p>
+        </p:txBody>
+      </p:sp>
       <p:pic>
         <p:nvPicPr>
-          <p:cNvPr id="10" name="Picture 9" descr="konfidence-horizontal-light_640_crop.png">
+          <p:cNvPr id="13" name="Picture 12" descr="gardener-horizontal-color_520_crop.png">
             <a:hlinkClick r:id="rId11"/>
           </p:cNvPr>
           <p:cNvPicPr>
@@ -4495,17 +4571,53 @@
         </p:blipFill>
         <p:spPr>
           <a:xfrm>
-            <a:off x="5715000" y="8134848"/>
-            <a:ext cx="3048000" cy="303803"/>
+            <a:off x="2190750" y="8208680"/>
+            <a:ext cx="2476500" cy="537140"/>
           </a:xfrm>
           <a:prstGeom prst="rect">
             <a:avLst/>
           </a:prstGeom>
         </p:spPr>
       </p:pic>
+      <p:sp>
+        <p:nvSpPr>
+          <p:cNvPr id="14" name="TextBox 13"/>
+          <p:cNvSpPr txBox="1"/>
+          <p:nvPr/>
+        </p:nvSpPr>
+        <p:spPr>
+          <a:xfrm>
+            <a:off x="1524000" y="9105900"/>
+            <a:ext cx="3810000" cy="266700"/>
+          </a:xfrm>
+          <a:prstGeom prst="rect">
+            <a:avLst/>
+          </a:prstGeom>
+          <a:noFill/>
+        </p:spPr>
+        <p:txBody>
+          <a:bodyPr wrap="none" lIns="0" rIns="0" tIns="0" bIns="0">
+            <a:spAutoFit/>
+          </a:bodyPr>
+          <a:lstStyle/>
+          <a:p>
+            <a:pPr algn="ctr"/>
+            <a:r>
+              <a:rPr sz="2000">
+                <a:solidFill>
+                  <a:srgbClr val="6B7280"/>
+                </a:solidFill>
+                <a:latin typeface="Aptos"/>
+                <a:hlinkClick r:id="rId11"/>
+              </a:rPr>
+              <a:t>Gardener</a:t>
+            </a:r>
+          </a:p>
+        </p:txBody>
+      </p:sp>
       <p:pic>
         <p:nvPicPr>
-          <p:cNvPr id="11" name="Picture 10" descr="opencontrolplane-icon-color_640_crop.png">
+          <p:cNvPr id="15" name="Picture 14" descr="konfidence-horizontal-light_520_crop.png">
             <a:hlinkClick r:id="rId13"/>
           </p:cNvPr>
           <p:cNvPicPr>
@@ -4521,17 +4633,53 @@
         </p:blipFill>
         <p:spPr>
           <a:xfrm>
-            <a:off x="10728940" y="7905750"/>
-            <a:ext cx="640120" cy="762000"/>
+            <a:off x="6000750" y="8352426"/>
+            <a:ext cx="2476500" cy="249647"/>
           </a:xfrm>
           <a:prstGeom prst="rect">
             <a:avLst/>
           </a:prstGeom>
         </p:spPr>
       </p:pic>
+      <p:sp>
+        <p:nvSpPr>
+          <p:cNvPr id="16" name="TextBox 15"/>
+          <p:cNvSpPr txBox="1"/>
+          <p:nvPr/>
+        </p:nvSpPr>
+        <p:spPr>
+          <a:xfrm>
+            <a:off x="5334000" y="9105900"/>
+            <a:ext cx="3810000" cy="266700"/>
+          </a:xfrm>
+          <a:prstGeom prst="rect">
+            <a:avLst/>
+          </a:prstGeom>
+          <a:noFill/>
+        </p:spPr>
+        <p:txBody>
+          <a:bodyPr wrap="none" lIns="0" rIns="0" tIns="0" bIns="0">
+            <a:spAutoFit/>
+          </a:bodyPr>
+          <a:lstStyle/>
+          <a:p>
+            <a:pPr algn="ctr"/>
+            <a:r>
+              <a:rPr sz="2000">
+                <a:solidFill>
+                  <a:srgbClr val="6B7280"/>
+                </a:solidFill>
+                <a:latin typeface="Aptos"/>
+                <a:hlinkClick r:id="rId13"/>
+              </a:rPr>
+              <a:t>Konfidence</a:t>
+            </a:r>
+          </a:p>
+        </p:txBody>
+      </p:sp>
       <p:pic>
         <p:nvPicPr>
-          <p:cNvPr id="12" name="Picture 11" descr="platform-mesh-horizontal-color_640_crop.png">
+          <p:cNvPr id="17" name="Picture 16" descr="opencontrolplane-icon-color_520_crop.png">
             <a:hlinkClick r:id="rId15"/>
           </p:cNvPr>
           <p:cNvPicPr>
@@ -4547,8 +4695,8 @@
         </p:blipFill>
         <p:spPr>
           <a:xfrm>
-            <a:off x="13335000" y="7922419"/>
-            <a:ext cx="3048000" cy="728662"/>
+            <a:off x="10761077" y="8134350"/>
+            <a:ext cx="575845" cy="685800"/>
           </a:xfrm>
           <a:prstGeom prst="rect">
             <a:avLst/>
@@ -4557,14 +4705,14 @@
       </p:pic>
       <p:sp>
         <p:nvSpPr>
-          <p:cNvPr id="13" name="TextBox 12"/>
+          <p:cNvPr id="18" name="TextBox 17"/>
           <p:cNvSpPr txBox="1"/>
           <p:nvPr/>
         </p:nvSpPr>
         <p:spPr>
           <a:xfrm>
-            <a:off x="1143000" y="9239250"/>
-            <a:ext cx="16002000" cy="762000"/>
+            <a:off x="9144000" y="9105900"/>
+            <a:ext cx="3810000" cy="266700"/>
           </a:xfrm>
           <a:prstGeom prst="rect">
             <a:avLst/>
@@ -4577,33 +4725,56 @@
           </a:bodyPr>
           <a:lstStyle/>
           <a:p>
-            <a:pPr algn="ctr">
-              <a:lnSpc>
-                <a:spcPct val="140000"/>
-              </a:lnSpc>
-            </a:pPr>
-            <a:r>
-              <a:rPr sz="1800">
+            <a:pPr algn="ctr"/>
+            <a:r>
+              <a:rPr sz="2000">
                 <a:solidFill>
-                  <a:srgbClr val="0A3A99"/>
+                  <a:srgbClr val="6B7280"/>
                 </a:solidFill>
                 <a:latin typeface="Aptos"/>
+                <a:hlinkClick r:id="rId15"/>
               </a:rPr>
-              <a:t>An open standard, neutrally governed — your stack stays portable, your dependencies stay yours.</a:t>
-            </a:r>
-          </a:p>
-        </p:txBody>
-      </p:sp>
-      <p:sp>
-        <p:nvSpPr>
-          <p:cNvPr id="14" name="TextBox 13"/>
+              <a:t>OpenControlPlane</a:t>
+            </a:r>
+          </a:p>
+        </p:txBody>
+      </p:sp>
+      <p:pic>
+        <p:nvPicPr>
+          <p:cNvPr id="19" name="Picture 18" descr="platform-mesh-horizontal-color_520_crop.png">
+            <a:hlinkClick r:id="rId17"/>
+          </p:cNvPr>
+          <p:cNvPicPr>
+            <a:picLocks noChangeAspect="1"/>
+          </p:cNvPicPr>
+          <p:nvPr/>
+        </p:nvPicPr>
+        <p:blipFill>
+          <a:blip r:embed="rId16"/>
+          <a:stretch>
+            <a:fillRect/>
+          </a:stretch>
+        </p:blipFill>
+        <p:spPr>
+          <a:xfrm>
+            <a:off x="13620750" y="8181975"/>
+            <a:ext cx="2476500" cy="590550"/>
+          </a:xfrm>
+          <a:prstGeom prst="rect">
+            <a:avLst/>
+          </a:prstGeom>
+        </p:spPr>
+      </p:pic>
+      <p:sp>
+        <p:nvSpPr>
+          <p:cNvPr id="20" name="TextBox 19"/>
           <p:cNvSpPr txBox="1"/>
           <p:nvPr/>
         </p:nvSpPr>
         <p:spPr>
           <a:xfrm>
-            <a:off x="1143000" y="9906000"/>
-            <a:ext cx="16002000" cy="381000"/>
+            <a:off x="12954000" y="9105900"/>
+            <a:ext cx="3810000" cy="266700"/>
           </a:xfrm>
           <a:prstGeom prst="rect">
             <a:avLst/>
@@ -4618,13 +4789,14 @@
           <a:p>
             <a:pPr algn="ctr"/>
             <a:r>
-              <a:rPr sz="1300">
+              <a:rPr sz="2000">
                 <a:solidFill>
                   <a:srgbClr val="6B7280"/>
                 </a:solidFill>
                 <a:latin typeface="Aptos"/>
+                <a:hlinkClick r:id="rId17"/>
               </a:rPr>
-              <a:t>sap.com · bwi.de · sapns2.com · neonephos.org · gardener.cloud · konfidence.cloud · platform-mesh.io · open-control-plane.io</a:t>
+              <a:t>Platform Mesh</a:t>
             </a:r>
           </a:p>
         </p:txBody>
@@ -4825,7 +4997,7 @@
           <a:lstStyle/>
           <a:p>
             <a:r>
-              <a:t>TRADEMARK &amp; LICENSE NOTICES</a:t>
+              <a:t>TRADEMARK &amp; LICENSE NOTICES (1/2)</a:t>
             </a:r>
           </a:p>
         </p:txBody>
@@ -4995,6 +5167,82 @@
               <a:t>OpenControlPlane — open-source project at open-control-plane.io. Editorial use only; verify with the project before external publication. open-control-plane.io</a:t>
             </a:r>
           </a:p>
+        </p:txBody>
+      </p:sp>
+    </p:spTree>
+  </p:cSld>
+  <p:clrMapOvr>
+    <a:masterClrMapping/>
+  </p:clrMapOvr>
+</p:sld>
+</file>
+
+<file path=ppt/slides/slide15.xml><?xml version="1.0" encoding="utf-8"?>
+<p:sld xmlns:a="http://schemas.openxmlformats.org/drawingml/2006/main" xmlns:p="http://schemas.openxmlformats.org/presentationml/2006/main" xmlns:r="http://schemas.openxmlformats.org/officeDocument/2006/relationships" show="0">
+  <p:cSld>
+    <p:spTree>
+      <p:nvGrpSpPr>
+        <p:cNvPr id="1" name=""/>
+        <p:cNvGrpSpPr/>
+        <p:nvPr/>
+      </p:nvGrpSpPr>
+      <p:grpSpPr/>
+      <p:sp>
+        <p:nvSpPr>
+          <p:cNvPr id="2" name="Text Placeholder 1"/>
+          <p:cNvSpPr>
+            <a:spLocks noGrp="1"/>
+          </p:cNvSpPr>
+          <p:nvPr>
+            <p:ph type="body" idx="1"/>
+          </p:nvPr>
+        </p:nvSpPr>
+        <p:spPr/>
+        <p:txBody>
+          <a:bodyPr/>
+          <a:lstStyle/>
+          <a:p>
+            <a:r>
+              <a:t>TRADEMARK &amp; LICENSE NOTICES (2/2)</a:t>
+            </a:r>
+          </a:p>
+        </p:txBody>
+      </p:sp>
+      <p:sp>
+        <p:nvSpPr>
+          <p:cNvPr id="3" name="Title 2"/>
+          <p:cNvSpPr>
+            <a:spLocks noGrp="1"/>
+          </p:cNvSpPr>
+          <p:nvPr>
+            <p:ph type="title" idx="2"/>
+          </p:nvPr>
+        </p:nvSpPr>
+        <p:spPr/>
+        <p:txBody>
+          <a:bodyPr/>
+          <a:lstStyle/>
+          <a:p>
+            <a:r>
+              <a:t>Third-party trademarks named for technical reference.</a:t>
+            </a:r>
+          </a:p>
+        </p:txBody>
+      </p:sp>
+      <p:sp>
+        <p:nvSpPr>
+          <p:cNvPr id="4" name="Text Placeholder 3"/>
+          <p:cNvSpPr>
+            <a:spLocks noGrp="1"/>
+          </p:cNvSpPr>
+          <p:nvPr>
+            <p:ph type="body" idx="10"/>
+          </p:nvPr>
+        </p:nvSpPr>
+        <p:spPr/>
+        <p:txBody>
+          <a:bodyPr/>
+          <a:lstStyle/>
           <a:p>
             <a:pPr>
               <a:spcBef>

</xml_diff>